<commit_message>
1b R session stuff
</commit_message>
<xml_diff>
--- a/slides/01b_R_intro_data_functions.pptx
+++ b/slides/01b_R_intro_data_functions.pptx
@@ -5,26 +5,29 @@
     <p:sldMasterId id="2147483661" r:id="rId1"/>
   </p:sldMasterIdLst>
   <p:notesMasterIdLst>
-    <p:notesMasterId r:id="rId19"/>
+    <p:notesMasterId r:id="rId22"/>
   </p:notesMasterIdLst>
   <p:sldIdLst>
     <p:sldId id="299" r:id="rId2"/>
     <p:sldId id="272" r:id="rId3"/>
     <p:sldId id="378" r:id="rId4"/>
-    <p:sldId id="375" r:id="rId5"/>
-    <p:sldId id="394" r:id="rId6"/>
-    <p:sldId id="393" r:id="rId7"/>
-    <p:sldId id="392" r:id="rId8"/>
-    <p:sldId id="384" r:id="rId9"/>
-    <p:sldId id="385" r:id="rId10"/>
-    <p:sldId id="387" r:id="rId11"/>
-    <p:sldId id="388" r:id="rId12"/>
+    <p:sldId id="382" r:id="rId5"/>
+    <p:sldId id="375" r:id="rId6"/>
+    <p:sldId id="394" r:id="rId7"/>
+    <p:sldId id="393" r:id="rId8"/>
+    <p:sldId id="392" r:id="rId9"/>
+    <p:sldId id="384" r:id="rId10"/>
+    <p:sldId id="385" r:id="rId11"/>
+    <p:sldId id="387" r:id="rId12"/>
     <p:sldId id="265" r:id="rId13"/>
     <p:sldId id="386" r:id="rId14"/>
     <p:sldId id="389" r:id="rId15"/>
-    <p:sldId id="390" r:id="rId16"/>
-    <p:sldId id="391" r:id="rId17"/>
-    <p:sldId id="380" r:id="rId18"/>
+    <p:sldId id="388" r:id="rId16"/>
+    <p:sldId id="390" r:id="rId17"/>
+    <p:sldId id="391" r:id="rId18"/>
+    <p:sldId id="380" r:id="rId19"/>
+    <p:sldId id="395" r:id="rId20"/>
+    <p:sldId id="381" r:id="rId21"/>
   </p:sldIdLst>
   <p:sldSz cx="12192000" cy="6858000"/>
   <p:notesSz cx="6858000" cy="9144000"/>
@@ -137,53 +140,30 @@
 </p188:authorLst>
 </file>
 
-<file path=ppt/revisionInfo.xml><?xml version="1.0" encoding="utf-8"?>
-<p1510:revInfo xmlns:a="http://schemas.openxmlformats.org/drawingml/2006/main" xmlns:r="http://schemas.openxmlformats.org/officeDocument/2006/relationships" xmlns:p1510="http://schemas.microsoft.com/office/powerpoint/2015/10/main">
-  <p1510:revLst>
-    <p1510:client id="{8F87CF4E-35EC-43E1-8BD5-AC5B8FE9E056}" v="127" dt="2026-08-25T14:53:32.047"/>
-  </p1510:revLst>
-</p1510:revInfo>
-</file>
-
 <file path=ppt/changesInfos/changesInfo1.xml><?xml version="1.0" encoding="utf-8"?>
 <pc:chgInfo xmlns:a="http://schemas.openxmlformats.org/drawingml/2006/main" xmlns:r="http://schemas.openxmlformats.org/officeDocument/2006/relationships" xmlns:ac="http://schemas.microsoft.com/office/drawing/2013/main/command" xmlns:pc="http://schemas.microsoft.com/office/powerpoint/2013/main/command">
   <pc:docChgLst>
     <pc:chgData name="Katie Owers Bonner" userId="031be739-2ca3-49bb-9134-32c5274b029d" providerId="ADAL" clId="{A2AFF3C0-B35D-4D35-896C-645D8DA4EEB0}"/>
     <pc:docChg chg="undo custSel addSld delSld modSld sldOrd modMainMaster">
-      <pc:chgData name="Katie Owers Bonner" userId="031be739-2ca3-49bb-9134-32c5274b029d" providerId="ADAL" clId="{A2AFF3C0-B35D-4D35-896C-645D8DA4EEB0}" dt="2026-08-25T14:53:24.731" v="634" actId="20577"/>
+      <pc:chgData name="Katie Owers Bonner" userId="031be739-2ca3-49bb-9134-32c5274b029d" providerId="ADAL" clId="{A2AFF3C0-B35D-4D35-896C-645D8DA4EEB0}" dt="2026-08-31T13:48:03.169" v="756"/>
       <pc:docMkLst>
         <pc:docMk/>
       </pc:docMkLst>
-      <pc:sldChg chg="add del">
-        <pc:chgData name="Katie Owers Bonner" userId="031be739-2ca3-49bb-9134-32c5274b029d" providerId="ADAL" clId="{A2AFF3C0-B35D-4D35-896C-645D8DA4EEB0}" dt="2026-08-25T14:31:23.543" v="22" actId="47"/>
+      <pc:sldChg chg="ord">
+        <pc:chgData name="Katie Owers Bonner" userId="031be739-2ca3-49bb-9134-32c5274b029d" providerId="ADAL" clId="{A2AFF3C0-B35D-4D35-896C-645D8DA4EEB0}" dt="2026-08-31T13:47:54.374" v="754"/>
         <pc:sldMkLst>
           <pc:docMk/>
-          <pc:sldMk cId="0" sldId="262"/>
-        </pc:sldMkLst>
-      </pc:sldChg>
-      <pc:sldChg chg="add del">
-        <pc:chgData name="Katie Owers Bonner" userId="031be739-2ca3-49bb-9134-32c5274b029d" providerId="ADAL" clId="{A2AFF3C0-B35D-4D35-896C-645D8DA4EEB0}" dt="2026-08-25T14:31:10.581" v="18" actId="47"/>
-        <pc:sldMkLst>
-          <pc:docMk/>
-          <pc:sldMk cId="1346459711" sldId="271"/>
+          <pc:sldMk cId="0" sldId="265"/>
         </pc:sldMkLst>
       </pc:sldChg>
       <pc:sldChg chg="addSp delSp modSp mod">
-        <pc:chgData name="Katie Owers Bonner" userId="031be739-2ca3-49bb-9134-32c5274b029d" providerId="ADAL" clId="{A2AFF3C0-B35D-4D35-896C-645D8DA4EEB0}" dt="2026-08-25T14:46:38.462" v="476" actId="313"/>
+        <pc:chgData name="Katie Owers Bonner" userId="031be739-2ca3-49bb-9134-32c5274b029d" providerId="ADAL" clId="{A2AFF3C0-B35D-4D35-896C-645D8DA4EEB0}" dt="2026-08-31T13:20:09.779" v="710" actId="20577"/>
         <pc:sldMkLst>
           <pc:docMk/>
           <pc:sldMk cId="4126705857" sldId="272"/>
         </pc:sldMkLst>
-        <pc:spChg chg="add del">
-          <ac:chgData name="Katie Owers Bonner" userId="031be739-2ca3-49bb-9134-32c5274b029d" providerId="ADAL" clId="{A2AFF3C0-B35D-4D35-896C-645D8DA4EEB0}" dt="2026-08-25T14:42:06.676" v="259" actId="22"/>
-          <ac:spMkLst>
-            <pc:docMk/>
-            <pc:sldMk cId="4126705857" sldId="272"/>
-            <ac:spMk id="3" creationId="{D06F9670-E5F9-84CC-CC98-CF53532FBA9C}"/>
-          </ac:spMkLst>
-        </pc:spChg>
         <pc:spChg chg="add mod">
-          <ac:chgData name="Katie Owers Bonner" userId="031be739-2ca3-49bb-9134-32c5274b029d" providerId="ADAL" clId="{A2AFF3C0-B35D-4D35-896C-645D8DA4EEB0}" dt="2026-08-25T14:46:16.424" v="473" actId="1076"/>
+          <ac:chgData name="Katie Owers Bonner" userId="031be739-2ca3-49bb-9134-32c5274b029d" providerId="ADAL" clId="{A2AFF3C0-B35D-4D35-896C-645D8DA4EEB0}" dt="2026-08-25T19:58:32.383" v="699" actId="1076"/>
           <ac:spMkLst>
             <pc:docMk/>
             <pc:sldMk cId="4126705857" sldId="272"/>
@@ -191,7 +171,7 @@
           </ac:spMkLst>
         </pc:spChg>
         <pc:spChg chg="add mod">
-          <ac:chgData name="Katie Owers Bonner" userId="031be739-2ca3-49bb-9134-32c5274b029d" providerId="ADAL" clId="{A2AFF3C0-B35D-4D35-896C-645D8DA4EEB0}" dt="2026-08-25T14:46:21.588" v="474" actId="1076"/>
+          <ac:chgData name="Katie Owers Bonner" userId="031be739-2ca3-49bb-9134-32c5274b029d" providerId="ADAL" clId="{A2AFF3C0-B35D-4D35-896C-645D8DA4EEB0}" dt="2026-08-31T13:20:09.779" v="710" actId="20577"/>
           <ac:spMkLst>
             <pc:docMk/>
             <pc:sldMk cId="4126705857" sldId="272"/>
@@ -207,7 +187,7 @@
           </ac:spMkLst>
         </pc:spChg>
         <pc:spChg chg="mod">
-          <ac:chgData name="Katie Owers Bonner" userId="031be739-2ca3-49bb-9134-32c5274b029d" providerId="ADAL" clId="{A2AFF3C0-B35D-4D35-896C-645D8DA4EEB0}" dt="2026-08-25T14:46:38.462" v="476" actId="313"/>
+          <ac:chgData name="Katie Owers Bonner" userId="031be739-2ca3-49bb-9134-32c5274b029d" providerId="ADAL" clId="{A2AFF3C0-B35D-4D35-896C-645D8DA4EEB0}" dt="2026-08-31T13:20:07.936" v="709" actId="20577"/>
           <ac:spMkLst>
             <pc:docMk/>
             <pc:sldMk cId="4126705857" sldId="272"/>
@@ -215,32 +195,26 @@
           </ac:spMkLst>
         </pc:spChg>
       </pc:sldChg>
-      <pc:sldChg chg="add del">
-        <pc:chgData name="Katie Owers Bonner" userId="031be739-2ca3-49bb-9134-32c5274b029d" providerId="ADAL" clId="{A2AFF3C0-B35D-4D35-896C-645D8DA4EEB0}" dt="2026-08-25T14:31:18.401" v="19" actId="47"/>
-        <pc:sldMkLst>
-          <pc:docMk/>
-          <pc:sldMk cId="347713999" sldId="273"/>
-        </pc:sldMkLst>
-      </pc:sldChg>
-      <pc:sldChg chg="add del">
-        <pc:chgData name="Katie Owers Bonner" userId="031be739-2ca3-49bb-9134-32c5274b029d" providerId="ADAL" clId="{A2AFF3C0-B35D-4D35-896C-645D8DA4EEB0}" dt="2026-08-25T14:31:20.165" v="20" actId="47"/>
-        <pc:sldMkLst>
-          <pc:docMk/>
-          <pc:sldMk cId="536404643" sldId="296"/>
-        </pc:sldMkLst>
-      </pc:sldChg>
-      <pc:sldChg chg="delSp modSp mod">
-        <pc:chgData name="Katie Owers Bonner" userId="031be739-2ca3-49bb-9134-32c5274b029d" providerId="ADAL" clId="{A2AFF3C0-B35D-4D35-896C-645D8DA4EEB0}" dt="2026-08-25T14:38:46.786" v="28" actId="1076"/>
+      <pc:sldChg chg="addSp delSp modSp mod modClrScheme chgLayout modNotesTx">
+        <pc:chgData name="Katie Owers Bonner" userId="031be739-2ca3-49bb-9134-32c5274b029d" providerId="ADAL" clId="{A2AFF3C0-B35D-4D35-896C-645D8DA4EEB0}" dt="2026-08-31T13:19:56.978" v="708" actId="20577"/>
         <pc:sldMkLst>
           <pc:docMk/>
           <pc:sldMk cId="0" sldId="299"/>
         </pc:sldMkLst>
-        <pc:spChg chg="del">
-          <ac:chgData name="Katie Owers Bonner" userId="031be739-2ca3-49bb-9134-32c5274b029d" providerId="ADAL" clId="{A2AFF3C0-B35D-4D35-896C-645D8DA4EEB0}" dt="2026-08-25T14:30:25.774" v="1" actId="478"/>
+        <pc:spChg chg="add del mod ord">
+          <ac:chgData name="Katie Owers Bonner" userId="031be739-2ca3-49bb-9134-32c5274b029d" providerId="ADAL" clId="{A2AFF3C0-B35D-4D35-896C-645D8DA4EEB0}" dt="2026-08-31T13:19:51.110" v="706" actId="478"/>
           <ac:spMkLst>
             <pc:docMk/>
             <pc:sldMk cId="0" sldId="299"/>
-            <ac:spMk id="2" creationId="{979EBCB2-BDD6-364D-A3DF-4D6E8B1F0936}"/>
+            <ac:spMk id="2" creationId="{10D864A0-29D1-B24E-39E2-A54EEE7755F3}"/>
+          </ac:spMkLst>
+        </pc:spChg>
+        <pc:spChg chg="add del mod ord">
+          <ac:chgData name="Katie Owers Bonner" userId="031be739-2ca3-49bb-9134-32c5274b029d" providerId="ADAL" clId="{A2AFF3C0-B35D-4D35-896C-645D8DA4EEB0}" dt="2026-08-31T13:19:53.484" v="707" actId="478"/>
+          <ac:spMkLst>
+            <pc:docMk/>
+            <pc:sldMk cId="0" sldId="299"/>
+            <ac:spMk id="3" creationId="{898596A4-BFFF-78E2-254B-0357E1D7BFD4}"/>
           </ac:spMkLst>
         </pc:spChg>
         <pc:spChg chg="mod">
@@ -249,14 +223,6 @@
             <pc:docMk/>
             <pc:sldMk cId="0" sldId="299"/>
             <ac:spMk id="109" creationId="{00000000-0000-0000-0000-000000000000}"/>
-          </ac:spMkLst>
-        </pc:spChg>
-        <pc:spChg chg="del">
-          <ac:chgData name="Katie Owers Bonner" userId="031be739-2ca3-49bb-9134-32c5274b029d" providerId="ADAL" clId="{A2AFF3C0-B35D-4D35-896C-645D8DA4EEB0}" dt="2026-08-25T14:30:24.772" v="0" actId="478"/>
-          <ac:spMkLst>
-            <pc:docMk/>
-            <pc:sldMk cId="0" sldId="299"/>
-            <ac:spMk id="111" creationId="{00000000-0000-0000-0000-000000000000}"/>
           </ac:spMkLst>
         </pc:spChg>
         <pc:spChg chg="mod">
@@ -268,21 +234,14 @@
           </ac:spMkLst>
         </pc:spChg>
       </pc:sldChg>
-      <pc:sldChg chg="add del">
-        <pc:chgData name="Katie Owers Bonner" userId="031be739-2ca3-49bb-9134-32c5274b029d" providerId="ADAL" clId="{A2AFF3C0-B35D-4D35-896C-645D8DA4EEB0}" dt="2026-08-25T14:31:22.198" v="21" actId="47"/>
-        <pc:sldMkLst>
-          <pc:docMk/>
-          <pc:sldMk cId="561263410" sldId="373"/>
-        </pc:sldMkLst>
-      </pc:sldChg>
-      <pc:sldChg chg="modSp add ord modAnim">
-        <pc:chgData name="Katie Owers Bonner" userId="031be739-2ca3-49bb-9134-32c5274b029d" providerId="ADAL" clId="{A2AFF3C0-B35D-4D35-896C-645D8DA4EEB0}" dt="2026-08-25T14:45:25.449" v="429" actId="313"/>
+      <pc:sldChg chg="modSp add mod ord addAnim delAnim modAnim">
+        <pc:chgData name="Katie Owers Bonner" userId="031be739-2ca3-49bb-9134-32c5274b029d" providerId="ADAL" clId="{A2AFF3C0-B35D-4D35-896C-645D8DA4EEB0}" dt="2026-08-25T20:01:18.352" v="703" actId="21"/>
         <pc:sldMkLst>
           <pc:docMk/>
           <pc:sldMk cId="562143459" sldId="375"/>
         </pc:sldMkLst>
         <pc:spChg chg="mod">
-          <ac:chgData name="Katie Owers Bonner" userId="031be739-2ca3-49bb-9134-32c5274b029d" providerId="ADAL" clId="{A2AFF3C0-B35D-4D35-896C-645D8DA4EEB0}" dt="2026-08-25T14:45:25.449" v="429" actId="313"/>
+          <ac:chgData name="Katie Owers Bonner" userId="031be739-2ca3-49bb-9134-32c5274b029d" providerId="ADAL" clId="{A2AFF3C0-B35D-4D35-896C-645D8DA4EEB0}" dt="2026-08-25T20:01:18.352" v="703" actId="21"/>
           <ac:spMkLst>
             <pc:docMk/>
             <pc:sldMk cId="562143459" sldId="375"/>
@@ -314,21 +273,28 @@
         </pc:spChg>
       </pc:sldChg>
       <pc:sldChg chg="add del">
-        <pc:chgData name="Katie Owers Bonner" userId="031be739-2ca3-49bb-9134-32c5274b029d" providerId="ADAL" clId="{A2AFF3C0-B35D-4D35-896C-645D8DA4EEB0}" dt="2026-08-25T14:43:25.345" v="321"/>
-        <pc:sldMkLst>
-          <pc:docMk/>
-          <pc:sldMk cId="4275729855" sldId="378"/>
-        </pc:sldMkLst>
-      </pc:sldChg>
-      <pc:sldChg chg="add del">
         <pc:chgData name="Katie Owers Bonner" userId="031be739-2ca3-49bb-9134-32c5274b029d" providerId="ADAL" clId="{A2AFF3C0-B35D-4D35-896C-645D8DA4EEB0}" dt="2026-08-25T14:31:00.813" v="13" actId="47"/>
         <pc:sldMkLst>
           <pc:docMk/>
           <pc:sldMk cId="2135785689" sldId="380"/>
         </pc:sldMkLst>
       </pc:sldChg>
+      <pc:sldChg chg="add">
+        <pc:chgData name="Katie Owers Bonner" userId="031be739-2ca3-49bb-9134-32c5274b029d" providerId="ADAL" clId="{A2AFF3C0-B35D-4D35-896C-645D8DA4EEB0}" dt="2026-08-25T19:57:03.918" v="698"/>
+        <pc:sldMkLst>
+          <pc:docMk/>
+          <pc:sldMk cId="2110054645" sldId="381"/>
+        </pc:sldMkLst>
+      </pc:sldChg>
+      <pc:sldChg chg="add">
+        <pc:chgData name="Katie Owers Bonner" userId="031be739-2ca3-49bb-9134-32c5274b029d" providerId="ADAL" clId="{A2AFF3C0-B35D-4D35-896C-645D8DA4EEB0}" dt="2026-08-25T20:00:12.452" v="701"/>
+        <pc:sldMkLst>
+          <pc:docMk/>
+          <pc:sldMk cId="1682775875" sldId="382"/>
+        </pc:sldMkLst>
+      </pc:sldChg>
       <pc:sldChg chg="modSp mod">
-        <pc:chgData name="Katie Owers Bonner" userId="031be739-2ca3-49bb-9134-32c5274b029d" providerId="ADAL" clId="{A2AFF3C0-B35D-4D35-896C-645D8DA4EEB0}" dt="2026-08-25T14:42:36.600" v="275" actId="20577"/>
+        <pc:chgData name="Katie Owers Bonner" userId="031be739-2ca3-49bb-9134-32c5274b029d" providerId="ADAL" clId="{A2AFF3C0-B35D-4D35-896C-645D8DA4EEB0}" dt="2026-08-31T13:37:26.869" v="752" actId="6549"/>
         <pc:sldMkLst>
           <pc:docMk/>
           <pc:sldMk cId="1004716227" sldId="384"/>
@@ -341,6 +307,36 @@
             <ac:spMk id="410" creationId="{56E0C99F-CD6A-56C9-69D8-9A0ACFD8D8BA}"/>
           </ac:spMkLst>
         </pc:spChg>
+        <pc:spChg chg="mod">
+          <ac:chgData name="Katie Owers Bonner" userId="031be739-2ca3-49bb-9134-32c5274b029d" providerId="ADAL" clId="{A2AFF3C0-B35D-4D35-896C-645D8DA4EEB0}" dt="2026-08-31T13:37:26.869" v="752" actId="6549"/>
+          <ac:spMkLst>
+            <pc:docMk/>
+            <pc:sldMk cId="1004716227" sldId="384"/>
+            <ac:spMk id="411" creationId="{DFBCC7F1-E720-B918-8B69-A0B3687D7154}"/>
+          </ac:spMkLst>
+        </pc:spChg>
+      </pc:sldChg>
+      <pc:sldChg chg="modSp mod">
+        <pc:chgData name="Katie Owers Bonner" userId="031be739-2ca3-49bb-9134-32c5274b029d" providerId="ADAL" clId="{A2AFF3C0-B35D-4D35-896C-645D8DA4EEB0}" dt="2026-08-31T13:28:59.138" v="730" actId="20577"/>
+        <pc:sldMkLst>
+          <pc:docMk/>
+          <pc:sldMk cId="253628221" sldId="385"/>
+        </pc:sldMkLst>
+        <pc:spChg chg="mod">
+          <ac:chgData name="Katie Owers Bonner" userId="031be739-2ca3-49bb-9134-32c5274b029d" providerId="ADAL" clId="{A2AFF3C0-B35D-4D35-896C-645D8DA4EEB0}" dt="2026-08-31T13:28:59.138" v="730" actId="20577"/>
+          <ac:spMkLst>
+            <pc:docMk/>
+            <pc:sldMk cId="253628221" sldId="385"/>
+            <ac:spMk id="404" creationId="{5C4BE77C-871F-04F9-5530-4C4BCEF146E7}"/>
+          </ac:spMkLst>
+        </pc:spChg>
+      </pc:sldChg>
+      <pc:sldChg chg="ord">
+        <pc:chgData name="Katie Owers Bonner" userId="031be739-2ca3-49bb-9134-32c5274b029d" providerId="ADAL" clId="{A2AFF3C0-B35D-4D35-896C-645D8DA4EEB0}" dt="2026-08-31T13:48:03.169" v="756"/>
+        <pc:sldMkLst>
+          <pc:docMk/>
+          <pc:sldMk cId="2386386992" sldId="388"/>
+        </pc:sldMkLst>
       </pc:sldChg>
       <pc:sldChg chg="add del">
         <pc:chgData name="Katie Owers Bonner" userId="031be739-2ca3-49bb-9134-32c5274b029d" providerId="ADAL" clId="{A2AFF3C0-B35D-4D35-896C-645D8DA4EEB0}" dt="2026-08-25T14:30:52.052" v="10" actId="47"/>
@@ -354,50 +350,6 @@
         <pc:sldMkLst>
           <pc:docMk/>
           <pc:sldMk cId="1223427279" sldId="391"/>
-        </pc:sldMkLst>
-      </pc:sldChg>
-      <pc:sldChg chg="add del">
-        <pc:chgData name="Katie Owers Bonner" userId="031be739-2ca3-49bb-9134-32c5274b029d" providerId="ADAL" clId="{A2AFF3C0-B35D-4D35-896C-645D8DA4EEB0}" dt="2026-08-25T14:42:57.424" v="283"/>
-        <pc:sldMkLst>
-          <pc:docMk/>
-          <pc:sldMk cId="2689544542" sldId="391"/>
-        </pc:sldMkLst>
-      </pc:sldChg>
-      <pc:sldChg chg="modSp add del mod">
-        <pc:chgData name="Katie Owers Bonner" userId="031be739-2ca3-49bb-9134-32c5274b029d" providerId="ADAL" clId="{A2AFF3C0-B35D-4D35-896C-645D8DA4EEB0}" dt="2026-08-25T14:42:25.989" v="266" actId="47"/>
-        <pc:sldMkLst>
-          <pc:docMk/>
-          <pc:sldMk cId="2944975061" sldId="391"/>
-        </pc:sldMkLst>
-        <pc:spChg chg="mod">
-          <ac:chgData name="Katie Owers Bonner" userId="031be739-2ca3-49bb-9134-32c5274b029d" providerId="ADAL" clId="{A2AFF3C0-B35D-4D35-896C-645D8DA4EEB0}" dt="2026-08-25T14:41:33.380" v="245"/>
-          <ac:spMkLst>
-            <pc:docMk/>
-            <pc:sldMk cId="2944975061" sldId="391"/>
-            <ac:spMk id="141" creationId="{B4611B3F-98A1-021B-2D41-FA612281AE1E}"/>
-          </ac:spMkLst>
-        </pc:spChg>
-        <pc:spChg chg="mod">
-          <ac:chgData name="Katie Owers Bonner" userId="031be739-2ca3-49bb-9134-32c5274b029d" providerId="ADAL" clId="{A2AFF3C0-B35D-4D35-896C-645D8DA4EEB0}" dt="2026-08-25T14:42:15.366" v="262" actId="1076"/>
-          <ac:spMkLst>
-            <pc:docMk/>
-            <pc:sldMk cId="2944975061" sldId="391"/>
-            <ac:spMk id="142" creationId="{E2492666-7CBC-4032-30A9-9FFCAE4B2F1B}"/>
-          </ac:spMkLst>
-        </pc:spChg>
-      </pc:sldChg>
-      <pc:sldChg chg="add del">
-        <pc:chgData name="Katie Owers Bonner" userId="031be739-2ca3-49bb-9134-32c5274b029d" providerId="ADAL" clId="{A2AFF3C0-B35D-4D35-896C-645D8DA4EEB0}" dt="2026-08-25T14:42:51.181" v="281"/>
-        <pc:sldMkLst>
-          <pc:docMk/>
-          <pc:sldMk cId="3020371471" sldId="391"/>
-        </pc:sldMkLst>
-      </pc:sldChg>
-      <pc:sldChg chg="add del">
-        <pc:chgData name="Katie Owers Bonner" userId="031be739-2ca3-49bb-9134-32c5274b029d" providerId="ADAL" clId="{A2AFF3C0-B35D-4D35-896C-645D8DA4EEB0}" dt="2026-08-25T14:42:48.088" v="279"/>
-        <pc:sldMkLst>
-          <pc:docMk/>
-          <pc:sldMk cId="3268291564" sldId="391"/>
         </pc:sldMkLst>
       </pc:sldChg>
       <pc:sldChg chg="modSp add mod ord">
@@ -415,13 +367,6 @@
           </ac:spMkLst>
         </pc:spChg>
       </pc:sldChg>
-      <pc:sldChg chg="add del">
-        <pc:chgData name="Katie Owers Bonner" userId="031be739-2ca3-49bb-9134-32c5274b029d" providerId="ADAL" clId="{A2AFF3C0-B35D-4D35-896C-645D8DA4EEB0}" dt="2026-08-25T14:44:22.300" v="329"/>
-        <pc:sldMkLst>
-          <pc:docMk/>
-          <pc:sldMk cId="1167498359" sldId="393"/>
-        </pc:sldMkLst>
-      </pc:sldChg>
       <pc:sldChg chg="addSp delSp modSp new mod modClrScheme chgLayout">
         <pc:chgData name="Katie Owers Bonner" userId="031be739-2ca3-49bb-9134-32c5274b029d" providerId="ADAL" clId="{A2AFF3C0-B35D-4D35-896C-645D8DA4EEB0}" dt="2026-08-25T14:48:26.502" v="514" actId="1076"/>
         <pc:sldMkLst>
@@ -434,38 +379,6 @@
             <pc:docMk/>
             <pc:sldMk cId="2296402173" sldId="393"/>
             <ac:spMk id="2" creationId="{2E7D3381-C585-2A1E-1968-D1CFD3DF086F}"/>
-          </ac:spMkLst>
-        </pc:spChg>
-        <pc:spChg chg="add del mod">
-          <ac:chgData name="Katie Owers Bonner" userId="031be739-2ca3-49bb-9134-32c5274b029d" providerId="ADAL" clId="{A2AFF3C0-B35D-4D35-896C-645D8DA4EEB0}" dt="2026-08-25T14:47:55.402" v="508" actId="26606"/>
-          <ac:spMkLst>
-            <pc:docMk/>
-            <pc:sldMk cId="2296402173" sldId="393"/>
-            <ac:spMk id="3" creationId="{E5AC3EB7-06CD-717F-0B82-DDDA9A23BA55}"/>
-          </ac:spMkLst>
-        </pc:spChg>
-        <pc:spChg chg="add del mod">
-          <ac:chgData name="Katie Owers Bonner" userId="031be739-2ca3-49bb-9134-32c5274b029d" providerId="ADAL" clId="{A2AFF3C0-B35D-4D35-896C-645D8DA4EEB0}" dt="2026-08-25T14:47:55.402" v="507" actId="26606"/>
-          <ac:spMkLst>
-            <pc:docMk/>
-            <pc:sldMk cId="2296402173" sldId="393"/>
-            <ac:spMk id="5" creationId="{7639195E-1B8D-B740-7CED-5AD05C684A81}"/>
-          </ac:spMkLst>
-        </pc:spChg>
-        <pc:spChg chg="add del mod">
-          <ac:chgData name="Katie Owers Bonner" userId="031be739-2ca3-49bb-9134-32c5274b029d" providerId="ADAL" clId="{A2AFF3C0-B35D-4D35-896C-645D8DA4EEB0}" dt="2026-08-25T14:47:58.573" v="509" actId="478"/>
-          <ac:spMkLst>
-            <pc:docMk/>
-            <pc:sldMk cId="2296402173" sldId="393"/>
-            <ac:spMk id="7" creationId="{87D80540-3164-8E2F-F8BF-C56C49DA85F4}"/>
-          </ac:spMkLst>
-        </pc:spChg>
-        <pc:spChg chg="add del mod">
-          <ac:chgData name="Katie Owers Bonner" userId="031be739-2ca3-49bb-9134-32c5274b029d" providerId="ADAL" clId="{A2AFF3C0-B35D-4D35-896C-645D8DA4EEB0}" dt="2026-08-25T14:47:48.044" v="505" actId="26606"/>
-          <ac:spMkLst>
-            <pc:docMk/>
-            <pc:sldMk cId="2296402173" sldId="393"/>
-            <ac:spMk id="8" creationId="{C9A51912-6A04-4A61-7A1B-8D813180F983}"/>
           </ac:spMkLst>
         </pc:spChg>
       </pc:sldChg>
@@ -492,6 +405,29 @@
           </ac:spMkLst>
         </pc:spChg>
       </pc:sldChg>
+      <pc:sldChg chg="modSp add mod ord">
+        <pc:chgData name="Katie Owers Bonner" userId="031be739-2ca3-49bb-9134-32c5274b029d" providerId="ADAL" clId="{A2AFF3C0-B35D-4D35-896C-645D8DA4EEB0}" dt="2026-08-25T19:56:40.121" v="696" actId="14100"/>
+        <pc:sldMkLst>
+          <pc:docMk/>
+          <pc:sldMk cId="3505932459" sldId="395"/>
+        </pc:sldMkLst>
+        <pc:spChg chg="mod">
+          <ac:chgData name="Katie Owers Bonner" userId="031be739-2ca3-49bb-9134-32c5274b029d" providerId="ADAL" clId="{A2AFF3C0-B35D-4D35-896C-645D8DA4EEB0}" dt="2026-08-25T19:56:36.538" v="695" actId="20577"/>
+          <ac:spMkLst>
+            <pc:docMk/>
+            <pc:sldMk cId="3505932459" sldId="395"/>
+            <ac:spMk id="134" creationId="{B2390F86-F7C2-0C93-6066-1A98C227DC84}"/>
+          </ac:spMkLst>
+        </pc:spChg>
+        <pc:spChg chg="mod">
+          <ac:chgData name="Katie Owers Bonner" userId="031be739-2ca3-49bb-9134-32c5274b029d" providerId="ADAL" clId="{A2AFF3C0-B35D-4D35-896C-645D8DA4EEB0}" dt="2026-08-25T19:56:40.121" v="696" actId="14100"/>
+          <ac:spMkLst>
+            <pc:docMk/>
+            <pc:sldMk cId="3505932459" sldId="395"/>
+            <ac:spMk id="135" creationId="{0C15ED0C-A394-9233-F734-6F8EBBB3A9C7}"/>
+          </ac:spMkLst>
+        </pc:spChg>
+      </pc:sldChg>
       <pc:sldMasterChg chg="addSldLayout delSldLayout modSldLayout">
         <pc:chgData name="Katie Owers Bonner" userId="031be739-2ca3-49bb-9134-32c5274b029d" providerId="ADAL" clId="{A2AFF3C0-B35D-4D35-896C-645D8DA4EEB0}" dt="2026-08-25T14:47:19.202" v="501"/>
         <pc:sldMasterMkLst>
@@ -506,14 +442,6 @@
             <pc:sldLayoutMk cId="2982445581" sldId="2147483662"/>
           </pc:sldLayoutMkLst>
         </pc:sldLayoutChg>
-        <pc:sldLayoutChg chg="add del">
-          <pc:chgData name="Katie Owers Bonner" userId="031be739-2ca3-49bb-9134-32c5274b029d" providerId="ADAL" clId="{A2AFF3C0-B35D-4D35-896C-645D8DA4EEB0}" dt="2026-08-25T14:31:23.543" v="22" actId="47"/>
-          <pc:sldLayoutMkLst>
-            <pc:docMk/>
-            <pc:sldMasterMk cId="2621704862" sldId="2147483661"/>
-            <pc:sldLayoutMk cId="2584189377" sldId="2147483676"/>
-          </pc:sldLayoutMkLst>
-        </pc:sldLayoutChg>
         <pc:sldLayoutChg chg="delSp">
           <pc:chgData name="Katie Owers Bonner" userId="031be739-2ca3-49bb-9134-32c5274b029d" providerId="ADAL" clId="{A2AFF3C0-B35D-4D35-896C-645D8DA4EEB0}" dt="2026-08-25T14:47:19.202" v="501"/>
           <pc:sldLayoutMkLst>
@@ -521,38 +449,32 @@
             <pc:sldMasterMk cId="2621704862" sldId="2147483661"/>
             <pc:sldLayoutMk cId="3920709949" sldId="2147483683"/>
           </pc:sldLayoutMkLst>
-          <pc:spChg chg="del">
-            <ac:chgData name="Katie Owers Bonner" userId="031be739-2ca3-49bb-9134-32c5274b029d" providerId="ADAL" clId="{A2AFF3C0-B35D-4D35-896C-645D8DA4EEB0}" dt="2026-08-25T14:47:19.202" v="501"/>
-            <ac:spMkLst>
-              <pc:docMk/>
-              <pc:sldMasterMk cId="2621704862" sldId="2147483661"/>
-              <pc:sldLayoutMk cId="3920709949" sldId="2147483683"/>
-              <ac:spMk id="73" creationId="{00000000-0000-0000-0000-000000000000}"/>
-            </ac:spMkLst>
-          </pc:spChg>
-          <pc:spChg chg="del">
-            <ac:chgData name="Katie Owers Bonner" userId="031be739-2ca3-49bb-9134-32c5274b029d" providerId="ADAL" clId="{A2AFF3C0-B35D-4D35-896C-645D8DA4EEB0}" dt="2026-08-25T14:47:19.202" v="501"/>
-            <ac:spMkLst>
-              <pc:docMk/>
-              <pc:sldMasterMk cId="2621704862" sldId="2147483661"/>
-              <pc:sldLayoutMk cId="3920709949" sldId="2147483683"/>
-              <ac:spMk id="74" creationId="{00000000-0000-0000-0000-000000000000}"/>
-            </ac:spMkLst>
-          </pc:spChg>
-          <pc:spChg chg="del">
-            <ac:chgData name="Katie Owers Bonner" userId="031be739-2ca3-49bb-9134-32c5274b029d" providerId="ADAL" clId="{A2AFF3C0-B35D-4D35-896C-645D8DA4EEB0}" dt="2026-08-25T14:47:19.202" v="501"/>
-            <ac:spMkLst>
-              <pc:docMk/>
-              <pc:sldMasterMk cId="2621704862" sldId="2147483661"/>
-              <pc:sldLayoutMk cId="3920709949" sldId="2147483683"/>
-              <ac:spMk id="76" creationId="{00000000-0000-0000-0000-000000000000}"/>
-            </ac:spMkLst>
-          </pc:spChg>
         </pc:sldLayoutChg>
       </pc:sldMasterChg>
     </pc:docChg>
   </pc:docChgLst>
 </pc:chgInfo>
+</file>
+
+<file path=ppt/comments/modernComment_17D_7DC4E0F5.xml><?xml version="1.0" encoding="utf-8"?>
+<p188:cmLst xmlns:a="http://schemas.openxmlformats.org/drawingml/2006/main" xmlns:r="http://schemas.openxmlformats.org/officeDocument/2006/relationships" xmlns:p188="http://schemas.microsoft.com/office/powerpoint/2018/8/main">
+  <p188:cm id="{DBC26449-BF37-4967-A178-96C99F096B0C}" authorId="{45D1CE9B-DF25-4FEC-06DE-212637DD9CB8}" created="2026-02-02T21:26:20.531">
+    <pc:sldMkLst xmlns:pc="http://schemas.microsoft.com/office/powerpoint/2013/main/command">
+      <pc:docMk/>
+      <pc:sldMk cId="497580468" sldId="381"/>
+    </pc:sldMkLst>
+    <p188:txBody>
+      <a:bodyPr/>
+      <a:lstStyle/>
+      <a:p>
+        <a:r>
+          <a:rPr lang="en-US"/>
+          <a:t>Decide how much of this and the R slide are needed. Keep RStudio</a:t>
+        </a:r>
+      </a:p>
+    </p188:txBody>
+  </p188:cm>
+</p188:cmLst>
 </file>
 
 <file path=ppt/notesMasters/notesMaster1.xml><?xml version="1.0" encoding="utf-8"?>
@@ -637,7 +559,7 @@
           <a:p>
             <a:fld id="{F19BCB6A-05C9-45C4-8C56-4DA0982723A6}" type="datetimeFigureOut">
               <a:rPr lang="en-US" smtClean="0"/>
-              <a:t>8/25/2026</a:t>
+              <a:t>8/31/2026</a:t>
             </a:fld>
             <a:endParaRPr lang="en-US"/>
           </a:p>
@@ -946,37 +868,6 @@
           </a:bodyPr>
           <a:lstStyle/>
           <a:p>
-            <a:pPr marL="0" marR="0" lvl="0" indent="0" algn="l" defTabSz="914400" rtl="0" eaLnBrk="1" fontAlgn="auto" latinLnBrk="0" hangingPunct="1">
-              <a:lnSpc>
-                <a:spcPct val="100000"/>
-              </a:lnSpc>
-              <a:spcBef>
-                <a:spcPts val="0"/>
-              </a:spcBef>
-              <a:spcAft>
-                <a:spcPts val="0"/>
-              </a:spcAft>
-              <a:buClrTx/>
-              <a:buSzTx/>
-              <a:buFontTx/>
-              <a:buNone/>
-              <a:tabLst/>
-              <a:defRPr/>
-            </a:pPr>
-            <a:r>
-              <a:rPr lang="en-US" sz="1200" b="0" i="0" kern="1200" dirty="0">
-                <a:solidFill>
-                  <a:schemeClr val="tx1"/>
-                </a:solidFill>
-                <a:effectLst/>
-                <a:latin typeface="+mn-lt"/>
-                <a:ea typeface="+mn-ea"/>
-                <a:cs typeface="+mn-cs"/>
-              </a:rPr>
-              <a:t>While people are joining - put something you're looking forward to this month in the chat!</a:t>
-            </a:r>
-          </a:p>
-          <a:p>
             <a:pPr marL="0" lvl="0" indent="0" algn="l" rtl="0">
               <a:spcBef>
                 <a:spcPts val="0"/>
@@ -1047,7 +938,7 @@
         <p:cNvPr id="1" name="Shape 399">
           <a:extLst>
             <a:ext uri="{FF2B5EF4-FFF2-40B4-BE49-F238E27FC236}">
-              <a16:creationId xmlns:a16="http://schemas.microsoft.com/office/drawing/2014/main" id="{34F22D89-3098-F772-6A2C-E8AB6713CFAF}"/>
+              <a16:creationId xmlns:a16="http://schemas.microsoft.com/office/drawing/2014/main" id="{0F7086A5-A86A-C9CF-5D0E-EFF43A4E8E47}"/>
             </a:ext>
           </a:extLst>
         </p:cNvPr>
@@ -1067,7 +958,7 @@
           <p:cNvPr id="400" name="Google Shape;400;g3b4aedc2736_1_104:notes">
             <a:extLst>
               <a:ext uri="{FF2B5EF4-FFF2-40B4-BE49-F238E27FC236}">
-                <a16:creationId xmlns:a16="http://schemas.microsoft.com/office/drawing/2014/main" id="{67E83DA5-1B8C-A466-EDE7-107175B5A945}"/>
+                <a16:creationId xmlns:a16="http://schemas.microsoft.com/office/drawing/2014/main" id="{7E4C12AA-A7C9-ECC0-C304-F5B05BE903AA}"/>
               </a:ext>
             </a:extLst>
           </p:cNvPr>
@@ -1120,7 +1011,7 @@
           <p:cNvPr id="401" name="Google Shape;401;g3b4aedc2736_1_104:notes">
             <a:extLst>
               <a:ext uri="{FF2B5EF4-FFF2-40B4-BE49-F238E27FC236}">
-                <a16:creationId xmlns:a16="http://schemas.microsoft.com/office/drawing/2014/main" id="{FC1B0303-9825-AF45-0DBC-14F560F912BA}"/>
+                <a16:creationId xmlns:a16="http://schemas.microsoft.com/office/drawing/2014/main" id="{73A9895A-2001-B9C0-94BE-EA02E6648583}"/>
               </a:ext>
             </a:extLst>
           </p:cNvPr>
@@ -1175,7 +1066,7 @@
     </p:spTree>
     <p:extLst>
       <p:ext uri="{BB962C8B-B14F-4D97-AF65-F5344CB8AC3E}">
-        <p14:creationId xmlns:p14="http://schemas.microsoft.com/office/powerpoint/2010/main" val="804786023"/>
+        <p14:creationId xmlns:p14="http://schemas.microsoft.com/office/powerpoint/2010/main" val="3925003050"/>
       </p:ext>
     </p:extLst>
   </p:cSld>
@@ -1608,6 +1499,152 @@
         <p:cNvPr id="1" name="Shape 399">
           <a:extLst>
             <a:ext uri="{FF2B5EF4-FFF2-40B4-BE49-F238E27FC236}">
+              <a16:creationId xmlns:a16="http://schemas.microsoft.com/office/drawing/2014/main" id="{34F22D89-3098-F772-6A2C-E8AB6713CFAF}"/>
+            </a:ext>
+          </a:extLst>
+        </p:cNvPr>
+        <p:cNvGrpSpPr/>
+        <p:nvPr/>
+      </p:nvGrpSpPr>
+      <p:grpSpPr>
+        <a:xfrm>
+          <a:off x="0" y="0"/>
+          <a:ext cx="0" cy="0"/>
+          <a:chOff x="0" y="0"/>
+          <a:chExt cx="0" cy="0"/>
+        </a:xfrm>
+      </p:grpSpPr>
+      <p:sp>
+        <p:nvSpPr>
+          <p:cNvPr id="400" name="Google Shape;400;g3b4aedc2736_1_104:notes">
+            <a:extLst>
+              <a:ext uri="{FF2B5EF4-FFF2-40B4-BE49-F238E27FC236}">
+                <a16:creationId xmlns:a16="http://schemas.microsoft.com/office/drawing/2014/main" id="{67E83DA5-1B8C-A466-EDE7-107175B5A945}"/>
+              </a:ext>
+            </a:extLst>
+          </p:cNvPr>
+          <p:cNvSpPr txBox="1">
+            <a:spLocks noGrp="1"/>
+          </p:cNvSpPr>
+          <p:nvPr>
+            <p:ph type="body" idx="1"/>
+          </p:nvPr>
+        </p:nvSpPr>
+        <p:spPr>
+          <a:xfrm>
+            <a:off x="685800" y="4343400"/>
+            <a:ext cx="5486400" cy="4114800"/>
+          </a:xfrm>
+          <a:prstGeom prst="rect">
+            <a:avLst/>
+          </a:prstGeom>
+          <a:noFill/>
+          <a:ln>
+            <a:noFill/>
+          </a:ln>
+        </p:spPr>
+        <p:txBody>
+          <a:bodyPr spcFirstLastPara="1" wrap="square" lIns="91425" tIns="91425" rIns="91425" bIns="91425" anchor="t" anchorCtr="0">
+            <a:noAutofit/>
+          </a:bodyPr>
+          <a:lstStyle/>
+          <a:p>
+            <a:pPr marL="0" lvl="0" indent="0" algn="l" rtl="0">
+              <a:spcBef>
+                <a:spcPts val="0"/>
+              </a:spcBef>
+              <a:spcAft>
+                <a:spcPts val="0"/>
+              </a:spcAft>
+              <a:buClr>
+                <a:schemeClr val="dk1"/>
+              </a:buClr>
+              <a:buSzPts val="1200"/>
+              <a:buFont typeface="Arial"/>
+              <a:buNone/>
+            </a:pPr>
+            <a:endParaRPr/>
+          </a:p>
+        </p:txBody>
+      </p:sp>
+      <p:sp>
+        <p:nvSpPr>
+          <p:cNvPr id="401" name="Google Shape;401;g3b4aedc2736_1_104:notes">
+            <a:extLst>
+              <a:ext uri="{FF2B5EF4-FFF2-40B4-BE49-F238E27FC236}">
+                <a16:creationId xmlns:a16="http://schemas.microsoft.com/office/drawing/2014/main" id="{FC1B0303-9825-AF45-0DBC-14F560F912BA}"/>
+              </a:ext>
+            </a:extLst>
+          </p:cNvPr>
+          <p:cNvSpPr>
+            <a:spLocks noGrp="1" noRot="1" noChangeAspect="1"/>
+          </p:cNvSpPr>
+          <p:nvPr>
+            <p:ph type="sldImg" idx="2"/>
+          </p:nvPr>
+        </p:nvSpPr>
+        <p:spPr>
+          <a:xfrm>
+            <a:off x="381000" y="685800"/>
+            <a:ext cx="6096000" cy="3429000"/>
+          </a:xfrm>
+          <a:custGeom>
+            <a:avLst/>
+            <a:gdLst/>
+            <a:ahLst/>
+            <a:cxnLst/>
+            <a:rect l="l" t="t" r="r" b="b"/>
+            <a:pathLst>
+              <a:path w="120000" h="120000" extrusionOk="0">
+                <a:moveTo>
+                  <a:pt x="0" y="0"/>
+                </a:moveTo>
+                <a:lnTo>
+                  <a:pt x="120000" y="0"/>
+                </a:lnTo>
+                <a:lnTo>
+                  <a:pt x="120000" y="120000"/>
+                </a:lnTo>
+                <a:lnTo>
+                  <a:pt x="0" y="120000"/>
+                </a:lnTo>
+                <a:close/>
+              </a:path>
+            </a:pathLst>
+          </a:custGeom>
+          <a:noFill/>
+          <a:ln w="12700" cap="flat" cmpd="sng">
+            <a:solidFill>
+              <a:srgbClr val="000000"/>
+            </a:solidFill>
+            <a:prstDash val="solid"/>
+            <a:round/>
+            <a:headEnd type="none" w="sm" len="sm"/>
+            <a:tailEnd type="none" w="sm" len="sm"/>
+          </a:ln>
+        </p:spPr>
+      </p:sp>
+    </p:spTree>
+    <p:extLst>
+      <p:ext uri="{BB962C8B-B14F-4D97-AF65-F5344CB8AC3E}">
+        <p14:creationId xmlns:p14="http://schemas.microsoft.com/office/powerpoint/2010/main" val="804786023"/>
+      </p:ext>
+    </p:extLst>
+  </p:cSld>
+  <p:clrMapOvr>
+    <a:masterClrMapping/>
+  </p:clrMapOvr>
+</p:notes>
+</file>
+
+<file path=ppt/notesSlides/notesSlide15.xml><?xml version="1.0" encoding="utf-8"?>
+<p:notes xmlns:a="http://schemas.openxmlformats.org/drawingml/2006/main" xmlns:r="http://schemas.openxmlformats.org/officeDocument/2006/relationships" xmlns:p="http://schemas.openxmlformats.org/presentationml/2006/main" showMasterSp="0" showMasterPhAnim="0">
+  <p:cSld>
+    <p:spTree>
+      <p:nvGrpSpPr>
+        <p:cNvPr id="1" name="Shape 399">
+          <a:extLst>
+            <a:ext uri="{FF2B5EF4-FFF2-40B4-BE49-F238E27FC236}">
               <a16:creationId xmlns:a16="http://schemas.microsoft.com/office/drawing/2014/main" id="{0355F859-177F-3E88-8C28-609B0065DEF4}"/>
             </a:ext>
           </a:extLst>
@@ -1746,7 +1783,7 @@
 </p:notes>
 </file>
 
-<file path=ppt/notesSlides/notesSlide15.xml><?xml version="1.0" encoding="utf-8"?>
+<file path=ppt/notesSlides/notesSlide16.xml><?xml version="1.0" encoding="utf-8"?>
 <p:notes xmlns:a="http://schemas.openxmlformats.org/drawingml/2006/main" xmlns:r="http://schemas.openxmlformats.org/officeDocument/2006/relationships" xmlns:p="http://schemas.openxmlformats.org/presentationml/2006/main" showMasterSp="0" showMasterPhAnim="0">
   <p:cSld>
     <p:spTree>
@@ -1873,7 +1910,7 @@
 </p:notes>
 </file>
 
-<file path=ppt/notesSlides/notesSlide16.xml><?xml version="1.0" encoding="utf-8"?>
+<file path=ppt/notesSlides/notesSlide17.xml><?xml version="1.0" encoding="utf-8"?>
 <p:notes xmlns:a="http://schemas.openxmlformats.org/drawingml/2006/main" xmlns:r="http://schemas.openxmlformats.org/officeDocument/2006/relationships" xmlns:p="http://schemas.openxmlformats.org/presentationml/2006/main" showMasterSp="0" showMasterPhAnim="0">
   <p:cSld>
     <p:spTree>
@@ -1991,6 +2028,260 @@
     <p:extLst>
       <p:ext uri="{BB962C8B-B14F-4D97-AF65-F5344CB8AC3E}">
         <p14:creationId xmlns:p14="http://schemas.microsoft.com/office/powerpoint/2010/main" val="1394264793"/>
+      </p:ext>
+    </p:extLst>
+  </p:cSld>
+  <p:clrMapOvr>
+    <a:masterClrMapping/>
+  </p:clrMapOvr>
+</p:notes>
+</file>
+
+<file path=ppt/notesSlides/notesSlide18.xml><?xml version="1.0" encoding="utf-8"?>
+<p:notes xmlns:a="http://schemas.openxmlformats.org/drawingml/2006/main" xmlns:r="http://schemas.openxmlformats.org/officeDocument/2006/relationships" xmlns:p="http://schemas.openxmlformats.org/presentationml/2006/main" showMasterSp="0" showMasterPhAnim="0">
+  <p:cSld>
+    <p:spTree>
+      <p:nvGrpSpPr>
+        <p:cNvPr id="1" name="Shape 130">
+          <a:extLst>
+            <a:ext uri="{FF2B5EF4-FFF2-40B4-BE49-F238E27FC236}">
+              <a16:creationId xmlns:a16="http://schemas.microsoft.com/office/drawing/2014/main" id="{2CC2EE28-5F41-E683-EE6C-257DA08AD285}"/>
+            </a:ext>
+          </a:extLst>
+        </p:cNvPr>
+        <p:cNvGrpSpPr/>
+        <p:nvPr/>
+      </p:nvGrpSpPr>
+      <p:grpSpPr>
+        <a:xfrm>
+          <a:off x="0" y="0"/>
+          <a:ext cx="0" cy="0"/>
+          <a:chOff x="0" y="0"/>
+          <a:chExt cx="0" cy="0"/>
+        </a:xfrm>
+      </p:grpSpPr>
+      <p:sp>
+        <p:nvSpPr>
+          <p:cNvPr id="131" name="Google Shape;131;p4:notes">
+            <a:extLst>
+              <a:ext uri="{FF2B5EF4-FFF2-40B4-BE49-F238E27FC236}">
+                <a16:creationId xmlns:a16="http://schemas.microsoft.com/office/drawing/2014/main" id="{8EC24C3B-DE6C-5D37-2207-3A02ECB92E34}"/>
+              </a:ext>
+            </a:extLst>
+          </p:cNvPr>
+          <p:cNvSpPr txBox="1">
+            <a:spLocks noGrp="1"/>
+          </p:cNvSpPr>
+          <p:nvPr>
+            <p:ph type="body" idx="1"/>
+          </p:nvPr>
+        </p:nvSpPr>
+        <p:spPr>
+          <a:xfrm>
+            <a:off x="685800" y="4343400"/>
+            <a:ext cx="5486400" cy="4114800"/>
+          </a:xfrm>
+          <a:prstGeom prst="rect">
+            <a:avLst/>
+          </a:prstGeom>
+        </p:spPr>
+        <p:txBody>
+          <a:bodyPr spcFirstLastPara="1" wrap="square" lIns="91425" tIns="91425" rIns="91425" bIns="91425" anchor="t" anchorCtr="0">
+            <a:noAutofit/>
+          </a:bodyPr>
+          <a:lstStyle/>
+          <a:p>
+            <a:pPr marL="0" lvl="0" indent="0" algn="l" rtl="0">
+              <a:spcBef>
+                <a:spcPts val="0"/>
+              </a:spcBef>
+              <a:spcAft>
+                <a:spcPts val="0"/>
+              </a:spcAft>
+              <a:buNone/>
+            </a:pPr>
+            <a:endParaRPr/>
+          </a:p>
+        </p:txBody>
+      </p:sp>
+      <p:sp>
+        <p:nvSpPr>
+          <p:cNvPr id="132" name="Google Shape;132;p4:notes">
+            <a:extLst>
+              <a:ext uri="{FF2B5EF4-FFF2-40B4-BE49-F238E27FC236}">
+                <a16:creationId xmlns:a16="http://schemas.microsoft.com/office/drawing/2014/main" id="{09C3F176-C072-454E-4568-D044199DDA15}"/>
+              </a:ext>
+            </a:extLst>
+          </p:cNvPr>
+          <p:cNvSpPr>
+            <a:spLocks noGrp="1" noRot="1" noChangeAspect="1"/>
+          </p:cNvSpPr>
+          <p:nvPr>
+            <p:ph type="sldImg" idx="2"/>
+          </p:nvPr>
+        </p:nvSpPr>
+        <p:spPr>
+          <a:xfrm>
+            <a:off x="381000" y="685800"/>
+            <a:ext cx="6096000" cy="3429000"/>
+          </a:xfrm>
+          <a:custGeom>
+            <a:avLst/>
+            <a:gdLst/>
+            <a:ahLst/>
+            <a:cxnLst/>
+            <a:rect l="l" t="t" r="r" b="b"/>
+            <a:pathLst>
+              <a:path w="120000" h="120000" extrusionOk="0">
+                <a:moveTo>
+                  <a:pt x="0" y="0"/>
+                </a:moveTo>
+                <a:lnTo>
+                  <a:pt x="120000" y="0"/>
+                </a:lnTo>
+                <a:lnTo>
+                  <a:pt x="120000" y="120000"/>
+                </a:lnTo>
+                <a:lnTo>
+                  <a:pt x="0" y="120000"/>
+                </a:lnTo>
+                <a:close/>
+              </a:path>
+            </a:pathLst>
+          </a:custGeom>
+        </p:spPr>
+      </p:sp>
+    </p:spTree>
+    <p:extLst>
+      <p:ext uri="{BB962C8B-B14F-4D97-AF65-F5344CB8AC3E}">
+        <p14:creationId xmlns:p14="http://schemas.microsoft.com/office/powerpoint/2010/main" val="2958105343"/>
+      </p:ext>
+    </p:extLst>
+  </p:cSld>
+  <p:clrMapOvr>
+    <a:masterClrMapping/>
+  </p:clrMapOvr>
+</p:notes>
+</file>
+
+<file path=ppt/notesSlides/notesSlide19.xml><?xml version="1.0" encoding="utf-8"?>
+<p:notes xmlns:a="http://schemas.openxmlformats.org/drawingml/2006/main" xmlns:r="http://schemas.openxmlformats.org/officeDocument/2006/relationships" xmlns:p="http://schemas.openxmlformats.org/presentationml/2006/main" showMasterSp="0" showMasterPhAnim="0">
+  <p:cSld>
+    <p:spTree>
+      <p:nvGrpSpPr>
+        <p:cNvPr id="1" name="Shape 136">
+          <a:extLst>
+            <a:ext uri="{FF2B5EF4-FFF2-40B4-BE49-F238E27FC236}">
+              <a16:creationId xmlns:a16="http://schemas.microsoft.com/office/drawing/2014/main" id="{B49412A7-B15D-7A44-A17D-698E2D072C5A}"/>
+            </a:ext>
+          </a:extLst>
+        </p:cNvPr>
+        <p:cNvGrpSpPr/>
+        <p:nvPr/>
+      </p:nvGrpSpPr>
+      <p:grpSpPr>
+        <a:xfrm>
+          <a:off x="0" y="0"/>
+          <a:ext cx="0" cy="0"/>
+          <a:chOff x="0" y="0"/>
+          <a:chExt cx="0" cy="0"/>
+        </a:xfrm>
+      </p:grpSpPr>
+      <p:sp>
+        <p:nvSpPr>
+          <p:cNvPr id="137" name="Google Shape;137;p5:notes">
+            <a:extLst>
+              <a:ext uri="{FF2B5EF4-FFF2-40B4-BE49-F238E27FC236}">
+                <a16:creationId xmlns:a16="http://schemas.microsoft.com/office/drawing/2014/main" id="{F40A2094-F6A4-54B3-0F79-12B4B2BF6A4F}"/>
+              </a:ext>
+            </a:extLst>
+          </p:cNvPr>
+          <p:cNvSpPr txBox="1">
+            <a:spLocks noGrp="1"/>
+          </p:cNvSpPr>
+          <p:nvPr>
+            <p:ph type="body" idx="1"/>
+          </p:nvPr>
+        </p:nvSpPr>
+        <p:spPr>
+          <a:xfrm>
+            <a:off x="685800" y="4343400"/>
+            <a:ext cx="5486400" cy="4114800"/>
+          </a:xfrm>
+          <a:prstGeom prst="rect">
+            <a:avLst/>
+          </a:prstGeom>
+        </p:spPr>
+        <p:txBody>
+          <a:bodyPr spcFirstLastPara="1" wrap="square" lIns="91425" tIns="91425" rIns="91425" bIns="91425" anchor="t" anchorCtr="0">
+            <a:noAutofit/>
+          </a:bodyPr>
+          <a:lstStyle/>
+          <a:p>
+            <a:pPr marL="0" lvl="0" indent="0" algn="l" rtl="0">
+              <a:spcBef>
+                <a:spcPts val="0"/>
+              </a:spcBef>
+              <a:spcAft>
+                <a:spcPts val="0"/>
+              </a:spcAft>
+              <a:buNone/>
+            </a:pPr>
+            <a:endParaRPr dirty="0"/>
+          </a:p>
+        </p:txBody>
+      </p:sp>
+      <p:sp>
+        <p:nvSpPr>
+          <p:cNvPr id="138" name="Google Shape;138;p5:notes">
+            <a:extLst>
+              <a:ext uri="{FF2B5EF4-FFF2-40B4-BE49-F238E27FC236}">
+                <a16:creationId xmlns:a16="http://schemas.microsoft.com/office/drawing/2014/main" id="{290747B7-16A5-C89F-60C4-B0FF6670EAAD}"/>
+              </a:ext>
+            </a:extLst>
+          </p:cNvPr>
+          <p:cNvSpPr>
+            <a:spLocks noGrp="1" noRot="1" noChangeAspect="1"/>
+          </p:cNvSpPr>
+          <p:nvPr>
+            <p:ph type="sldImg" idx="2"/>
+          </p:nvPr>
+        </p:nvSpPr>
+        <p:spPr>
+          <a:xfrm>
+            <a:off x="381000" y="685800"/>
+            <a:ext cx="6096000" cy="3429000"/>
+          </a:xfrm>
+          <a:custGeom>
+            <a:avLst/>
+            <a:gdLst/>
+            <a:ahLst/>
+            <a:cxnLst/>
+            <a:rect l="l" t="t" r="r" b="b"/>
+            <a:pathLst>
+              <a:path w="120000" h="120000" extrusionOk="0">
+                <a:moveTo>
+                  <a:pt x="0" y="0"/>
+                </a:moveTo>
+                <a:lnTo>
+                  <a:pt x="120000" y="0"/>
+                </a:lnTo>
+                <a:lnTo>
+                  <a:pt x="120000" y="120000"/>
+                </a:lnTo>
+                <a:lnTo>
+                  <a:pt x="0" y="120000"/>
+                </a:lnTo>
+                <a:close/>
+              </a:path>
+            </a:pathLst>
+          </a:custGeom>
+        </p:spPr>
+      </p:sp>
+    </p:spTree>
+    <p:extLst>
+      <p:ext uri="{BB962C8B-B14F-4D97-AF65-F5344CB8AC3E}">
+        <p14:creationId xmlns:p14="http://schemas.microsoft.com/office/powerpoint/2010/main" val="142371176"/>
       </p:ext>
     </p:extLst>
   </p:cSld>
@@ -2262,6 +2553,133 @@
         <p:cNvPr id="1" name="Shape 136">
           <a:extLst>
             <a:ext uri="{FF2B5EF4-FFF2-40B4-BE49-F238E27FC236}">
+              <a16:creationId xmlns:a16="http://schemas.microsoft.com/office/drawing/2014/main" id="{C346BDD1-FCAE-9BAA-D7B4-FEAACD391DB2}"/>
+            </a:ext>
+          </a:extLst>
+        </p:cNvPr>
+        <p:cNvGrpSpPr/>
+        <p:nvPr/>
+      </p:nvGrpSpPr>
+      <p:grpSpPr>
+        <a:xfrm>
+          <a:off x="0" y="0"/>
+          <a:ext cx="0" cy="0"/>
+          <a:chOff x="0" y="0"/>
+          <a:chExt cx="0" cy="0"/>
+        </a:xfrm>
+      </p:grpSpPr>
+      <p:sp>
+        <p:nvSpPr>
+          <p:cNvPr id="137" name="Google Shape;137;p5:notes">
+            <a:extLst>
+              <a:ext uri="{FF2B5EF4-FFF2-40B4-BE49-F238E27FC236}">
+                <a16:creationId xmlns:a16="http://schemas.microsoft.com/office/drawing/2014/main" id="{ED753F9D-C11D-C5DB-E783-51BF278293A9}"/>
+              </a:ext>
+            </a:extLst>
+          </p:cNvPr>
+          <p:cNvSpPr txBox="1">
+            <a:spLocks noGrp="1"/>
+          </p:cNvSpPr>
+          <p:nvPr>
+            <p:ph type="body" idx="1"/>
+          </p:nvPr>
+        </p:nvSpPr>
+        <p:spPr>
+          <a:xfrm>
+            <a:off x="685800" y="4343400"/>
+            <a:ext cx="5486400" cy="4114800"/>
+          </a:xfrm>
+          <a:prstGeom prst="rect">
+            <a:avLst/>
+          </a:prstGeom>
+        </p:spPr>
+        <p:txBody>
+          <a:bodyPr spcFirstLastPara="1" wrap="square" lIns="91425" tIns="91425" rIns="91425" bIns="91425" anchor="t" anchorCtr="0">
+            <a:noAutofit/>
+          </a:bodyPr>
+          <a:lstStyle/>
+          <a:p>
+            <a:pPr marL="0" lvl="0" indent="0" algn="l" rtl="0">
+              <a:spcBef>
+                <a:spcPts val="0"/>
+              </a:spcBef>
+              <a:spcAft>
+                <a:spcPts val="0"/>
+              </a:spcAft>
+              <a:buNone/>
+            </a:pPr>
+            <a:endParaRPr dirty="0"/>
+          </a:p>
+        </p:txBody>
+      </p:sp>
+      <p:sp>
+        <p:nvSpPr>
+          <p:cNvPr id="138" name="Google Shape;138;p5:notes">
+            <a:extLst>
+              <a:ext uri="{FF2B5EF4-FFF2-40B4-BE49-F238E27FC236}">
+                <a16:creationId xmlns:a16="http://schemas.microsoft.com/office/drawing/2014/main" id="{7B9BD3CB-6FEC-A81D-D8B6-735A250B469D}"/>
+              </a:ext>
+            </a:extLst>
+          </p:cNvPr>
+          <p:cNvSpPr>
+            <a:spLocks noGrp="1" noRot="1" noChangeAspect="1"/>
+          </p:cNvSpPr>
+          <p:nvPr>
+            <p:ph type="sldImg" idx="2"/>
+          </p:nvPr>
+        </p:nvSpPr>
+        <p:spPr>
+          <a:xfrm>
+            <a:off x="381000" y="685800"/>
+            <a:ext cx="6096000" cy="3429000"/>
+          </a:xfrm>
+          <a:custGeom>
+            <a:avLst/>
+            <a:gdLst/>
+            <a:ahLst/>
+            <a:cxnLst/>
+            <a:rect l="l" t="t" r="r" b="b"/>
+            <a:pathLst>
+              <a:path w="120000" h="120000" extrusionOk="0">
+                <a:moveTo>
+                  <a:pt x="0" y="0"/>
+                </a:moveTo>
+                <a:lnTo>
+                  <a:pt x="120000" y="0"/>
+                </a:lnTo>
+                <a:lnTo>
+                  <a:pt x="120000" y="120000"/>
+                </a:lnTo>
+                <a:lnTo>
+                  <a:pt x="0" y="120000"/>
+                </a:lnTo>
+                <a:close/>
+              </a:path>
+            </a:pathLst>
+          </a:custGeom>
+        </p:spPr>
+      </p:sp>
+    </p:spTree>
+    <p:extLst>
+      <p:ext uri="{BB962C8B-B14F-4D97-AF65-F5344CB8AC3E}">
+        <p14:creationId xmlns:p14="http://schemas.microsoft.com/office/powerpoint/2010/main" val="3892978200"/>
+      </p:ext>
+    </p:extLst>
+  </p:cSld>
+  <p:clrMapOvr>
+    <a:masterClrMapping/>
+  </p:clrMapOvr>
+</p:notes>
+</file>
+
+<file path=ppt/notesSlides/notesSlide5.xml><?xml version="1.0" encoding="utf-8"?>
+<p:notes xmlns:a="http://schemas.openxmlformats.org/drawingml/2006/main" xmlns:r="http://schemas.openxmlformats.org/officeDocument/2006/relationships" xmlns:p="http://schemas.openxmlformats.org/presentationml/2006/main" showMasterSp="0" showMasterPhAnim="0">
+  <p:cSld>
+    <p:spTree>
+      <p:nvGrpSpPr>
+        <p:cNvPr id="1" name="Shape 136">
+          <a:extLst>
+            <a:ext uri="{FF2B5EF4-FFF2-40B4-BE49-F238E27FC236}">
               <a16:creationId xmlns:a16="http://schemas.microsoft.com/office/drawing/2014/main" id="{F87D20C0-3F7E-DD26-A611-CB26FCE0E4E8}"/>
             </a:ext>
           </a:extLst>
@@ -2381,7 +2799,7 @@
 </p:notes>
 </file>
 
-<file path=ppt/notesSlides/notesSlide5.xml><?xml version="1.0" encoding="utf-8"?>
+<file path=ppt/notesSlides/notesSlide6.xml><?xml version="1.0" encoding="utf-8"?>
 <p:notes xmlns:a="http://schemas.openxmlformats.org/drawingml/2006/main" xmlns:r="http://schemas.openxmlformats.org/officeDocument/2006/relationships" xmlns:p="http://schemas.openxmlformats.org/presentationml/2006/main" showMasterSp="0" showMasterPhAnim="0">
   <p:cSld>
     <p:spTree>
@@ -2508,7 +2926,7 @@
 </p:notes>
 </file>
 
-<file path=ppt/notesSlides/notesSlide6.xml><?xml version="1.0" encoding="utf-8"?>
+<file path=ppt/notesSlides/notesSlide7.xml><?xml version="1.0" encoding="utf-8"?>
 <p:notes xmlns:a="http://schemas.openxmlformats.org/drawingml/2006/main" xmlns:r="http://schemas.openxmlformats.org/officeDocument/2006/relationships" xmlns:p="http://schemas.openxmlformats.org/presentationml/2006/main" showMasterSp="0" showMasterPhAnim="0">
   <p:cSld>
     <p:spTree>
@@ -2635,7 +3053,7 @@
 </p:notes>
 </file>
 
-<file path=ppt/notesSlides/notesSlide7.xml><?xml version="1.0" encoding="utf-8"?>
+<file path=ppt/notesSlides/notesSlide8.xml><?xml version="1.0" encoding="utf-8"?>
 <p:notes xmlns:a="http://schemas.openxmlformats.org/drawingml/2006/main" xmlns:r="http://schemas.openxmlformats.org/officeDocument/2006/relationships" xmlns:p="http://schemas.openxmlformats.org/presentationml/2006/main" showMasterSp="0" showMasterPhAnim="0">
   <p:cSld>
     <p:spTree>
@@ -2781,7 +3199,7 @@
 </p:notes>
 </file>
 
-<file path=ppt/notesSlides/notesSlide8.xml><?xml version="1.0" encoding="utf-8"?>
+<file path=ppt/notesSlides/notesSlide9.xml><?xml version="1.0" encoding="utf-8"?>
 <p:notes xmlns:a="http://schemas.openxmlformats.org/drawingml/2006/main" xmlns:r="http://schemas.openxmlformats.org/officeDocument/2006/relationships" xmlns:p="http://schemas.openxmlformats.org/presentationml/2006/main" showMasterSp="0" showMasterPhAnim="0">
   <p:cSld>
     <p:spTree>
@@ -2918,152 +3336,6 @@
     <p:extLst>
       <p:ext uri="{BB962C8B-B14F-4D97-AF65-F5344CB8AC3E}">
         <p14:creationId xmlns:p14="http://schemas.microsoft.com/office/powerpoint/2010/main" val="2379007290"/>
-      </p:ext>
-    </p:extLst>
-  </p:cSld>
-  <p:clrMapOvr>
-    <a:masterClrMapping/>
-  </p:clrMapOvr>
-</p:notes>
-</file>
-
-<file path=ppt/notesSlides/notesSlide9.xml><?xml version="1.0" encoding="utf-8"?>
-<p:notes xmlns:a="http://schemas.openxmlformats.org/drawingml/2006/main" xmlns:r="http://schemas.openxmlformats.org/officeDocument/2006/relationships" xmlns:p="http://schemas.openxmlformats.org/presentationml/2006/main" showMasterSp="0" showMasterPhAnim="0">
-  <p:cSld>
-    <p:spTree>
-      <p:nvGrpSpPr>
-        <p:cNvPr id="1" name="Shape 399">
-          <a:extLst>
-            <a:ext uri="{FF2B5EF4-FFF2-40B4-BE49-F238E27FC236}">
-              <a16:creationId xmlns:a16="http://schemas.microsoft.com/office/drawing/2014/main" id="{0F7086A5-A86A-C9CF-5D0E-EFF43A4E8E47}"/>
-            </a:ext>
-          </a:extLst>
-        </p:cNvPr>
-        <p:cNvGrpSpPr/>
-        <p:nvPr/>
-      </p:nvGrpSpPr>
-      <p:grpSpPr>
-        <a:xfrm>
-          <a:off x="0" y="0"/>
-          <a:ext cx="0" cy="0"/>
-          <a:chOff x="0" y="0"/>
-          <a:chExt cx="0" cy="0"/>
-        </a:xfrm>
-      </p:grpSpPr>
-      <p:sp>
-        <p:nvSpPr>
-          <p:cNvPr id="400" name="Google Shape;400;g3b4aedc2736_1_104:notes">
-            <a:extLst>
-              <a:ext uri="{FF2B5EF4-FFF2-40B4-BE49-F238E27FC236}">
-                <a16:creationId xmlns:a16="http://schemas.microsoft.com/office/drawing/2014/main" id="{7E4C12AA-A7C9-ECC0-C304-F5B05BE903AA}"/>
-              </a:ext>
-            </a:extLst>
-          </p:cNvPr>
-          <p:cNvSpPr txBox="1">
-            <a:spLocks noGrp="1"/>
-          </p:cNvSpPr>
-          <p:nvPr>
-            <p:ph type="body" idx="1"/>
-          </p:nvPr>
-        </p:nvSpPr>
-        <p:spPr>
-          <a:xfrm>
-            <a:off x="685800" y="4343400"/>
-            <a:ext cx="5486400" cy="4114800"/>
-          </a:xfrm>
-          <a:prstGeom prst="rect">
-            <a:avLst/>
-          </a:prstGeom>
-          <a:noFill/>
-          <a:ln>
-            <a:noFill/>
-          </a:ln>
-        </p:spPr>
-        <p:txBody>
-          <a:bodyPr spcFirstLastPara="1" wrap="square" lIns="91425" tIns="91425" rIns="91425" bIns="91425" anchor="t" anchorCtr="0">
-            <a:noAutofit/>
-          </a:bodyPr>
-          <a:lstStyle/>
-          <a:p>
-            <a:pPr marL="0" lvl="0" indent="0" algn="l" rtl="0">
-              <a:spcBef>
-                <a:spcPts val="0"/>
-              </a:spcBef>
-              <a:spcAft>
-                <a:spcPts val="0"/>
-              </a:spcAft>
-              <a:buClr>
-                <a:schemeClr val="dk1"/>
-              </a:buClr>
-              <a:buSzPts val="1200"/>
-              <a:buFont typeface="Arial"/>
-              <a:buNone/>
-            </a:pPr>
-            <a:endParaRPr/>
-          </a:p>
-        </p:txBody>
-      </p:sp>
-      <p:sp>
-        <p:nvSpPr>
-          <p:cNvPr id="401" name="Google Shape;401;g3b4aedc2736_1_104:notes">
-            <a:extLst>
-              <a:ext uri="{FF2B5EF4-FFF2-40B4-BE49-F238E27FC236}">
-                <a16:creationId xmlns:a16="http://schemas.microsoft.com/office/drawing/2014/main" id="{73A9895A-2001-B9C0-94BE-EA02E6648583}"/>
-              </a:ext>
-            </a:extLst>
-          </p:cNvPr>
-          <p:cNvSpPr>
-            <a:spLocks noGrp="1" noRot="1" noChangeAspect="1"/>
-          </p:cNvSpPr>
-          <p:nvPr>
-            <p:ph type="sldImg" idx="2"/>
-          </p:nvPr>
-        </p:nvSpPr>
-        <p:spPr>
-          <a:xfrm>
-            <a:off x="381000" y="685800"/>
-            <a:ext cx="6096000" cy="3429000"/>
-          </a:xfrm>
-          <a:custGeom>
-            <a:avLst/>
-            <a:gdLst/>
-            <a:ahLst/>
-            <a:cxnLst/>
-            <a:rect l="l" t="t" r="r" b="b"/>
-            <a:pathLst>
-              <a:path w="120000" h="120000" extrusionOk="0">
-                <a:moveTo>
-                  <a:pt x="0" y="0"/>
-                </a:moveTo>
-                <a:lnTo>
-                  <a:pt x="120000" y="0"/>
-                </a:lnTo>
-                <a:lnTo>
-                  <a:pt x="120000" y="120000"/>
-                </a:lnTo>
-                <a:lnTo>
-                  <a:pt x="0" y="120000"/>
-                </a:lnTo>
-                <a:close/>
-              </a:path>
-            </a:pathLst>
-          </a:custGeom>
-          <a:noFill/>
-          <a:ln w="12700" cap="flat" cmpd="sng">
-            <a:solidFill>
-              <a:srgbClr val="000000"/>
-            </a:solidFill>
-            <a:prstDash val="solid"/>
-            <a:round/>
-            <a:headEnd type="none" w="sm" len="sm"/>
-            <a:tailEnd type="none" w="sm" len="sm"/>
-          </a:ln>
-        </p:spPr>
-      </p:sp>
-    </p:spTree>
-    <p:extLst>
-      <p:ext uri="{BB962C8B-B14F-4D97-AF65-F5344CB8AC3E}">
-        <p14:creationId xmlns:p14="http://schemas.microsoft.com/office/powerpoint/2010/main" val="3925003050"/>
       </p:ext>
     </p:extLst>
   </p:cSld>
@@ -11234,6 +11506,372 @@
         <p:cNvPr id="1" name="Shape 402">
           <a:extLst>
             <a:ext uri="{FF2B5EF4-FFF2-40B4-BE49-F238E27FC236}">
+              <a16:creationId xmlns:a16="http://schemas.microsoft.com/office/drawing/2014/main" id="{D19B995F-4F11-003F-071B-0101898D8F3E}"/>
+            </a:ext>
+          </a:extLst>
+        </p:cNvPr>
+        <p:cNvGrpSpPr/>
+        <p:nvPr/>
+      </p:nvGrpSpPr>
+      <p:grpSpPr>
+        <a:xfrm>
+          <a:off x="0" y="0"/>
+          <a:ext cx="0" cy="0"/>
+          <a:chOff x="0" y="0"/>
+          <a:chExt cx="0" cy="0"/>
+        </a:xfrm>
+      </p:grpSpPr>
+      <p:sp>
+        <p:nvSpPr>
+          <p:cNvPr id="403" name="Google Shape;403;p77">
+            <a:extLst>
+              <a:ext uri="{FF2B5EF4-FFF2-40B4-BE49-F238E27FC236}">
+                <a16:creationId xmlns:a16="http://schemas.microsoft.com/office/drawing/2014/main" id="{BBBB5F37-0696-8B6F-E525-4BC94DE9A0ED}"/>
+              </a:ext>
+            </a:extLst>
+          </p:cNvPr>
+          <p:cNvSpPr txBox="1"/>
+          <p:nvPr/>
+        </p:nvSpPr>
+        <p:spPr>
+          <a:xfrm>
+            <a:off x="922201" y="1157695"/>
+            <a:ext cx="6097600" cy="746936"/>
+          </a:xfrm>
+          <a:prstGeom prst="rect">
+            <a:avLst/>
+          </a:prstGeom>
+          <a:noFill/>
+          <a:ln>
+            <a:noFill/>
+          </a:ln>
+        </p:spPr>
+        <p:txBody>
+          <a:bodyPr spcFirstLastPara="1" wrap="square" lIns="0" tIns="0" rIns="0" bIns="0" anchor="t" anchorCtr="0">
+            <a:spAutoFit/>
+          </a:bodyPr>
+          <a:lstStyle/>
+          <a:p>
+            <a:pPr>
+              <a:lnSpc>
+                <a:spcPct val="140007"/>
+              </a:lnSpc>
+            </a:pPr>
+            <a:r>
+              <a:rPr lang="en-US" sz="3467" dirty="0">
+                <a:solidFill>
+                  <a:srgbClr val="00693D"/>
+                </a:solidFill>
+                <a:latin typeface="Anton"/>
+                <a:ea typeface="Anton"/>
+                <a:cs typeface="Anton"/>
+                <a:sym typeface="Anton"/>
+              </a:rPr>
+              <a:t>Project organization</a:t>
+            </a:r>
+            <a:endParaRPr sz="933" dirty="0">
+              <a:solidFill>
+                <a:srgbClr val="000000"/>
+              </a:solidFill>
+              <a:latin typeface="Anton"/>
+              <a:ea typeface="Anton"/>
+              <a:cs typeface="Anton"/>
+              <a:sym typeface="Anton"/>
+            </a:endParaRPr>
+          </a:p>
+        </p:txBody>
+      </p:sp>
+      <p:sp>
+        <p:nvSpPr>
+          <p:cNvPr id="404" name="Google Shape;404;p77">
+            <a:extLst>
+              <a:ext uri="{FF2B5EF4-FFF2-40B4-BE49-F238E27FC236}">
+                <a16:creationId xmlns:a16="http://schemas.microsoft.com/office/drawing/2014/main" id="{5C4BE77C-871F-04F9-5530-4C4BCEF146E7}"/>
+              </a:ext>
+            </a:extLst>
+          </p:cNvPr>
+          <p:cNvSpPr txBox="1"/>
+          <p:nvPr/>
+        </p:nvSpPr>
+        <p:spPr>
+          <a:xfrm>
+            <a:off x="880492" y="1904631"/>
+            <a:ext cx="9776400" cy="4832349"/>
+          </a:xfrm>
+          <a:prstGeom prst="rect">
+            <a:avLst/>
+          </a:prstGeom>
+          <a:noFill/>
+          <a:ln>
+            <a:noFill/>
+          </a:ln>
+        </p:spPr>
+        <p:txBody>
+          <a:bodyPr spcFirstLastPara="1" wrap="square" lIns="0" tIns="0" rIns="0" bIns="0" anchor="t" anchorCtr="0">
+            <a:spAutoFit/>
+          </a:bodyPr>
+          <a:lstStyle/>
+          <a:p>
+            <a:pPr marL="609585">
+              <a:lnSpc>
+                <a:spcPct val="140013"/>
+              </a:lnSpc>
+            </a:pPr>
+            <a:endParaRPr sz="2400" dirty="0">
+              <a:solidFill>
+                <a:srgbClr val="12312B"/>
+              </a:solidFill>
+              <a:latin typeface="Archivo Medium"/>
+              <a:ea typeface="Archivo Medium"/>
+              <a:cs typeface="Archivo Medium"/>
+              <a:sym typeface="Archivo Medium"/>
+            </a:endParaRPr>
+          </a:p>
+          <a:p>
+            <a:pPr marL="433260" lvl="1" indent="-216630" defTabSz="609630">
+              <a:lnSpc>
+                <a:spcPct val="140013"/>
+              </a:lnSpc>
+              <a:buClr>
+                <a:srgbClr val="12312B"/>
+              </a:buClr>
+              <a:buSzPts val="3009"/>
+              <a:buFont typeface="Archivo Medium"/>
+              <a:buChar char="•"/>
+            </a:pPr>
+            <a:r>
+              <a:rPr lang="en-US" sz="2006" kern="0" dirty="0">
+                <a:solidFill>
+                  <a:srgbClr val="12312B"/>
+                </a:solidFill>
+                <a:latin typeface="Archivo Medium"/>
+                <a:cs typeface="Archivo Medium"/>
+                <a:sym typeface="Archivo Medium"/>
+              </a:rPr>
+              <a:t>One folder, one project – store all files for a project in one well-organized folder, with subfolders for</a:t>
+            </a:r>
+          </a:p>
+          <a:p>
+            <a:pPr marL="866521" lvl="2" indent="-288840" defTabSz="609630">
+              <a:lnSpc>
+                <a:spcPct val="140013"/>
+              </a:lnSpc>
+              <a:buClr>
+                <a:srgbClr val="12312B"/>
+              </a:buClr>
+              <a:buSzPts val="3009"/>
+              <a:buFont typeface="Archivo Medium"/>
+              <a:buChar char="⚬"/>
+            </a:pPr>
+            <a:r>
+              <a:rPr lang="en-US" sz="1600" dirty="0">
+                <a:latin typeface="Archivo Medium"/>
+                <a:sym typeface="Archivo Medium"/>
+              </a:rPr>
+              <a:t>Documents (docs)</a:t>
+            </a:r>
+          </a:p>
+          <a:p>
+            <a:pPr marL="866521" lvl="2" indent="-288840" defTabSz="609630">
+              <a:lnSpc>
+                <a:spcPct val="140013"/>
+              </a:lnSpc>
+              <a:buClr>
+                <a:srgbClr val="12312B"/>
+              </a:buClr>
+              <a:buSzPts val="3009"/>
+              <a:buFont typeface="Archivo Medium"/>
+              <a:buChar char="⚬"/>
+            </a:pPr>
+            <a:r>
+              <a:rPr lang="en-US" sz="1600" dirty="0">
+                <a:latin typeface="Archivo Medium"/>
+                <a:sym typeface="Archivo Medium"/>
+              </a:rPr>
+              <a:t>Data</a:t>
+            </a:r>
+          </a:p>
+          <a:p>
+            <a:pPr marL="866521" lvl="2" indent="-288840" defTabSz="609630">
+              <a:lnSpc>
+                <a:spcPct val="140013"/>
+              </a:lnSpc>
+              <a:buClr>
+                <a:srgbClr val="12312B"/>
+              </a:buClr>
+              <a:buSzPts val="3009"/>
+              <a:buFont typeface="Archivo Medium"/>
+              <a:buChar char="⚬"/>
+            </a:pPr>
+            <a:r>
+              <a:rPr lang="en-US" sz="1600" dirty="0">
+                <a:latin typeface="Archivo Medium"/>
+                <a:sym typeface="Archivo Medium"/>
+              </a:rPr>
+              <a:t>Code</a:t>
+            </a:r>
+          </a:p>
+          <a:p>
+            <a:pPr marL="866521" lvl="2" indent="-288840" defTabSz="609630">
+              <a:lnSpc>
+                <a:spcPct val="140013"/>
+              </a:lnSpc>
+              <a:buClr>
+                <a:srgbClr val="12312B"/>
+              </a:buClr>
+              <a:buSzPts val="3009"/>
+              <a:buFont typeface="Archivo Medium"/>
+              <a:buChar char="⚬"/>
+            </a:pPr>
+            <a:r>
+              <a:rPr lang="en-US" sz="1600" dirty="0">
+                <a:latin typeface="Archivo Medium"/>
+                <a:sym typeface="Archivo Medium"/>
+              </a:rPr>
+              <a:t>Output</a:t>
+            </a:r>
+          </a:p>
+          <a:p>
+            <a:pPr marL="866521" lvl="2" indent="-288840" defTabSz="609630">
+              <a:lnSpc>
+                <a:spcPct val="140013"/>
+              </a:lnSpc>
+              <a:buClr>
+                <a:srgbClr val="12312B"/>
+              </a:buClr>
+              <a:buSzPts val="3009"/>
+              <a:buFont typeface="Archivo Medium"/>
+              <a:buChar char="⚬"/>
+            </a:pPr>
+            <a:r>
+              <a:rPr lang="en-US" sz="1600" dirty="0">
+                <a:latin typeface="Archivo Medium"/>
+                <a:sym typeface="Archivo Medium"/>
+              </a:rPr>
+              <a:t>Others as needed</a:t>
+            </a:r>
+            <a:endParaRPr lang="en-US" sz="2006" kern="0" dirty="0">
+              <a:solidFill>
+                <a:srgbClr val="12312B"/>
+              </a:solidFill>
+              <a:latin typeface="Archivo Medium"/>
+              <a:cs typeface="Archivo Medium"/>
+              <a:sym typeface="Archivo Medium"/>
+            </a:endParaRPr>
+          </a:p>
+          <a:p>
+            <a:pPr marL="433260" lvl="1" indent="-216630" defTabSz="609630">
+              <a:lnSpc>
+                <a:spcPct val="140013"/>
+              </a:lnSpc>
+              <a:buClr>
+                <a:srgbClr val="12312B"/>
+              </a:buClr>
+              <a:buSzPts val="3009"/>
+              <a:buFont typeface="Archivo Medium"/>
+              <a:buChar char="•"/>
+            </a:pPr>
+            <a:endParaRPr lang="en-US" sz="2006" kern="0" dirty="0">
+              <a:solidFill>
+                <a:srgbClr val="12312B"/>
+              </a:solidFill>
+              <a:latin typeface="Archivo Medium"/>
+              <a:cs typeface="Archivo Medium"/>
+              <a:sym typeface="Archivo Medium"/>
+            </a:endParaRPr>
+          </a:p>
+          <a:p>
+            <a:pPr marL="433260" lvl="1" indent="-216630" defTabSz="609630">
+              <a:lnSpc>
+                <a:spcPct val="140013"/>
+              </a:lnSpc>
+              <a:buClr>
+                <a:srgbClr val="12312B"/>
+              </a:buClr>
+              <a:buSzPts val="3009"/>
+              <a:buFont typeface="Archivo Medium"/>
+              <a:buChar char="•"/>
+            </a:pPr>
+            <a:r>
+              <a:rPr lang="en-US" sz="2006" kern="0" dirty="0">
+                <a:solidFill>
+                  <a:srgbClr val="12312B"/>
+                </a:solidFill>
+                <a:latin typeface="Archivo Medium"/>
+                <a:cs typeface="Archivo Medium"/>
+                <a:sym typeface="Archivo Medium"/>
+              </a:rPr>
+              <a:t>The materials for this workshop series are organized this way and are available here: </a:t>
+            </a:r>
+            <a:r>
+              <a:rPr lang="en-US" sz="2006" kern="0" dirty="0">
+                <a:solidFill>
+                  <a:srgbClr val="12312B"/>
+                </a:solidFill>
+                <a:highlight>
+                  <a:srgbClr val="FFFF00"/>
+                </a:highlight>
+                <a:latin typeface="Archivo Medium"/>
+                <a:cs typeface="Archivo Medium"/>
+                <a:sym typeface="Archivo Medium"/>
+                <a:hlinkClick r:id="rId3"/>
+              </a:rPr>
+              <a:t>https://dartgo.org/r-projects</a:t>
+            </a:r>
+            <a:r>
+              <a:rPr lang="en-US" sz="2006" kern="0" dirty="0">
+                <a:solidFill>
+                  <a:srgbClr val="12312B"/>
+                </a:solidFill>
+                <a:highlight>
+                  <a:srgbClr val="FFFF00"/>
+                </a:highlight>
+                <a:latin typeface="Archivo Medium"/>
+                <a:cs typeface="Archivo Medium"/>
+                <a:sym typeface="Archivo Medium"/>
+              </a:rPr>
+              <a:t> </a:t>
+            </a:r>
+          </a:p>
+          <a:p>
+            <a:pPr>
+              <a:lnSpc>
+                <a:spcPct val="140013"/>
+              </a:lnSpc>
+            </a:pPr>
+            <a:endParaRPr sz="2000" dirty="0">
+              <a:solidFill>
+                <a:srgbClr val="12312B"/>
+              </a:solidFill>
+              <a:latin typeface="Arial"/>
+              <a:ea typeface="Arial"/>
+              <a:cs typeface="Arial"/>
+              <a:sym typeface="Arial"/>
+            </a:endParaRPr>
+          </a:p>
+        </p:txBody>
+      </p:sp>
+    </p:spTree>
+    <p:extLst>
+      <p:ext uri="{BB962C8B-B14F-4D97-AF65-F5344CB8AC3E}">
+        <p14:creationId xmlns:p14="http://schemas.microsoft.com/office/powerpoint/2010/main" val="253628221"/>
+      </p:ext>
+    </p:extLst>
+  </p:cSld>
+  <p:clrMapOvr>
+    <a:masterClrMapping/>
+  </p:clrMapOvr>
+</p:sld>
+</file>
+
+<file path=ppt/slides/slide11.xml><?xml version="1.0" encoding="utf-8"?>
+<p:sld xmlns:a="http://schemas.openxmlformats.org/drawingml/2006/main" xmlns:r="http://schemas.openxmlformats.org/officeDocument/2006/relationships" xmlns:p="http://schemas.openxmlformats.org/presentationml/2006/main">
+  <p:cSld>
+    <p:spTree>
+      <p:nvGrpSpPr>
+        <p:cNvPr id="1" name="Shape 402">
+          <a:extLst>
+            <a:ext uri="{FF2B5EF4-FFF2-40B4-BE49-F238E27FC236}">
               <a16:creationId xmlns:a16="http://schemas.microsoft.com/office/drawing/2014/main" id="{E30A3F55-1856-49CB-AF28-4110546CFCEA}"/>
             </a:ext>
           </a:extLst>
@@ -11466,290 +12104,6 @@
     <p:extLst>
       <p:ext uri="{BB962C8B-B14F-4D97-AF65-F5344CB8AC3E}">
         <p14:creationId xmlns:p14="http://schemas.microsoft.com/office/powerpoint/2010/main" val="115751723"/>
-      </p:ext>
-    </p:extLst>
-  </p:cSld>
-  <p:clrMapOvr>
-    <a:masterClrMapping/>
-  </p:clrMapOvr>
-</p:sld>
-</file>
-
-<file path=ppt/slides/slide11.xml><?xml version="1.0" encoding="utf-8"?>
-<p:sld xmlns:a="http://schemas.openxmlformats.org/drawingml/2006/main" xmlns:r="http://schemas.openxmlformats.org/officeDocument/2006/relationships" xmlns:p="http://schemas.openxmlformats.org/presentationml/2006/main">
-  <p:cSld>
-    <p:spTree>
-      <p:nvGrpSpPr>
-        <p:cNvPr id="1" name="Shape 402">
-          <a:extLst>
-            <a:ext uri="{FF2B5EF4-FFF2-40B4-BE49-F238E27FC236}">
-              <a16:creationId xmlns:a16="http://schemas.microsoft.com/office/drawing/2014/main" id="{17492F1C-6C41-2C7D-69A8-6133416D96BF}"/>
-            </a:ext>
-          </a:extLst>
-        </p:cNvPr>
-        <p:cNvGrpSpPr/>
-        <p:nvPr/>
-      </p:nvGrpSpPr>
-      <p:grpSpPr>
-        <a:xfrm>
-          <a:off x="0" y="0"/>
-          <a:ext cx="0" cy="0"/>
-          <a:chOff x="0" y="0"/>
-          <a:chExt cx="0" cy="0"/>
-        </a:xfrm>
-      </p:grpSpPr>
-      <p:sp>
-        <p:nvSpPr>
-          <p:cNvPr id="403" name="Google Shape;403;p77">
-            <a:extLst>
-              <a:ext uri="{FF2B5EF4-FFF2-40B4-BE49-F238E27FC236}">
-                <a16:creationId xmlns:a16="http://schemas.microsoft.com/office/drawing/2014/main" id="{2AAEA18C-4620-269A-348C-38807269B343}"/>
-              </a:ext>
-            </a:extLst>
-          </p:cNvPr>
-          <p:cNvSpPr txBox="1"/>
-          <p:nvPr/>
-        </p:nvSpPr>
-        <p:spPr>
-          <a:xfrm>
-            <a:off x="922201" y="1157695"/>
-            <a:ext cx="6097600" cy="746936"/>
-          </a:xfrm>
-          <a:prstGeom prst="rect">
-            <a:avLst/>
-          </a:prstGeom>
-          <a:noFill/>
-          <a:ln>
-            <a:noFill/>
-          </a:ln>
-        </p:spPr>
-        <p:txBody>
-          <a:bodyPr spcFirstLastPara="1" wrap="square" lIns="0" tIns="0" rIns="0" bIns="0" anchor="t" anchorCtr="0">
-            <a:spAutoFit/>
-          </a:bodyPr>
-          <a:lstStyle/>
-          <a:p>
-            <a:pPr>
-              <a:lnSpc>
-                <a:spcPct val="140007"/>
-              </a:lnSpc>
-            </a:pPr>
-            <a:r>
-              <a:rPr lang="en-US" sz="3467" dirty="0">
-                <a:solidFill>
-                  <a:srgbClr val="00693D"/>
-                </a:solidFill>
-                <a:latin typeface="Anton"/>
-                <a:ea typeface="Anton"/>
-                <a:cs typeface="Anton"/>
-                <a:sym typeface="Anton"/>
-              </a:rPr>
-              <a:t>Loading Data</a:t>
-            </a:r>
-            <a:endParaRPr sz="933" dirty="0">
-              <a:solidFill>
-                <a:srgbClr val="000000"/>
-              </a:solidFill>
-              <a:latin typeface="Anton"/>
-              <a:ea typeface="Anton"/>
-              <a:cs typeface="Anton"/>
-              <a:sym typeface="Anton"/>
-            </a:endParaRPr>
-          </a:p>
-        </p:txBody>
-      </p:sp>
-      <p:sp>
-        <p:nvSpPr>
-          <p:cNvPr id="404" name="Google Shape;404;p77">
-            <a:extLst>
-              <a:ext uri="{FF2B5EF4-FFF2-40B4-BE49-F238E27FC236}">
-                <a16:creationId xmlns:a16="http://schemas.microsoft.com/office/drawing/2014/main" id="{CE1441DE-1E48-71E6-EE95-90FE965F0669}"/>
-              </a:ext>
-            </a:extLst>
-          </p:cNvPr>
-          <p:cNvSpPr txBox="1"/>
-          <p:nvPr/>
-        </p:nvSpPr>
-        <p:spPr>
-          <a:xfrm>
-            <a:off x="880492" y="1904631"/>
-            <a:ext cx="9776400" cy="2677913"/>
-          </a:xfrm>
-          <a:prstGeom prst="rect">
-            <a:avLst/>
-          </a:prstGeom>
-          <a:noFill/>
-          <a:ln>
-            <a:noFill/>
-          </a:ln>
-        </p:spPr>
-        <p:txBody>
-          <a:bodyPr spcFirstLastPara="1" wrap="square" lIns="0" tIns="0" rIns="0" bIns="0" anchor="t" anchorCtr="0">
-            <a:spAutoFit/>
-          </a:bodyPr>
-          <a:lstStyle/>
-          <a:p>
-            <a:pPr marL="609585">
-              <a:lnSpc>
-                <a:spcPct val="140013"/>
-              </a:lnSpc>
-            </a:pPr>
-            <a:endParaRPr sz="2400" dirty="0">
-              <a:solidFill>
-                <a:srgbClr val="12312B"/>
-              </a:solidFill>
-              <a:latin typeface="Archivo Medium"/>
-              <a:ea typeface="Archivo Medium"/>
-              <a:cs typeface="Archivo Medium"/>
-              <a:sym typeface="Archivo Medium"/>
-            </a:endParaRPr>
-          </a:p>
-          <a:p>
-            <a:pPr marL="433260" lvl="1" indent="-216630" defTabSz="609630">
-              <a:lnSpc>
-                <a:spcPct val="140013"/>
-              </a:lnSpc>
-              <a:buClr>
-                <a:srgbClr val="12312B"/>
-              </a:buClr>
-              <a:buSzPts val="3009"/>
-              <a:buFont typeface="Archivo Medium"/>
-              <a:buChar char="•"/>
-            </a:pPr>
-            <a:r>
-              <a:rPr lang="en-US" sz="2006" kern="0" dirty="0">
-                <a:solidFill>
-                  <a:srgbClr val="12312B"/>
-                </a:solidFill>
-                <a:latin typeface="Archivo Medium"/>
-                <a:cs typeface="Archivo Medium"/>
-                <a:sym typeface="Archivo Medium"/>
-              </a:rPr>
-              <a:t>The first step is to tell R where on your computer to look for the data</a:t>
-            </a:r>
-          </a:p>
-          <a:p>
-            <a:pPr marL="866521" lvl="2" indent="-288840" defTabSz="609630">
-              <a:lnSpc>
-                <a:spcPct val="140013"/>
-              </a:lnSpc>
-              <a:buClr>
-                <a:srgbClr val="12312B"/>
-              </a:buClr>
-              <a:buSzPts val="3009"/>
-              <a:buFont typeface="Archivo Medium"/>
-              <a:buChar char="⚬"/>
-            </a:pPr>
-            <a:r>
-              <a:rPr lang="en-US" dirty="0">
-                <a:latin typeface="Archivo Medium"/>
-                <a:sym typeface="Archivo Medium"/>
-              </a:rPr>
-              <a:t>The bad way: Set working directory using an absolute path</a:t>
-            </a:r>
-          </a:p>
-          <a:p>
-            <a:pPr marL="866521" lvl="2" indent="-288840" defTabSz="609630">
-              <a:lnSpc>
-                <a:spcPct val="140013"/>
-              </a:lnSpc>
-              <a:buClr>
-                <a:srgbClr val="12312B"/>
-              </a:buClr>
-              <a:buSzPts val="3009"/>
-              <a:buFont typeface="Archivo Medium"/>
-              <a:buChar char="⚬"/>
-            </a:pPr>
-            <a:r>
-              <a:rPr lang="en-US" dirty="0">
-                <a:latin typeface="Archivo Medium"/>
-                <a:sym typeface="Archivo Medium"/>
-              </a:rPr>
-              <a:t>The good way: Use the “here” package to specify a relative path</a:t>
-            </a:r>
-          </a:p>
-          <a:p>
-            <a:pPr marL="433260" lvl="1" indent="-216630" defTabSz="609630">
-              <a:lnSpc>
-                <a:spcPct val="140013"/>
-              </a:lnSpc>
-              <a:buClr>
-                <a:srgbClr val="12312B"/>
-              </a:buClr>
-              <a:buSzPts val="3009"/>
-              <a:buFont typeface="Archivo Medium"/>
-              <a:buChar char="•"/>
-            </a:pPr>
-            <a:endParaRPr lang="en-US" sz="2006" kern="0" dirty="0">
-              <a:solidFill>
-                <a:srgbClr val="12312B"/>
-              </a:solidFill>
-              <a:latin typeface="Archivo Medium"/>
-              <a:cs typeface="Archivo Medium"/>
-              <a:sym typeface="Archivo Medium"/>
-            </a:endParaRPr>
-          </a:p>
-          <a:p>
-            <a:pPr marL="433260" lvl="1" indent="-216630" defTabSz="609630">
-              <a:lnSpc>
-                <a:spcPct val="140013"/>
-              </a:lnSpc>
-              <a:buClr>
-                <a:srgbClr val="12312B"/>
-              </a:buClr>
-              <a:buSzPts val="3009"/>
-              <a:buFont typeface="Archivo Medium"/>
-              <a:buChar char="•"/>
-            </a:pPr>
-            <a:r>
-              <a:rPr lang="en-US" sz="2006" kern="0" dirty="0">
-                <a:solidFill>
-                  <a:srgbClr val="12312B"/>
-                </a:solidFill>
-                <a:latin typeface="Archivo Medium"/>
-                <a:cs typeface="Archivo Medium"/>
-                <a:sym typeface="Archivo Medium"/>
-              </a:rPr>
-              <a:t>Then you tell it how to read it using a function, like read.csv() or </a:t>
-            </a:r>
-            <a:r>
-              <a:rPr lang="en-US" sz="2006" kern="0" dirty="0" err="1">
-                <a:solidFill>
-                  <a:srgbClr val="12312B"/>
-                </a:solidFill>
-                <a:latin typeface="Archivo Medium"/>
-                <a:cs typeface="Archivo Medium"/>
-                <a:sym typeface="Archivo Medium"/>
-              </a:rPr>
-              <a:t>read_xlsx</a:t>
-            </a:r>
-            <a:r>
-              <a:rPr lang="en-US" sz="2006" kern="0" dirty="0">
-                <a:solidFill>
-                  <a:srgbClr val="12312B"/>
-                </a:solidFill>
-                <a:latin typeface="Archivo Medium"/>
-                <a:cs typeface="Archivo Medium"/>
-                <a:sym typeface="Archivo Medium"/>
-              </a:rPr>
-              <a:t>()</a:t>
-            </a:r>
-            <a:endParaRPr sz="2000" dirty="0">
-              <a:solidFill>
-                <a:srgbClr val="12312B"/>
-              </a:solidFill>
-              <a:latin typeface="Arial"/>
-              <a:ea typeface="Arial"/>
-              <a:cs typeface="Arial"/>
-              <a:sym typeface="Arial"/>
-            </a:endParaRPr>
-          </a:p>
-        </p:txBody>
-      </p:sp>
-    </p:spTree>
-    <p:extLst>
-      <p:ext uri="{BB962C8B-B14F-4D97-AF65-F5344CB8AC3E}">
-        <p14:creationId xmlns:p14="http://schemas.microsoft.com/office/powerpoint/2010/main" val="2386386992"/>
       </p:ext>
     </p:extLst>
   </p:cSld>
@@ -12722,6 +13076,290 @@
         <p:cNvPr id="1" name="Shape 402">
           <a:extLst>
             <a:ext uri="{FF2B5EF4-FFF2-40B4-BE49-F238E27FC236}">
+              <a16:creationId xmlns:a16="http://schemas.microsoft.com/office/drawing/2014/main" id="{17492F1C-6C41-2C7D-69A8-6133416D96BF}"/>
+            </a:ext>
+          </a:extLst>
+        </p:cNvPr>
+        <p:cNvGrpSpPr/>
+        <p:nvPr/>
+      </p:nvGrpSpPr>
+      <p:grpSpPr>
+        <a:xfrm>
+          <a:off x="0" y="0"/>
+          <a:ext cx="0" cy="0"/>
+          <a:chOff x="0" y="0"/>
+          <a:chExt cx="0" cy="0"/>
+        </a:xfrm>
+      </p:grpSpPr>
+      <p:sp>
+        <p:nvSpPr>
+          <p:cNvPr id="403" name="Google Shape;403;p77">
+            <a:extLst>
+              <a:ext uri="{FF2B5EF4-FFF2-40B4-BE49-F238E27FC236}">
+                <a16:creationId xmlns:a16="http://schemas.microsoft.com/office/drawing/2014/main" id="{2AAEA18C-4620-269A-348C-38807269B343}"/>
+              </a:ext>
+            </a:extLst>
+          </p:cNvPr>
+          <p:cNvSpPr txBox="1"/>
+          <p:nvPr/>
+        </p:nvSpPr>
+        <p:spPr>
+          <a:xfrm>
+            <a:off x="922201" y="1157695"/>
+            <a:ext cx="6097600" cy="746936"/>
+          </a:xfrm>
+          <a:prstGeom prst="rect">
+            <a:avLst/>
+          </a:prstGeom>
+          <a:noFill/>
+          <a:ln>
+            <a:noFill/>
+          </a:ln>
+        </p:spPr>
+        <p:txBody>
+          <a:bodyPr spcFirstLastPara="1" wrap="square" lIns="0" tIns="0" rIns="0" bIns="0" anchor="t" anchorCtr="0">
+            <a:spAutoFit/>
+          </a:bodyPr>
+          <a:lstStyle/>
+          <a:p>
+            <a:pPr>
+              <a:lnSpc>
+                <a:spcPct val="140007"/>
+              </a:lnSpc>
+            </a:pPr>
+            <a:r>
+              <a:rPr lang="en-US" sz="3467" dirty="0">
+                <a:solidFill>
+                  <a:srgbClr val="00693D"/>
+                </a:solidFill>
+                <a:latin typeface="Anton"/>
+                <a:ea typeface="Anton"/>
+                <a:cs typeface="Anton"/>
+                <a:sym typeface="Anton"/>
+              </a:rPr>
+              <a:t>Loading Data</a:t>
+            </a:r>
+            <a:endParaRPr sz="933" dirty="0">
+              <a:solidFill>
+                <a:srgbClr val="000000"/>
+              </a:solidFill>
+              <a:latin typeface="Anton"/>
+              <a:ea typeface="Anton"/>
+              <a:cs typeface="Anton"/>
+              <a:sym typeface="Anton"/>
+            </a:endParaRPr>
+          </a:p>
+        </p:txBody>
+      </p:sp>
+      <p:sp>
+        <p:nvSpPr>
+          <p:cNvPr id="404" name="Google Shape;404;p77">
+            <a:extLst>
+              <a:ext uri="{FF2B5EF4-FFF2-40B4-BE49-F238E27FC236}">
+                <a16:creationId xmlns:a16="http://schemas.microsoft.com/office/drawing/2014/main" id="{CE1441DE-1E48-71E6-EE95-90FE965F0669}"/>
+              </a:ext>
+            </a:extLst>
+          </p:cNvPr>
+          <p:cNvSpPr txBox="1"/>
+          <p:nvPr/>
+        </p:nvSpPr>
+        <p:spPr>
+          <a:xfrm>
+            <a:off x="880492" y="1904631"/>
+            <a:ext cx="9776400" cy="2677913"/>
+          </a:xfrm>
+          <a:prstGeom prst="rect">
+            <a:avLst/>
+          </a:prstGeom>
+          <a:noFill/>
+          <a:ln>
+            <a:noFill/>
+          </a:ln>
+        </p:spPr>
+        <p:txBody>
+          <a:bodyPr spcFirstLastPara="1" wrap="square" lIns="0" tIns="0" rIns="0" bIns="0" anchor="t" anchorCtr="0">
+            <a:spAutoFit/>
+          </a:bodyPr>
+          <a:lstStyle/>
+          <a:p>
+            <a:pPr marL="609585">
+              <a:lnSpc>
+                <a:spcPct val="140013"/>
+              </a:lnSpc>
+            </a:pPr>
+            <a:endParaRPr sz="2400" dirty="0">
+              <a:solidFill>
+                <a:srgbClr val="12312B"/>
+              </a:solidFill>
+              <a:latin typeface="Archivo Medium"/>
+              <a:ea typeface="Archivo Medium"/>
+              <a:cs typeface="Archivo Medium"/>
+              <a:sym typeface="Archivo Medium"/>
+            </a:endParaRPr>
+          </a:p>
+          <a:p>
+            <a:pPr marL="433260" lvl="1" indent="-216630" defTabSz="609630">
+              <a:lnSpc>
+                <a:spcPct val="140013"/>
+              </a:lnSpc>
+              <a:buClr>
+                <a:srgbClr val="12312B"/>
+              </a:buClr>
+              <a:buSzPts val="3009"/>
+              <a:buFont typeface="Archivo Medium"/>
+              <a:buChar char="•"/>
+            </a:pPr>
+            <a:r>
+              <a:rPr lang="en-US" sz="2006" kern="0" dirty="0">
+                <a:solidFill>
+                  <a:srgbClr val="12312B"/>
+                </a:solidFill>
+                <a:latin typeface="Archivo Medium"/>
+                <a:cs typeface="Archivo Medium"/>
+                <a:sym typeface="Archivo Medium"/>
+              </a:rPr>
+              <a:t>The first step is to tell R where on your computer to look for the data</a:t>
+            </a:r>
+          </a:p>
+          <a:p>
+            <a:pPr marL="866521" lvl="2" indent="-288840" defTabSz="609630">
+              <a:lnSpc>
+                <a:spcPct val="140013"/>
+              </a:lnSpc>
+              <a:buClr>
+                <a:srgbClr val="12312B"/>
+              </a:buClr>
+              <a:buSzPts val="3009"/>
+              <a:buFont typeface="Archivo Medium"/>
+              <a:buChar char="⚬"/>
+            </a:pPr>
+            <a:r>
+              <a:rPr lang="en-US" dirty="0">
+                <a:latin typeface="Archivo Medium"/>
+                <a:sym typeface="Archivo Medium"/>
+              </a:rPr>
+              <a:t>The bad way: Set working directory using an absolute path</a:t>
+            </a:r>
+          </a:p>
+          <a:p>
+            <a:pPr marL="866521" lvl="2" indent="-288840" defTabSz="609630">
+              <a:lnSpc>
+                <a:spcPct val="140013"/>
+              </a:lnSpc>
+              <a:buClr>
+                <a:srgbClr val="12312B"/>
+              </a:buClr>
+              <a:buSzPts val="3009"/>
+              <a:buFont typeface="Archivo Medium"/>
+              <a:buChar char="⚬"/>
+            </a:pPr>
+            <a:r>
+              <a:rPr lang="en-US" dirty="0">
+                <a:latin typeface="Archivo Medium"/>
+                <a:sym typeface="Archivo Medium"/>
+              </a:rPr>
+              <a:t>The good way: Use the “here” package to specify a relative path</a:t>
+            </a:r>
+          </a:p>
+          <a:p>
+            <a:pPr marL="433260" lvl="1" indent="-216630" defTabSz="609630">
+              <a:lnSpc>
+                <a:spcPct val="140013"/>
+              </a:lnSpc>
+              <a:buClr>
+                <a:srgbClr val="12312B"/>
+              </a:buClr>
+              <a:buSzPts val="3009"/>
+              <a:buFont typeface="Archivo Medium"/>
+              <a:buChar char="•"/>
+            </a:pPr>
+            <a:endParaRPr lang="en-US" sz="2006" kern="0" dirty="0">
+              <a:solidFill>
+                <a:srgbClr val="12312B"/>
+              </a:solidFill>
+              <a:latin typeface="Archivo Medium"/>
+              <a:cs typeface="Archivo Medium"/>
+              <a:sym typeface="Archivo Medium"/>
+            </a:endParaRPr>
+          </a:p>
+          <a:p>
+            <a:pPr marL="433260" lvl="1" indent="-216630" defTabSz="609630">
+              <a:lnSpc>
+                <a:spcPct val="140013"/>
+              </a:lnSpc>
+              <a:buClr>
+                <a:srgbClr val="12312B"/>
+              </a:buClr>
+              <a:buSzPts val="3009"/>
+              <a:buFont typeface="Archivo Medium"/>
+              <a:buChar char="•"/>
+            </a:pPr>
+            <a:r>
+              <a:rPr lang="en-US" sz="2006" kern="0" dirty="0">
+                <a:solidFill>
+                  <a:srgbClr val="12312B"/>
+                </a:solidFill>
+                <a:latin typeface="Archivo Medium"/>
+                <a:cs typeface="Archivo Medium"/>
+                <a:sym typeface="Archivo Medium"/>
+              </a:rPr>
+              <a:t>Then you tell it how to read it using a function, like read.csv() or </a:t>
+            </a:r>
+            <a:r>
+              <a:rPr lang="en-US" sz="2006" kern="0" dirty="0" err="1">
+                <a:solidFill>
+                  <a:srgbClr val="12312B"/>
+                </a:solidFill>
+                <a:latin typeface="Archivo Medium"/>
+                <a:cs typeface="Archivo Medium"/>
+                <a:sym typeface="Archivo Medium"/>
+              </a:rPr>
+              <a:t>read_xlsx</a:t>
+            </a:r>
+            <a:r>
+              <a:rPr lang="en-US" sz="2006" kern="0" dirty="0">
+                <a:solidFill>
+                  <a:srgbClr val="12312B"/>
+                </a:solidFill>
+                <a:latin typeface="Archivo Medium"/>
+                <a:cs typeface="Archivo Medium"/>
+                <a:sym typeface="Archivo Medium"/>
+              </a:rPr>
+              <a:t>()</a:t>
+            </a:r>
+            <a:endParaRPr sz="2000" dirty="0">
+              <a:solidFill>
+                <a:srgbClr val="12312B"/>
+              </a:solidFill>
+              <a:latin typeface="Arial"/>
+              <a:ea typeface="Arial"/>
+              <a:cs typeface="Arial"/>
+              <a:sym typeface="Arial"/>
+            </a:endParaRPr>
+          </a:p>
+        </p:txBody>
+      </p:sp>
+    </p:spTree>
+    <p:extLst>
+      <p:ext uri="{BB962C8B-B14F-4D97-AF65-F5344CB8AC3E}">
+        <p14:creationId xmlns:p14="http://schemas.microsoft.com/office/powerpoint/2010/main" val="2386386992"/>
+      </p:ext>
+    </p:extLst>
+  </p:cSld>
+  <p:clrMapOvr>
+    <a:masterClrMapping/>
+  </p:clrMapOvr>
+</p:sld>
+</file>
+
+<file path=ppt/slides/slide16.xml><?xml version="1.0" encoding="utf-8"?>
+<p:sld xmlns:a="http://schemas.openxmlformats.org/drawingml/2006/main" xmlns:r="http://schemas.openxmlformats.org/officeDocument/2006/relationships" xmlns:p="http://schemas.openxmlformats.org/presentationml/2006/main">
+  <p:cSld>
+    <p:spTree>
+      <p:nvGrpSpPr>
+        <p:cNvPr id="1" name="Shape 402">
+          <a:extLst>
+            <a:ext uri="{FF2B5EF4-FFF2-40B4-BE49-F238E27FC236}">
               <a16:creationId xmlns:a16="http://schemas.microsoft.com/office/drawing/2014/main" id="{873992E1-73E7-18BD-FD75-8101CD21ADAF}"/>
             </a:ext>
           </a:extLst>
@@ -12969,7 +13607,7 @@
 </p:sld>
 </file>
 
-<file path=ppt/slides/slide16.xml><?xml version="1.0" encoding="utf-8"?>
+<file path=ppt/slides/slide17.xml><?xml version="1.0" encoding="utf-8"?>
 <p:sld xmlns:a="http://schemas.openxmlformats.org/drawingml/2006/main" xmlns:r="http://schemas.openxmlformats.org/officeDocument/2006/relationships" xmlns:p="http://schemas.openxmlformats.org/presentationml/2006/main">
   <p:cSld>
     <p:spTree>
@@ -13141,7 +13779,7 @@
 </p:sld>
 </file>
 
-<file path=ppt/slides/slide17.xml><?xml version="1.0" encoding="utf-8"?>
+<file path=ppt/slides/slide18.xml><?xml version="1.0" encoding="utf-8"?>
 <p:sld xmlns:a="http://schemas.openxmlformats.org/drawingml/2006/main" xmlns:r="http://schemas.openxmlformats.org/officeDocument/2006/relationships" xmlns:p="http://schemas.openxmlformats.org/presentationml/2006/main">
   <p:cSld>
     <p:spTree>
@@ -13640,6 +14278,178 @@
     <p:extLst>
       <p:ext uri="{BB962C8B-B14F-4D97-AF65-F5344CB8AC3E}">
         <p14:creationId xmlns:p14="http://schemas.microsoft.com/office/powerpoint/2010/main" val="2135785689"/>
+      </p:ext>
+    </p:extLst>
+  </p:cSld>
+  <p:clrMapOvr>
+    <a:masterClrMapping/>
+  </p:clrMapOvr>
+</p:sld>
+</file>
+
+<file path=ppt/slides/slide19.xml><?xml version="1.0" encoding="utf-8"?>
+<p:sld xmlns:a="http://schemas.openxmlformats.org/drawingml/2006/main" xmlns:r="http://schemas.openxmlformats.org/officeDocument/2006/relationships" xmlns:p="http://schemas.openxmlformats.org/presentationml/2006/main">
+  <p:cSld>
+    <p:spTree>
+      <p:nvGrpSpPr>
+        <p:cNvPr id="1" name="Shape 133">
+          <a:extLst>
+            <a:ext uri="{FF2B5EF4-FFF2-40B4-BE49-F238E27FC236}">
+              <a16:creationId xmlns:a16="http://schemas.microsoft.com/office/drawing/2014/main" id="{D4EF62E4-FB2B-7E4A-4CB1-53FFFC5316C8}"/>
+            </a:ext>
+          </a:extLst>
+        </p:cNvPr>
+        <p:cNvGrpSpPr/>
+        <p:nvPr/>
+      </p:nvGrpSpPr>
+      <p:grpSpPr>
+        <a:xfrm>
+          <a:off x="0" y="0"/>
+          <a:ext cx="0" cy="0"/>
+          <a:chOff x="0" y="0"/>
+          <a:chExt cx="0" cy="0"/>
+        </a:xfrm>
+      </p:grpSpPr>
+      <p:sp>
+        <p:nvSpPr>
+          <p:cNvPr id="134" name="Google Shape;134;p25">
+            <a:extLst>
+              <a:ext uri="{FF2B5EF4-FFF2-40B4-BE49-F238E27FC236}">
+                <a16:creationId xmlns:a16="http://schemas.microsoft.com/office/drawing/2014/main" id="{B2390F86-F7C2-0C93-6066-1A98C227DC84}"/>
+              </a:ext>
+            </a:extLst>
+          </p:cNvPr>
+          <p:cNvSpPr txBox="1"/>
+          <p:nvPr/>
+        </p:nvSpPr>
+        <p:spPr>
+          <a:xfrm>
+            <a:off x="1417320" y="2148841"/>
+            <a:ext cx="9930384" cy="738664"/>
+          </a:xfrm>
+          <a:prstGeom prst="rect">
+            <a:avLst/>
+          </a:prstGeom>
+          <a:noFill/>
+          <a:ln>
+            <a:noFill/>
+          </a:ln>
+        </p:spPr>
+        <p:txBody>
+          <a:bodyPr spcFirstLastPara="1" wrap="square" lIns="0" tIns="0" rIns="0" bIns="0" anchor="t" anchorCtr="0">
+            <a:spAutoFit/>
+          </a:bodyPr>
+          <a:lstStyle/>
+          <a:p>
+            <a:pPr defTabSz="609630">
+              <a:buClr>
+                <a:srgbClr val="000000"/>
+              </a:buClr>
+            </a:pPr>
+            <a:r>
+              <a:rPr lang="en-US" sz="4800" kern="0" dirty="0">
+                <a:solidFill>
+                  <a:srgbClr val="A5D75F"/>
+                </a:solidFill>
+                <a:latin typeface="Anton"/>
+                <a:ea typeface="Anton"/>
+                <a:cs typeface="Anton"/>
+                <a:sym typeface="Anton"/>
+              </a:rPr>
+              <a:t>Appendix on why coding and R</a:t>
+            </a:r>
+            <a:endParaRPr sz="100" kern="0" dirty="0">
+              <a:solidFill>
+                <a:srgbClr val="A5D75F"/>
+              </a:solidFill>
+              <a:latin typeface="Anton"/>
+              <a:ea typeface="Anton"/>
+              <a:cs typeface="Anton"/>
+              <a:sym typeface="Anton"/>
+            </a:endParaRPr>
+          </a:p>
+        </p:txBody>
+      </p:sp>
+      <p:sp>
+        <p:nvSpPr>
+          <p:cNvPr id="135" name="Google Shape;135;p25">
+            <a:extLst>
+              <a:ext uri="{FF2B5EF4-FFF2-40B4-BE49-F238E27FC236}">
+                <a16:creationId xmlns:a16="http://schemas.microsoft.com/office/drawing/2014/main" id="{0C15ED0C-A394-9233-F734-6F8EBBB3A9C7}"/>
+              </a:ext>
+            </a:extLst>
+          </p:cNvPr>
+          <p:cNvSpPr/>
+          <p:nvPr/>
+        </p:nvSpPr>
+        <p:spPr>
+          <a:xfrm>
+            <a:off x="1065004" y="2844069"/>
+            <a:ext cx="8373826" cy="780393"/>
+          </a:xfrm>
+          <a:custGeom>
+            <a:avLst/>
+            <a:gdLst/>
+            <a:ahLst/>
+            <a:cxnLst/>
+            <a:rect l="l" t="t" r="r" b="b"/>
+            <a:pathLst>
+              <a:path w="6287497" h="938348" extrusionOk="0">
+                <a:moveTo>
+                  <a:pt x="0" y="0"/>
+                </a:moveTo>
+                <a:lnTo>
+                  <a:pt x="6287496" y="0"/>
+                </a:lnTo>
+                <a:lnTo>
+                  <a:pt x="6287496" y="938349"/>
+                </a:lnTo>
+                <a:lnTo>
+                  <a:pt x="0" y="938349"/>
+                </a:lnTo>
+                <a:lnTo>
+                  <a:pt x="0" y="0"/>
+                </a:lnTo>
+                <a:close/>
+              </a:path>
+            </a:pathLst>
+          </a:custGeom>
+          <a:blipFill rotWithShape="1">
+            <a:blip r:embed="rId3">
+              <a:alphaModFix/>
+            </a:blip>
+            <a:stretch>
+              <a:fillRect/>
+            </a:stretch>
+          </a:blipFill>
+          <a:ln>
+            <a:noFill/>
+          </a:ln>
+        </p:spPr>
+        <p:txBody>
+          <a:bodyPr/>
+          <a:lstStyle/>
+          <a:p>
+            <a:pPr defTabSz="609630">
+              <a:buClr>
+                <a:srgbClr val="000000"/>
+              </a:buClr>
+            </a:pPr>
+            <a:endParaRPr lang="en-US" sz="933" kern="0">
+              <a:solidFill>
+                <a:srgbClr val="000000"/>
+              </a:solidFill>
+              <a:latin typeface="Arial"/>
+              <a:cs typeface="Arial"/>
+              <a:sym typeface="Arial"/>
+            </a:endParaRPr>
+          </a:p>
+        </p:txBody>
+      </p:sp>
+    </p:spTree>
+    <p:extLst>
+      <p:ext uri="{BB962C8B-B14F-4D97-AF65-F5344CB8AC3E}">
+        <p14:creationId xmlns:p14="http://schemas.microsoft.com/office/powerpoint/2010/main" val="3505932459"/>
       </p:ext>
     </p:extLst>
   </p:cSld>
@@ -13750,7 +14560,7 @@
         <p:spPr>
           <a:xfrm>
             <a:off x="884764" y="1900078"/>
-            <a:ext cx="9776400" cy="2241896"/>
+            <a:ext cx="9776400" cy="1724831"/>
           </a:xfrm>
           <a:prstGeom prst="rect">
             <a:avLst/>
@@ -13765,31 +14575,6 @@
             <a:spAutoFit/>
           </a:bodyPr>
           <a:lstStyle/>
-          <a:p>
-            <a:pPr marL="433260" lvl="1" indent="-216630" defTabSz="609630">
-              <a:lnSpc>
-                <a:spcPct val="140013"/>
-              </a:lnSpc>
-              <a:buClr>
-                <a:srgbClr val="12312B"/>
-              </a:buClr>
-              <a:buSzPts val="3009"/>
-              <a:buFont typeface="Archivo Medium"/>
-              <a:buChar char="•"/>
-            </a:pPr>
-            <a:r>
-              <a:rPr lang="en-US" sz="2400" kern="0" dirty="0">
-                <a:solidFill>
-                  <a:srgbClr val="12312B"/>
-                </a:solidFill>
-                <a:latin typeface="Archivo Medium"/>
-                <a:ea typeface="Archivo Medium"/>
-                <a:cs typeface="Archivo Medium"/>
-                <a:sym typeface="Archivo Medium"/>
-              </a:rPr>
-              <a:t>During this part, we will</a:t>
-            </a:r>
-          </a:p>
           <a:p>
             <a:pPr marL="1016730" lvl="2" indent="-342900" defTabSz="609630">
               <a:lnSpc>
@@ -13896,7 +14681,7 @@
         </p:nvSpPr>
         <p:spPr>
           <a:xfrm>
-            <a:off x="798287" y="3678703"/>
+            <a:off x="798287" y="3734252"/>
             <a:ext cx="6097800" cy="742383"/>
           </a:xfrm>
           <a:prstGeom prst="rect">
@@ -13951,7 +14736,7 @@
         <p:spPr>
           <a:xfrm>
             <a:off x="798287" y="4476635"/>
-            <a:ext cx="9776400" cy="1809726"/>
+            <a:ext cx="9776400" cy="1292662"/>
           </a:xfrm>
           <a:prstGeom prst="rect">
             <a:avLst/>
@@ -13966,31 +14751,6 @@
             <a:spAutoFit/>
           </a:bodyPr>
           <a:lstStyle/>
-          <a:p>
-            <a:pPr marL="433260" lvl="1" indent="-216630" defTabSz="609630">
-              <a:lnSpc>
-                <a:spcPct val="140013"/>
-              </a:lnSpc>
-              <a:buClr>
-                <a:srgbClr val="12312B"/>
-              </a:buClr>
-              <a:buSzPts val="3009"/>
-              <a:buFont typeface="Archivo Medium"/>
-              <a:buChar char="•"/>
-            </a:pPr>
-            <a:r>
-              <a:rPr lang="en-US" sz="2400" kern="0" dirty="0">
-                <a:solidFill>
-                  <a:srgbClr val="12312B"/>
-                </a:solidFill>
-                <a:latin typeface="Archivo Medium"/>
-                <a:ea typeface="Archivo Medium"/>
-                <a:cs typeface="Archivo Medium"/>
-                <a:sym typeface="Archivo Medium"/>
-              </a:rPr>
-              <a:t>During this part, we will</a:t>
-            </a:r>
-          </a:p>
           <a:p>
             <a:pPr marL="1016730" lvl="2" indent="-342900" defTabSz="609630">
               <a:lnSpc>
@@ -14081,6 +14841,381 @@
   <p:clrMapOvr>
     <a:masterClrMapping/>
   </p:clrMapOvr>
+</p:sld>
+</file>
+
+<file path=ppt/slides/slide20.xml><?xml version="1.0" encoding="utf-8"?>
+<p:sld xmlns:a="http://schemas.openxmlformats.org/drawingml/2006/main" xmlns:r="http://schemas.openxmlformats.org/officeDocument/2006/relationships" xmlns:p="http://schemas.openxmlformats.org/presentationml/2006/main">
+  <p:cSld>
+    <p:spTree>
+      <p:nvGrpSpPr>
+        <p:cNvPr id="1" name="Shape 139">
+          <a:extLst>
+            <a:ext uri="{FF2B5EF4-FFF2-40B4-BE49-F238E27FC236}">
+              <a16:creationId xmlns:a16="http://schemas.microsoft.com/office/drawing/2014/main" id="{19470CC5-593A-690F-079B-89C049CD711A}"/>
+            </a:ext>
+          </a:extLst>
+        </p:cNvPr>
+        <p:cNvGrpSpPr/>
+        <p:nvPr/>
+      </p:nvGrpSpPr>
+      <p:grpSpPr>
+        <a:xfrm>
+          <a:off x="0" y="0"/>
+          <a:ext cx="0" cy="0"/>
+          <a:chOff x="0" y="0"/>
+          <a:chExt cx="0" cy="0"/>
+        </a:xfrm>
+      </p:grpSpPr>
+      <p:sp>
+        <p:nvSpPr>
+          <p:cNvPr id="141" name="Google Shape;141;p26">
+            <a:extLst>
+              <a:ext uri="{FF2B5EF4-FFF2-40B4-BE49-F238E27FC236}">
+                <a16:creationId xmlns:a16="http://schemas.microsoft.com/office/drawing/2014/main" id="{065FBD60-648E-08FF-8FFE-BFA5ED4D3D17}"/>
+              </a:ext>
+            </a:extLst>
+          </p:cNvPr>
+          <p:cNvSpPr txBox="1"/>
+          <p:nvPr/>
+        </p:nvSpPr>
+        <p:spPr>
+          <a:xfrm>
+            <a:off x="922202" y="1157695"/>
+            <a:ext cx="6097800" cy="742383"/>
+          </a:xfrm>
+          <a:prstGeom prst="rect">
+            <a:avLst/>
+          </a:prstGeom>
+          <a:noFill/>
+          <a:ln>
+            <a:noFill/>
+          </a:ln>
+        </p:spPr>
+        <p:txBody>
+          <a:bodyPr spcFirstLastPara="1" wrap="square" lIns="0" tIns="0" rIns="0" bIns="0" anchor="t" anchorCtr="0">
+            <a:spAutoFit/>
+          </a:bodyPr>
+          <a:lstStyle/>
+          <a:p>
+            <a:pPr defTabSz="609630">
+              <a:lnSpc>
+                <a:spcPct val="140007"/>
+              </a:lnSpc>
+              <a:buClr>
+                <a:srgbClr val="000000"/>
+              </a:buClr>
+            </a:pPr>
+            <a:r>
+              <a:rPr lang="en-US" sz="3446" kern="0" dirty="0">
+                <a:solidFill>
+                  <a:srgbClr val="00693D"/>
+                </a:solidFill>
+                <a:latin typeface="Anton"/>
+                <a:ea typeface="Anton"/>
+                <a:cs typeface="Anton"/>
+                <a:sym typeface="Anton"/>
+              </a:rPr>
+              <a:t>Why code?</a:t>
+            </a:r>
+            <a:endParaRPr sz="933" kern="0" dirty="0">
+              <a:solidFill>
+                <a:srgbClr val="000000"/>
+              </a:solidFill>
+              <a:latin typeface="Anton"/>
+              <a:ea typeface="Anton"/>
+              <a:cs typeface="Anton"/>
+              <a:sym typeface="Anton"/>
+            </a:endParaRPr>
+          </a:p>
+        </p:txBody>
+      </p:sp>
+      <p:sp>
+        <p:nvSpPr>
+          <p:cNvPr id="142" name="Google Shape;142;p26">
+            <a:extLst>
+              <a:ext uri="{FF2B5EF4-FFF2-40B4-BE49-F238E27FC236}">
+                <a16:creationId xmlns:a16="http://schemas.microsoft.com/office/drawing/2014/main" id="{84E805A2-8A26-865B-942E-CB7F034379BD}"/>
+              </a:ext>
+            </a:extLst>
+          </p:cNvPr>
+          <p:cNvSpPr txBox="1"/>
+          <p:nvPr/>
+        </p:nvSpPr>
+        <p:spPr>
+          <a:xfrm>
+            <a:off x="922202" y="1736904"/>
+            <a:ext cx="9776400" cy="4919808"/>
+          </a:xfrm>
+          <a:prstGeom prst="rect">
+            <a:avLst/>
+          </a:prstGeom>
+          <a:noFill/>
+          <a:ln>
+            <a:noFill/>
+          </a:ln>
+        </p:spPr>
+        <p:txBody>
+          <a:bodyPr spcFirstLastPara="1" wrap="square" lIns="0" tIns="0" rIns="0" bIns="0" anchor="t" anchorCtr="0">
+            <a:spAutoFit/>
+          </a:bodyPr>
+          <a:lstStyle/>
+          <a:p>
+            <a:pPr marL="433260" lvl="1" indent="-216630" defTabSz="609630">
+              <a:lnSpc>
+                <a:spcPct val="140013"/>
+              </a:lnSpc>
+              <a:buClr>
+                <a:srgbClr val="12312B"/>
+              </a:buClr>
+              <a:buSzPts val="3009"/>
+              <a:buFont typeface="Archivo Medium"/>
+              <a:buChar char="•"/>
+            </a:pPr>
+            <a:endParaRPr lang="en-US" sz="2006" kern="0" dirty="0">
+              <a:solidFill>
+                <a:srgbClr val="12312B"/>
+              </a:solidFill>
+              <a:latin typeface="Archivo Medium"/>
+              <a:ea typeface="Archivo Medium"/>
+              <a:cs typeface="Archivo Medium"/>
+              <a:sym typeface="Archivo Medium"/>
+            </a:endParaRPr>
+          </a:p>
+          <a:p>
+            <a:pPr marL="433260" lvl="1" indent="-216630" defTabSz="609630">
+              <a:lnSpc>
+                <a:spcPct val="140013"/>
+              </a:lnSpc>
+              <a:buClr>
+                <a:srgbClr val="12312B"/>
+              </a:buClr>
+              <a:buSzPts val="3009"/>
+              <a:buFont typeface="Archivo Medium"/>
+              <a:buChar char="•"/>
+            </a:pPr>
+            <a:r>
+              <a:rPr lang="en-US" sz="2006" kern="0" dirty="0">
+                <a:solidFill>
+                  <a:srgbClr val="12312B"/>
+                </a:solidFill>
+                <a:latin typeface="Archivo Medium"/>
+                <a:ea typeface="Archivo Medium"/>
+                <a:cs typeface="Archivo Medium"/>
+                <a:sym typeface="Archivo Medium"/>
+              </a:rPr>
+              <a:t>Conducting your data explorations, analyses, and figure creation via code is great for reproducibility. </a:t>
+            </a:r>
+          </a:p>
+          <a:p>
+            <a:pPr marL="433260" lvl="1" indent="-216630" defTabSz="609630">
+              <a:lnSpc>
+                <a:spcPct val="140013"/>
+              </a:lnSpc>
+              <a:buClr>
+                <a:srgbClr val="12312B"/>
+              </a:buClr>
+              <a:buSzPts val="3009"/>
+              <a:buFont typeface="Archivo Medium"/>
+              <a:buChar char="•"/>
+            </a:pPr>
+            <a:endParaRPr lang="en-US" sz="2006" kern="0" dirty="0">
+              <a:solidFill>
+                <a:srgbClr val="12312B"/>
+              </a:solidFill>
+              <a:latin typeface="Archivo Medium"/>
+              <a:ea typeface="Archivo Medium"/>
+              <a:cs typeface="Archivo Medium"/>
+              <a:sym typeface="Archivo Medium"/>
+            </a:endParaRPr>
+          </a:p>
+          <a:p>
+            <a:pPr marL="433260" lvl="1" indent="-216630">
+              <a:lnSpc>
+                <a:spcPct val="140013"/>
+              </a:lnSpc>
+              <a:buClr>
+                <a:srgbClr val="12312B"/>
+              </a:buClr>
+              <a:buSzPts val="3009"/>
+              <a:buFont typeface="Archivo Medium"/>
+              <a:buChar char="•"/>
+            </a:pPr>
+            <a:r>
+              <a:rPr lang="en-US" sz="2006" dirty="0">
+                <a:solidFill>
+                  <a:srgbClr val="12312B"/>
+                </a:solidFill>
+                <a:latin typeface="Archivo Medium"/>
+                <a:sym typeface="Archivo Medium"/>
+              </a:rPr>
+              <a:t>What if you get an updated version of your dataset? Or another dataset to repeat your analysis on? Or a figure needs tweaking for publication?</a:t>
+            </a:r>
+          </a:p>
+          <a:p>
+            <a:pPr marL="866521" lvl="2" indent="-288840">
+              <a:lnSpc>
+                <a:spcPct val="140013"/>
+              </a:lnSpc>
+              <a:buClr>
+                <a:srgbClr val="12312B"/>
+              </a:buClr>
+              <a:buSzPts val="3009"/>
+              <a:buFont typeface="Archivo Medium"/>
+              <a:buChar char="⚬"/>
+            </a:pPr>
+            <a:r>
+              <a:rPr lang="en-US" dirty="0">
+                <a:solidFill>
+                  <a:srgbClr val="12312B"/>
+                </a:solidFill>
+                <a:latin typeface="Archivo Medium"/>
+                <a:sym typeface="Archivo Medium"/>
+              </a:rPr>
+              <a:t>If you did your work manually, you have to repeat the whole process. </a:t>
+            </a:r>
+          </a:p>
+          <a:p>
+            <a:pPr marL="1323721" lvl="3" indent="-288840">
+              <a:lnSpc>
+                <a:spcPct val="140013"/>
+              </a:lnSpc>
+              <a:buClr>
+                <a:srgbClr val="12312B"/>
+              </a:buClr>
+              <a:buSzPts val="3009"/>
+              <a:buFont typeface="Arial" panose="020B0604020202020204" pitchFamily="34" charset="0"/>
+              <a:buChar char="•"/>
+            </a:pPr>
+            <a:r>
+              <a:rPr lang="en-US" dirty="0">
+                <a:solidFill>
+                  <a:srgbClr val="12312B"/>
+                </a:solidFill>
+                <a:latin typeface="Archivo Medium"/>
+                <a:sym typeface="Arial"/>
+              </a:rPr>
+              <a:t>Manual modification is inefficient, error-prone, and hard to reproduce.</a:t>
+            </a:r>
+          </a:p>
+          <a:p>
+            <a:pPr marL="1323721" lvl="3" indent="-288840">
+              <a:lnSpc>
+                <a:spcPct val="140013"/>
+              </a:lnSpc>
+              <a:buClr>
+                <a:srgbClr val="12312B"/>
+              </a:buClr>
+              <a:buSzPts val="3009"/>
+              <a:buFont typeface="Arial" panose="020B0604020202020204" pitchFamily="34" charset="0"/>
+              <a:buChar char="•"/>
+            </a:pPr>
+            <a:r>
+              <a:rPr lang="en-US" dirty="0">
+                <a:solidFill>
+                  <a:srgbClr val="12312B"/>
+                </a:solidFill>
+                <a:latin typeface="Archivo Medium"/>
+                <a:sym typeface="Arial"/>
+              </a:rPr>
+              <a:t>It’s much harder for someone else to recreate your process. </a:t>
+            </a:r>
+          </a:p>
+          <a:p>
+            <a:pPr marL="866521" lvl="2" indent="-288840">
+              <a:lnSpc>
+                <a:spcPct val="140013"/>
+              </a:lnSpc>
+              <a:buClr>
+                <a:srgbClr val="12312B"/>
+              </a:buClr>
+              <a:buSzPts val="3009"/>
+              <a:buFont typeface="Archivo Medium"/>
+              <a:buChar char="⚬"/>
+            </a:pPr>
+            <a:r>
+              <a:rPr lang="en-US" dirty="0">
+                <a:solidFill>
+                  <a:srgbClr val="12312B"/>
+                </a:solidFill>
+                <a:latin typeface="Archivo Medium"/>
+                <a:sym typeface="Archivo Medium"/>
+              </a:rPr>
+              <a:t>If you are using a script, you simply re-run it with the required updates.</a:t>
+            </a:r>
+          </a:p>
+          <a:p>
+            <a:pPr marL="1320631" lvl="3" indent="-285750">
+              <a:lnSpc>
+                <a:spcPct val="140013"/>
+              </a:lnSpc>
+              <a:buClr>
+                <a:srgbClr val="12312B"/>
+              </a:buClr>
+              <a:buSzPts val="3009"/>
+              <a:buFont typeface="Arial" panose="020B0604020202020204" pitchFamily="34" charset="0"/>
+              <a:buChar char="•"/>
+            </a:pPr>
+            <a:r>
+              <a:rPr lang="en-US" dirty="0">
+                <a:solidFill>
+                  <a:srgbClr val="12312B"/>
+                </a:solidFill>
+                <a:latin typeface="Archivo Medium"/>
+                <a:sym typeface="Archivo Medium"/>
+              </a:rPr>
+              <a:t>Saves you time and ensures you get the same results each time.</a:t>
+            </a:r>
+          </a:p>
+          <a:p>
+            <a:pPr marL="1320631" lvl="3" indent="-285750">
+              <a:lnSpc>
+                <a:spcPct val="140013"/>
+              </a:lnSpc>
+              <a:buClr>
+                <a:srgbClr val="12312B"/>
+              </a:buClr>
+              <a:buSzPts val="3009"/>
+              <a:buFont typeface="Arial" panose="020B0604020202020204" pitchFamily="34" charset="0"/>
+              <a:buChar char="•"/>
+            </a:pPr>
+            <a:r>
+              <a:rPr lang="en-US" dirty="0">
+                <a:solidFill>
+                  <a:srgbClr val="12312B"/>
+                </a:solidFill>
+                <a:latin typeface="Archivo Medium"/>
+                <a:sym typeface="Archivo Medium"/>
+              </a:rPr>
+              <a:t>Anyone can reproduce your work, given the same raw data files and the script.</a:t>
+            </a:r>
+            <a:endParaRPr lang="en-US" sz="2006" kern="0" dirty="0">
+              <a:solidFill>
+                <a:srgbClr val="12312B"/>
+              </a:solidFill>
+              <a:latin typeface="Archivo Medium"/>
+              <a:ea typeface="Archivo Medium"/>
+              <a:cs typeface="Archivo Medium"/>
+              <a:sym typeface="Archivo Medium"/>
+            </a:endParaRPr>
+          </a:p>
+        </p:txBody>
+      </p:sp>
+    </p:spTree>
+    <p:extLst>
+      <p:ext uri="{BB962C8B-B14F-4D97-AF65-F5344CB8AC3E}">
+        <p14:creationId xmlns:p14="http://schemas.microsoft.com/office/powerpoint/2010/main" val="2110054645"/>
+      </p:ext>
+    </p:extLst>
+  </p:cSld>
+  <p:clrMapOvr>
+    <a:masterClrMapping/>
+  </p:clrMapOvr>
+  <p:extLst>
+    <p:ext uri="{6950BFC3-D8DA-4A85-94F7-54DA5524770B}">
+      <p188:commentRel xmlns:p188="http://schemas.microsoft.com/office/powerpoint/2018/8/main" r:id="rId3"/>
+    </p:ext>
+  </p:extLst>
 </p:sld>
 </file>
 
@@ -14257,6 +15392,610 @@
 </file>
 
 <file path=ppt/slides/slide4.xml><?xml version="1.0" encoding="utf-8"?>
+<p:sld xmlns:a="http://schemas.openxmlformats.org/drawingml/2006/main" xmlns:r="http://schemas.openxmlformats.org/officeDocument/2006/relationships" xmlns:p="http://schemas.openxmlformats.org/presentationml/2006/main">
+  <p:cSld>
+    <p:spTree>
+      <p:nvGrpSpPr>
+        <p:cNvPr id="1" name="Shape 139">
+          <a:extLst>
+            <a:ext uri="{FF2B5EF4-FFF2-40B4-BE49-F238E27FC236}">
+              <a16:creationId xmlns:a16="http://schemas.microsoft.com/office/drawing/2014/main" id="{064079F8-F37E-A07B-ED90-4DCE489A5E02}"/>
+            </a:ext>
+          </a:extLst>
+        </p:cNvPr>
+        <p:cNvGrpSpPr/>
+        <p:nvPr/>
+      </p:nvGrpSpPr>
+      <p:grpSpPr>
+        <a:xfrm>
+          <a:off x="0" y="0"/>
+          <a:ext cx="0" cy="0"/>
+          <a:chOff x="0" y="0"/>
+          <a:chExt cx="0" cy="0"/>
+        </a:xfrm>
+      </p:grpSpPr>
+      <p:sp>
+        <p:nvSpPr>
+          <p:cNvPr id="141" name="Google Shape;141;p26">
+            <a:extLst>
+              <a:ext uri="{FF2B5EF4-FFF2-40B4-BE49-F238E27FC236}">
+                <a16:creationId xmlns:a16="http://schemas.microsoft.com/office/drawing/2014/main" id="{B691B0C0-292D-12A0-3E0E-FB599A1FF623}"/>
+              </a:ext>
+            </a:extLst>
+          </p:cNvPr>
+          <p:cNvSpPr txBox="1"/>
+          <p:nvPr/>
+        </p:nvSpPr>
+        <p:spPr>
+          <a:xfrm>
+            <a:off x="922202" y="1157695"/>
+            <a:ext cx="6097800" cy="742383"/>
+          </a:xfrm>
+          <a:prstGeom prst="rect">
+            <a:avLst/>
+          </a:prstGeom>
+          <a:noFill/>
+          <a:ln>
+            <a:noFill/>
+          </a:ln>
+        </p:spPr>
+        <p:txBody>
+          <a:bodyPr spcFirstLastPara="1" wrap="square" lIns="0" tIns="0" rIns="0" bIns="0" anchor="t" anchorCtr="0">
+            <a:spAutoFit/>
+          </a:bodyPr>
+          <a:lstStyle/>
+          <a:p>
+            <a:pPr defTabSz="609630">
+              <a:lnSpc>
+                <a:spcPct val="140007"/>
+              </a:lnSpc>
+              <a:buClr>
+                <a:srgbClr val="000000"/>
+              </a:buClr>
+            </a:pPr>
+            <a:r>
+              <a:rPr lang="en-US" sz="3446" kern="0" dirty="0">
+                <a:solidFill>
+                  <a:srgbClr val="00693D"/>
+                </a:solidFill>
+                <a:latin typeface="Anton"/>
+                <a:ea typeface="Anton"/>
+                <a:cs typeface="Anton"/>
+                <a:sym typeface="Anton"/>
+              </a:rPr>
+              <a:t>Why R?</a:t>
+            </a:r>
+            <a:endParaRPr sz="933" kern="0" dirty="0">
+              <a:solidFill>
+                <a:srgbClr val="000000"/>
+              </a:solidFill>
+              <a:latin typeface="Anton"/>
+              <a:ea typeface="Anton"/>
+              <a:cs typeface="Anton"/>
+              <a:sym typeface="Anton"/>
+            </a:endParaRPr>
+          </a:p>
+        </p:txBody>
+      </p:sp>
+      <p:sp>
+        <p:nvSpPr>
+          <p:cNvPr id="142" name="Google Shape;142;p26">
+            <a:extLst>
+              <a:ext uri="{FF2B5EF4-FFF2-40B4-BE49-F238E27FC236}">
+                <a16:creationId xmlns:a16="http://schemas.microsoft.com/office/drawing/2014/main" id="{E189FD22-C7D4-7CB0-BF84-7F836CFE7975}"/>
+              </a:ext>
+            </a:extLst>
+          </p:cNvPr>
+          <p:cNvSpPr txBox="1"/>
+          <p:nvPr/>
+        </p:nvSpPr>
+        <p:spPr>
+          <a:xfrm>
+            <a:off x="922202" y="1736904"/>
+            <a:ext cx="9776400" cy="4665123"/>
+          </a:xfrm>
+          <a:prstGeom prst="rect">
+            <a:avLst/>
+          </a:prstGeom>
+          <a:noFill/>
+          <a:ln>
+            <a:noFill/>
+          </a:ln>
+        </p:spPr>
+        <p:txBody>
+          <a:bodyPr spcFirstLastPara="1" wrap="square" lIns="0" tIns="0" rIns="0" bIns="0" anchor="t" anchorCtr="0">
+            <a:spAutoFit/>
+          </a:bodyPr>
+          <a:lstStyle/>
+          <a:p>
+            <a:pPr marL="433260" lvl="1" indent="-216630" defTabSz="609630">
+              <a:lnSpc>
+                <a:spcPct val="140013"/>
+              </a:lnSpc>
+              <a:buClr>
+                <a:srgbClr val="12312B"/>
+              </a:buClr>
+              <a:buSzPts val="3009"/>
+              <a:buFont typeface="Archivo Medium"/>
+              <a:buChar char="•"/>
+            </a:pPr>
+            <a:endParaRPr lang="en-US" sz="2006" kern="0" dirty="0">
+              <a:solidFill>
+                <a:srgbClr val="12312B"/>
+              </a:solidFill>
+              <a:latin typeface="Archivo Medium"/>
+              <a:ea typeface="Archivo Medium"/>
+              <a:cs typeface="Archivo Medium"/>
+              <a:sym typeface="Archivo Medium"/>
+            </a:endParaRPr>
+          </a:p>
+          <a:p>
+            <a:pPr marL="433260" lvl="1" indent="-216630" defTabSz="609630">
+              <a:lnSpc>
+                <a:spcPct val="140013"/>
+              </a:lnSpc>
+              <a:buClr>
+                <a:srgbClr val="12312B"/>
+              </a:buClr>
+              <a:buSzPts val="3009"/>
+              <a:buFont typeface="Archivo Medium"/>
+              <a:buChar char="•"/>
+            </a:pPr>
+            <a:r>
+              <a:rPr lang="en-US" sz="2006" kern="0" dirty="0">
+                <a:solidFill>
+                  <a:srgbClr val="12312B"/>
+                </a:solidFill>
+                <a:latin typeface="Archivo Medium"/>
+                <a:ea typeface="Archivo Medium"/>
+                <a:cs typeface="Archivo Medium"/>
+                <a:sym typeface="Archivo Medium"/>
+              </a:rPr>
+              <a:t>R is a popular programming language and software for data analysis and visualization.</a:t>
+            </a:r>
+          </a:p>
+          <a:p>
+            <a:pPr marL="433260" lvl="1" indent="-216630" defTabSz="609630">
+              <a:lnSpc>
+                <a:spcPct val="140013"/>
+              </a:lnSpc>
+              <a:buClr>
+                <a:srgbClr val="12312B"/>
+              </a:buClr>
+              <a:buSzPts val="3009"/>
+              <a:buFont typeface="Archivo Medium"/>
+              <a:buChar char="•"/>
+            </a:pPr>
+            <a:endParaRPr lang="en-US" sz="2006" kern="0" dirty="0">
+              <a:solidFill>
+                <a:srgbClr val="12312B"/>
+              </a:solidFill>
+              <a:latin typeface="Archivo Medium"/>
+              <a:ea typeface="Archivo Medium"/>
+              <a:cs typeface="Archivo Medium"/>
+              <a:sym typeface="Archivo Medium"/>
+            </a:endParaRPr>
+          </a:p>
+          <a:p>
+            <a:pPr marL="433260" lvl="1" indent="-216630" defTabSz="609630">
+              <a:lnSpc>
+                <a:spcPct val="140013"/>
+              </a:lnSpc>
+              <a:buClr>
+                <a:srgbClr val="12312B"/>
+              </a:buClr>
+              <a:buSzPts val="3009"/>
+              <a:buFont typeface="Archivo Medium"/>
+              <a:buChar char="•"/>
+            </a:pPr>
+            <a:r>
+              <a:rPr lang="en-US" sz="2006" kern="0" dirty="0">
+                <a:solidFill>
+                  <a:srgbClr val="12312B"/>
+                </a:solidFill>
+                <a:latin typeface="Archivo Medium"/>
+                <a:ea typeface="Archivo Medium"/>
+                <a:cs typeface="Archivo Medium"/>
+                <a:sym typeface="Archivo Medium"/>
+              </a:rPr>
+              <a:t>It’s free and open source.</a:t>
+            </a:r>
+          </a:p>
+          <a:p>
+            <a:pPr marL="433260" lvl="1" indent="-216630" defTabSz="609630">
+              <a:lnSpc>
+                <a:spcPct val="140013"/>
+              </a:lnSpc>
+              <a:buClr>
+                <a:srgbClr val="12312B"/>
+              </a:buClr>
+              <a:buSzPts val="3009"/>
+              <a:buFont typeface="Archivo Medium"/>
+              <a:buChar char="•"/>
+            </a:pPr>
+            <a:endParaRPr lang="en-US" sz="2006" kern="0" dirty="0">
+              <a:solidFill>
+                <a:srgbClr val="12312B"/>
+              </a:solidFill>
+              <a:latin typeface="Archivo Medium"/>
+              <a:ea typeface="Archivo Medium"/>
+              <a:cs typeface="Archivo Medium"/>
+              <a:sym typeface="Archivo Medium"/>
+            </a:endParaRPr>
+          </a:p>
+          <a:p>
+            <a:pPr marL="433260" lvl="1" indent="-216630" defTabSz="609630">
+              <a:lnSpc>
+                <a:spcPct val="140013"/>
+              </a:lnSpc>
+              <a:buClr>
+                <a:srgbClr val="12312B"/>
+              </a:buClr>
+              <a:buSzPts val="3009"/>
+              <a:buFont typeface="Archivo Medium"/>
+              <a:buChar char="•"/>
+            </a:pPr>
+            <a:r>
+              <a:rPr lang="en-US" sz="2006" kern="0" dirty="0">
+                <a:solidFill>
+                  <a:srgbClr val="12312B"/>
+                </a:solidFill>
+                <a:latin typeface="Archivo Medium"/>
+                <a:ea typeface="Archivo Medium"/>
+                <a:cs typeface="Archivo Medium"/>
+                <a:sym typeface="Archivo Medium"/>
+              </a:rPr>
+              <a:t>It has a huge user community and internet presence.</a:t>
+            </a:r>
+          </a:p>
+          <a:p>
+            <a:pPr marL="866521" lvl="2" indent="-288840" defTabSz="609630">
+              <a:lnSpc>
+                <a:spcPct val="140013"/>
+              </a:lnSpc>
+              <a:buClr>
+                <a:srgbClr val="12312B"/>
+              </a:buClr>
+              <a:buSzPts val="3009"/>
+              <a:buFont typeface="Archivo Medium"/>
+              <a:buChar char="⚬"/>
+            </a:pPr>
+            <a:r>
+              <a:rPr lang="en-US" dirty="0">
+                <a:latin typeface="Archivo Medium"/>
+                <a:sym typeface="Archivo Medium"/>
+              </a:rPr>
+              <a:t>Easy to get help!</a:t>
+            </a:r>
+          </a:p>
+          <a:p>
+            <a:pPr marL="866521" lvl="2" indent="-288840" defTabSz="609630">
+              <a:lnSpc>
+                <a:spcPct val="140013"/>
+              </a:lnSpc>
+              <a:buClr>
+                <a:srgbClr val="12312B"/>
+              </a:buClr>
+              <a:buSzPts val="3009"/>
+              <a:buFont typeface="Archivo Medium"/>
+              <a:buChar char="⚬"/>
+            </a:pPr>
+            <a:r>
+              <a:rPr lang="en-US" dirty="0">
+                <a:latin typeface="Archivo Medium"/>
+                <a:sym typeface="Archivo Medium"/>
+              </a:rPr>
+              <a:t>Tons of great tools, no matter your subject area.</a:t>
+            </a:r>
+          </a:p>
+          <a:p>
+            <a:pPr marL="433260" lvl="1" indent="-216630" defTabSz="609630">
+              <a:lnSpc>
+                <a:spcPct val="140013"/>
+              </a:lnSpc>
+              <a:buClr>
+                <a:srgbClr val="12312B"/>
+              </a:buClr>
+              <a:buSzPts val="3009"/>
+              <a:buFont typeface="Archivo Medium"/>
+              <a:buChar char="•"/>
+            </a:pPr>
+            <a:endParaRPr lang="en-US" sz="2006" kern="0" dirty="0">
+              <a:solidFill>
+                <a:srgbClr val="12312B"/>
+              </a:solidFill>
+              <a:latin typeface="Archivo Medium"/>
+              <a:ea typeface="Archivo Medium"/>
+              <a:cs typeface="Archivo Medium"/>
+              <a:sym typeface="Archivo Medium"/>
+            </a:endParaRPr>
+          </a:p>
+          <a:p>
+            <a:pPr marL="433260" lvl="1" indent="-216630" defTabSz="609630">
+              <a:lnSpc>
+                <a:spcPct val="140013"/>
+              </a:lnSpc>
+              <a:buClr>
+                <a:srgbClr val="12312B"/>
+              </a:buClr>
+              <a:buSzPts val="3009"/>
+              <a:buFont typeface="Archivo Medium"/>
+              <a:buChar char="•"/>
+            </a:pPr>
+            <a:endParaRPr lang="en-US" sz="2006" kern="0" dirty="0">
+              <a:solidFill>
+                <a:srgbClr val="12312B"/>
+              </a:solidFill>
+              <a:latin typeface="Archivo Medium"/>
+              <a:ea typeface="Archivo Medium"/>
+              <a:cs typeface="Archivo Medium"/>
+              <a:sym typeface="Archivo Medium"/>
+            </a:endParaRPr>
+          </a:p>
+          <a:p>
+            <a:pPr marL="433260" lvl="1" indent="-216630" defTabSz="609630">
+              <a:lnSpc>
+                <a:spcPct val="140013"/>
+              </a:lnSpc>
+              <a:buClr>
+                <a:srgbClr val="12312B"/>
+              </a:buClr>
+              <a:buSzPts val="3009"/>
+              <a:buFont typeface="Archivo Medium"/>
+              <a:buChar char="•"/>
+            </a:pPr>
+            <a:endParaRPr lang="en-US" sz="2006" kern="0" dirty="0">
+              <a:solidFill>
+                <a:srgbClr val="12312B"/>
+              </a:solidFill>
+              <a:latin typeface="Archivo Medium"/>
+              <a:ea typeface="Archivo Medium"/>
+              <a:cs typeface="Archivo Medium"/>
+              <a:sym typeface="Archivo Medium"/>
+            </a:endParaRPr>
+          </a:p>
+        </p:txBody>
+      </p:sp>
+    </p:spTree>
+    <p:extLst>
+      <p:ext uri="{BB962C8B-B14F-4D97-AF65-F5344CB8AC3E}">
+        <p14:creationId xmlns:p14="http://schemas.microsoft.com/office/powerpoint/2010/main" val="1682775875"/>
+      </p:ext>
+    </p:extLst>
+  </p:cSld>
+  <p:clrMapOvr>
+    <a:masterClrMapping/>
+  </p:clrMapOvr>
+  <p:timing>
+    <p:tnLst>
+      <p:par>
+        <p:cTn id="1" dur="indefinite" restart="never" nodeType="tmRoot">
+          <p:childTnLst>
+            <p:seq concurrent="1" nextAc="seek">
+              <p:cTn id="2" dur="indefinite" nodeType="mainSeq">
+                <p:childTnLst>
+                  <p:par>
+                    <p:cTn id="3" fill="hold">
+                      <p:stCondLst>
+                        <p:cond delay="indefinite"/>
+                      </p:stCondLst>
+                      <p:childTnLst>
+                        <p:par>
+                          <p:cTn id="4" fill="hold">
+                            <p:stCondLst>
+                              <p:cond delay="0"/>
+                            </p:stCondLst>
+                            <p:childTnLst>
+                              <p:par>
+                                <p:cTn id="5" presetID="1" presetClass="entr" presetSubtype="0" fill="hold" nodeType="clickEffect">
+                                  <p:stCondLst>
+                                    <p:cond delay="0"/>
+                                  </p:stCondLst>
+                                  <p:childTnLst>
+                                    <p:set>
+                                      <p:cBhvr>
+                                        <p:cTn id="6" dur="1" fill="hold">
+                                          <p:stCondLst>
+                                            <p:cond delay="0"/>
+                                          </p:stCondLst>
+                                        </p:cTn>
+                                        <p:tgtEl>
+                                          <p:spTgt spid="142">
+                                            <p:txEl>
+                                              <p:pRg st="3" end="3"/>
+                                            </p:txEl>
+                                          </p:spTgt>
+                                        </p:tgtEl>
+                                        <p:attrNameLst>
+                                          <p:attrName>style.visibility</p:attrName>
+                                        </p:attrNameLst>
+                                      </p:cBhvr>
+                                      <p:to>
+                                        <p:strVal val="visible"/>
+                                      </p:to>
+                                    </p:set>
+                                  </p:childTnLst>
+                                </p:cTn>
+                              </p:par>
+                            </p:childTnLst>
+                          </p:cTn>
+                        </p:par>
+                      </p:childTnLst>
+                    </p:cTn>
+                  </p:par>
+                  <p:par>
+                    <p:cTn id="7" fill="hold">
+                      <p:stCondLst>
+                        <p:cond delay="indefinite"/>
+                      </p:stCondLst>
+                      <p:childTnLst>
+                        <p:par>
+                          <p:cTn id="8" fill="hold">
+                            <p:stCondLst>
+                              <p:cond delay="0"/>
+                            </p:stCondLst>
+                            <p:childTnLst>
+                              <p:par>
+                                <p:cTn id="9" presetID="1" presetClass="entr" presetSubtype="0" fill="hold" nodeType="clickEffect">
+                                  <p:stCondLst>
+                                    <p:cond delay="0"/>
+                                  </p:stCondLst>
+                                  <p:childTnLst>
+                                    <p:set>
+                                      <p:cBhvr>
+                                        <p:cTn id="10" dur="1" fill="hold">
+                                          <p:stCondLst>
+                                            <p:cond delay="0"/>
+                                          </p:stCondLst>
+                                        </p:cTn>
+                                        <p:tgtEl>
+                                          <p:spTgt spid="142">
+                                            <p:txEl>
+                                              <p:pRg st="5" end="5"/>
+                                            </p:txEl>
+                                          </p:spTgt>
+                                        </p:tgtEl>
+                                        <p:attrNameLst>
+                                          <p:attrName>style.visibility</p:attrName>
+                                        </p:attrNameLst>
+                                      </p:cBhvr>
+                                      <p:to>
+                                        <p:strVal val="visible"/>
+                                      </p:to>
+                                    </p:set>
+                                  </p:childTnLst>
+                                </p:cTn>
+                              </p:par>
+                            </p:childTnLst>
+                          </p:cTn>
+                        </p:par>
+                      </p:childTnLst>
+                    </p:cTn>
+                  </p:par>
+                  <p:par>
+                    <p:cTn id="11" fill="hold">
+                      <p:stCondLst>
+                        <p:cond delay="indefinite"/>
+                      </p:stCondLst>
+                      <p:childTnLst>
+                        <p:par>
+                          <p:cTn id="12" fill="hold">
+                            <p:stCondLst>
+                              <p:cond delay="0"/>
+                            </p:stCondLst>
+                            <p:childTnLst>
+                              <p:par>
+                                <p:cTn id="13" presetID="1" presetClass="entr" presetSubtype="0" fill="hold" nodeType="clickEffect">
+                                  <p:stCondLst>
+                                    <p:cond delay="0"/>
+                                  </p:stCondLst>
+                                  <p:childTnLst>
+                                    <p:set>
+                                      <p:cBhvr>
+                                        <p:cTn id="14" dur="1" fill="hold">
+                                          <p:stCondLst>
+                                            <p:cond delay="0"/>
+                                          </p:stCondLst>
+                                        </p:cTn>
+                                        <p:tgtEl>
+                                          <p:spTgt spid="142">
+                                            <p:txEl>
+                                              <p:pRg st="6" end="6"/>
+                                            </p:txEl>
+                                          </p:spTgt>
+                                        </p:tgtEl>
+                                        <p:attrNameLst>
+                                          <p:attrName>style.visibility</p:attrName>
+                                        </p:attrNameLst>
+                                      </p:cBhvr>
+                                      <p:to>
+                                        <p:strVal val="visible"/>
+                                      </p:to>
+                                    </p:set>
+                                  </p:childTnLst>
+                                </p:cTn>
+                              </p:par>
+                            </p:childTnLst>
+                          </p:cTn>
+                        </p:par>
+                      </p:childTnLst>
+                    </p:cTn>
+                  </p:par>
+                  <p:par>
+                    <p:cTn id="15" fill="hold">
+                      <p:stCondLst>
+                        <p:cond delay="indefinite"/>
+                      </p:stCondLst>
+                      <p:childTnLst>
+                        <p:par>
+                          <p:cTn id="16" fill="hold">
+                            <p:stCondLst>
+                              <p:cond delay="0"/>
+                            </p:stCondLst>
+                            <p:childTnLst>
+                              <p:par>
+                                <p:cTn id="17" presetID="1" presetClass="entr" presetSubtype="0" fill="hold" nodeType="clickEffect">
+                                  <p:stCondLst>
+                                    <p:cond delay="0"/>
+                                  </p:stCondLst>
+                                  <p:childTnLst>
+                                    <p:set>
+                                      <p:cBhvr>
+                                        <p:cTn id="18" dur="1" fill="hold">
+                                          <p:stCondLst>
+                                            <p:cond delay="0"/>
+                                          </p:stCondLst>
+                                        </p:cTn>
+                                        <p:tgtEl>
+                                          <p:spTgt spid="142">
+                                            <p:txEl>
+                                              <p:pRg st="7" end="7"/>
+                                            </p:txEl>
+                                          </p:spTgt>
+                                        </p:tgtEl>
+                                        <p:attrNameLst>
+                                          <p:attrName>style.visibility</p:attrName>
+                                        </p:attrNameLst>
+                                      </p:cBhvr>
+                                      <p:to>
+                                        <p:strVal val="visible"/>
+                                      </p:to>
+                                    </p:set>
+                                  </p:childTnLst>
+                                </p:cTn>
+                              </p:par>
+                            </p:childTnLst>
+                          </p:cTn>
+                        </p:par>
+                      </p:childTnLst>
+                    </p:cTn>
+                  </p:par>
+                </p:childTnLst>
+              </p:cTn>
+              <p:prevCondLst>
+                <p:cond evt="onPrev" delay="0">
+                  <p:tgtEl>
+                    <p:sldTgt/>
+                  </p:tgtEl>
+                </p:cond>
+              </p:prevCondLst>
+              <p:nextCondLst>
+                <p:cond evt="onNext" delay="0">
+                  <p:tgtEl>
+                    <p:sldTgt/>
+                  </p:tgtEl>
+                </p:cond>
+              </p:nextCondLst>
+            </p:seq>
+          </p:childTnLst>
+        </p:cTn>
+      </p:par>
+    </p:tnLst>
+  </p:timing>
+</p:sld>
+</file>
+
+<file path=ppt/slides/slide5.xml><?xml version="1.0" encoding="utf-8"?>
 <p:sld xmlns:a="http://schemas.openxmlformats.org/drawingml/2006/main" xmlns:r="http://schemas.openxmlformats.org/officeDocument/2006/relationships" xmlns:p="http://schemas.openxmlformats.org/presentationml/2006/main">
   <p:cSld>
     <p:spTree>
@@ -14846,7 +16585,7 @@
 </p:sld>
 </file>
 
-<file path=ppt/slides/slide5.xml><?xml version="1.0" encoding="utf-8"?>
+<file path=ppt/slides/slide6.xml><?xml version="1.0" encoding="utf-8"?>
 <p:sld xmlns:a="http://schemas.openxmlformats.org/drawingml/2006/main" xmlns:r="http://schemas.openxmlformats.org/officeDocument/2006/relationships" xmlns:p="http://schemas.openxmlformats.org/presentationml/2006/main">
   <p:cSld>
     <p:spTree>
@@ -15163,7 +16902,7 @@
 </p:sld>
 </file>
 
-<file path=ppt/slides/slide6.xml><?xml version="1.0" encoding="utf-8"?>
+<file path=ppt/slides/slide7.xml><?xml version="1.0" encoding="utf-8"?>
 <p:sld xmlns:a="http://schemas.openxmlformats.org/drawingml/2006/main" xmlns:r="http://schemas.openxmlformats.org/officeDocument/2006/relationships" xmlns:p="http://schemas.openxmlformats.org/presentationml/2006/main">
   <p:cSld>
     <p:spTree>
@@ -15228,7 +16967,7 @@
 </p:sld>
 </file>
 
-<file path=ppt/slides/slide7.xml><?xml version="1.0" encoding="utf-8"?>
+<file path=ppt/slides/slide8.xml><?xml version="1.0" encoding="utf-8"?>
 <p:sld xmlns:a="http://schemas.openxmlformats.org/drawingml/2006/main" xmlns:r="http://schemas.openxmlformats.org/officeDocument/2006/relationships" xmlns:p="http://schemas.openxmlformats.org/presentationml/2006/main">
   <p:cSld>
     <p:spTree>
@@ -15391,7 +17130,7 @@
 </p:sld>
 </file>
 
-<file path=ppt/slides/slide8.xml><?xml version="1.0" encoding="utf-8"?>
+<file path=ppt/slides/slide9.xml><?xml version="1.0" encoding="utf-8"?>
 <p:sld xmlns:a="http://schemas.openxmlformats.org/drawingml/2006/main" xmlns:r="http://schemas.openxmlformats.org/officeDocument/2006/relationships" xmlns:p="http://schemas.openxmlformats.org/presentationml/2006/main">
   <p:cSld>
     <p:spTree>
@@ -15489,7 +17228,7 @@
         <p:spPr>
           <a:xfrm>
             <a:off x="867673" y="1900079"/>
-            <a:ext cx="9776400" cy="4753865"/>
+            <a:ext cx="9776400" cy="4665123"/>
           </a:xfrm>
           <a:prstGeom prst="rect">
             <a:avLst/>
@@ -15516,29 +17255,6 @@
               <a:buFont typeface="Archivo Medium"/>
               <a:buChar char="•"/>
             </a:pPr>
-            <a:endParaRPr lang="en-US" sz="2006" kern="0" dirty="0">
-              <a:solidFill>
-                <a:srgbClr val="12312B"/>
-              </a:solidFill>
-              <a:highlight>
-                <a:srgbClr val="FFFF00"/>
-              </a:highlight>
-              <a:latin typeface="Archivo Medium"/>
-              <a:sym typeface="Archivo Medium"/>
-            </a:endParaRPr>
-          </a:p>
-          <a:p>
-            <a:pPr marL="433260" lvl="1" indent="-216630" defTabSz="609630">
-              <a:lnSpc>
-                <a:spcPct val="140013"/>
-              </a:lnSpc>
-              <a:buClr>
-                <a:srgbClr val="12312B"/>
-              </a:buClr>
-              <a:buSzPts val="3009"/>
-              <a:buFont typeface="Archivo Medium"/>
-              <a:buChar char="•"/>
-            </a:pPr>
             <a:r>
               <a:rPr lang="en-US" sz="2006" kern="0" dirty="0">
                 <a:solidFill>
@@ -15588,6 +17304,49 @@
                 <a:sym typeface="Archivo Medium"/>
               </a:rPr>
               <a:t>R Projects</a:t>
+            </a:r>
+          </a:p>
+          <a:p>
+            <a:pPr marL="433260" lvl="1" indent="-216630" defTabSz="609630">
+              <a:lnSpc>
+                <a:spcPct val="140013"/>
+              </a:lnSpc>
+              <a:buClr>
+                <a:srgbClr val="12312B"/>
+              </a:buClr>
+              <a:buSzPts val="3009"/>
+              <a:buFont typeface="Archivo Medium"/>
+              <a:buChar char="•"/>
+            </a:pPr>
+            <a:endParaRPr lang="en-US" sz="2006" kern="0" dirty="0">
+              <a:solidFill>
+                <a:srgbClr val="12312B"/>
+              </a:solidFill>
+              <a:latin typeface="Archivo Medium"/>
+              <a:sym typeface="Archivo Medium"/>
+            </a:endParaRPr>
+          </a:p>
+          <a:p>
+            <a:pPr marL="433260" lvl="1" indent="-216630" defTabSz="609630">
+              <a:lnSpc>
+                <a:spcPct val="140013"/>
+              </a:lnSpc>
+              <a:buClr>
+                <a:srgbClr val="12312B"/>
+              </a:buClr>
+              <a:buSzPts val="3009"/>
+              <a:buFont typeface="Archivo Medium"/>
+              <a:buChar char="•"/>
+            </a:pPr>
+            <a:r>
+              <a:rPr lang="en-US" sz="2006" kern="0" dirty="0">
+                <a:solidFill>
+                  <a:srgbClr val="12312B"/>
+                </a:solidFill>
+                <a:latin typeface="Archivo Medium"/>
+                <a:sym typeface="Archivo Medium"/>
+              </a:rPr>
+              <a:t>Quarto documents</a:t>
             </a:r>
           </a:p>
           <a:p>
@@ -15735,19 +17494,6 @@
               </a:rPr>
               <a:t>Learn about packages</a:t>
             </a:r>
-          </a:p>
-          <a:p>
-            <a:pPr marL="433260" lvl="1" indent="-216630" defTabSz="609630">
-              <a:lnSpc>
-                <a:spcPct val="140013"/>
-              </a:lnSpc>
-              <a:buClr>
-                <a:srgbClr val="12312B"/>
-              </a:buClr>
-              <a:buSzPts val="3009"/>
-              <a:buFont typeface="Archivo Medium"/>
-              <a:buChar char="•"/>
-            </a:pPr>
             <a:endParaRPr lang="en-US" sz="2006" kern="0" dirty="0">
               <a:solidFill>
                 <a:srgbClr val="12312B"/>
@@ -15767,377 +17513,6 @@
     <p:extLst>
       <p:ext uri="{BB962C8B-B14F-4D97-AF65-F5344CB8AC3E}">
         <p14:creationId xmlns:p14="http://schemas.microsoft.com/office/powerpoint/2010/main" val="1004716227"/>
-      </p:ext>
-    </p:extLst>
-  </p:cSld>
-  <p:clrMapOvr>
-    <a:masterClrMapping/>
-  </p:clrMapOvr>
-</p:sld>
-</file>
-
-<file path=ppt/slides/slide9.xml><?xml version="1.0" encoding="utf-8"?>
-<p:sld xmlns:a="http://schemas.openxmlformats.org/drawingml/2006/main" xmlns:r="http://schemas.openxmlformats.org/officeDocument/2006/relationships" xmlns:p="http://schemas.openxmlformats.org/presentationml/2006/main">
-  <p:cSld>
-    <p:spTree>
-      <p:nvGrpSpPr>
-        <p:cNvPr id="1" name="Shape 402">
-          <a:extLst>
-            <a:ext uri="{FF2B5EF4-FFF2-40B4-BE49-F238E27FC236}">
-              <a16:creationId xmlns:a16="http://schemas.microsoft.com/office/drawing/2014/main" id="{D19B995F-4F11-003F-071B-0101898D8F3E}"/>
-            </a:ext>
-          </a:extLst>
-        </p:cNvPr>
-        <p:cNvGrpSpPr/>
-        <p:nvPr/>
-      </p:nvGrpSpPr>
-      <p:grpSpPr>
-        <a:xfrm>
-          <a:off x="0" y="0"/>
-          <a:ext cx="0" cy="0"/>
-          <a:chOff x="0" y="0"/>
-          <a:chExt cx="0" cy="0"/>
-        </a:xfrm>
-      </p:grpSpPr>
-      <p:sp>
-        <p:nvSpPr>
-          <p:cNvPr id="403" name="Google Shape;403;p77">
-            <a:extLst>
-              <a:ext uri="{FF2B5EF4-FFF2-40B4-BE49-F238E27FC236}">
-                <a16:creationId xmlns:a16="http://schemas.microsoft.com/office/drawing/2014/main" id="{BBBB5F37-0696-8B6F-E525-4BC94DE9A0ED}"/>
-              </a:ext>
-            </a:extLst>
-          </p:cNvPr>
-          <p:cNvSpPr txBox="1"/>
-          <p:nvPr/>
-        </p:nvSpPr>
-        <p:spPr>
-          <a:xfrm>
-            <a:off x="922201" y="1157695"/>
-            <a:ext cx="6097600" cy="746936"/>
-          </a:xfrm>
-          <a:prstGeom prst="rect">
-            <a:avLst/>
-          </a:prstGeom>
-          <a:noFill/>
-          <a:ln>
-            <a:noFill/>
-          </a:ln>
-        </p:spPr>
-        <p:txBody>
-          <a:bodyPr spcFirstLastPara="1" wrap="square" lIns="0" tIns="0" rIns="0" bIns="0" anchor="t" anchorCtr="0">
-            <a:spAutoFit/>
-          </a:bodyPr>
-          <a:lstStyle/>
-          <a:p>
-            <a:pPr>
-              <a:lnSpc>
-                <a:spcPct val="140007"/>
-              </a:lnSpc>
-            </a:pPr>
-            <a:r>
-              <a:rPr lang="en-US" sz="3467" dirty="0">
-                <a:solidFill>
-                  <a:srgbClr val="00693D"/>
-                </a:solidFill>
-                <a:latin typeface="Anton"/>
-                <a:ea typeface="Anton"/>
-                <a:cs typeface="Anton"/>
-                <a:sym typeface="Anton"/>
-              </a:rPr>
-              <a:t>Project organization</a:t>
-            </a:r>
-            <a:endParaRPr sz="933" dirty="0">
-              <a:solidFill>
-                <a:srgbClr val="000000"/>
-              </a:solidFill>
-              <a:latin typeface="Anton"/>
-              <a:ea typeface="Anton"/>
-              <a:cs typeface="Anton"/>
-              <a:sym typeface="Anton"/>
-            </a:endParaRPr>
-          </a:p>
-        </p:txBody>
-      </p:sp>
-      <p:sp>
-        <p:nvSpPr>
-          <p:cNvPr id="404" name="Google Shape;404;p77">
-            <a:extLst>
-              <a:ext uri="{FF2B5EF4-FFF2-40B4-BE49-F238E27FC236}">
-                <a16:creationId xmlns:a16="http://schemas.microsoft.com/office/drawing/2014/main" id="{5C4BE77C-871F-04F9-5530-4C4BCEF146E7}"/>
-              </a:ext>
-            </a:extLst>
-          </p:cNvPr>
-          <p:cNvSpPr txBox="1"/>
-          <p:nvPr/>
-        </p:nvSpPr>
-        <p:spPr>
-          <a:xfrm>
-            <a:off x="880492" y="1904631"/>
-            <a:ext cx="9776400" cy="4832349"/>
-          </a:xfrm>
-          <a:prstGeom prst="rect">
-            <a:avLst/>
-          </a:prstGeom>
-          <a:noFill/>
-          <a:ln>
-            <a:noFill/>
-          </a:ln>
-        </p:spPr>
-        <p:txBody>
-          <a:bodyPr spcFirstLastPara="1" wrap="square" lIns="0" tIns="0" rIns="0" bIns="0" anchor="t" anchorCtr="0">
-            <a:spAutoFit/>
-          </a:bodyPr>
-          <a:lstStyle/>
-          <a:p>
-            <a:pPr marL="609585">
-              <a:lnSpc>
-                <a:spcPct val="140013"/>
-              </a:lnSpc>
-            </a:pPr>
-            <a:endParaRPr sz="2400" dirty="0">
-              <a:solidFill>
-                <a:srgbClr val="12312B"/>
-              </a:solidFill>
-              <a:latin typeface="Archivo Medium"/>
-              <a:ea typeface="Archivo Medium"/>
-              <a:cs typeface="Archivo Medium"/>
-              <a:sym typeface="Archivo Medium"/>
-            </a:endParaRPr>
-          </a:p>
-          <a:p>
-            <a:pPr marL="433260" lvl="1" indent="-216630" defTabSz="609630">
-              <a:lnSpc>
-                <a:spcPct val="140013"/>
-              </a:lnSpc>
-              <a:buClr>
-                <a:srgbClr val="12312B"/>
-              </a:buClr>
-              <a:buSzPts val="3009"/>
-              <a:buFont typeface="Archivo Medium"/>
-              <a:buChar char="•"/>
-            </a:pPr>
-            <a:r>
-              <a:rPr lang="en-US" sz="2006" kern="0" dirty="0">
-                <a:solidFill>
-                  <a:srgbClr val="12312B"/>
-                </a:solidFill>
-                <a:latin typeface="Archivo Medium"/>
-                <a:cs typeface="Archivo Medium"/>
-                <a:sym typeface="Archivo Medium"/>
-              </a:rPr>
-              <a:t>One folder, one project – store all files for a project in one well-organized folder, with subfolders for</a:t>
-            </a:r>
-          </a:p>
-          <a:p>
-            <a:pPr marL="866521" lvl="2" indent="-288840" defTabSz="609630">
-              <a:lnSpc>
-                <a:spcPct val="140013"/>
-              </a:lnSpc>
-              <a:buClr>
-                <a:srgbClr val="12312B"/>
-              </a:buClr>
-              <a:buSzPts val="3009"/>
-              <a:buFont typeface="Archivo Medium"/>
-              <a:buChar char="⚬"/>
-            </a:pPr>
-            <a:r>
-              <a:rPr lang="en-US" sz="1600" dirty="0">
-                <a:latin typeface="Archivo Medium"/>
-                <a:sym typeface="Archivo Medium"/>
-              </a:rPr>
-              <a:t>Documents (docs)</a:t>
-            </a:r>
-          </a:p>
-          <a:p>
-            <a:pPr marL="866521" lvl="2" indent="-288840" defTabSz="609630">
-              <a:lnSpc>
-                <a:spcPct val="140013"/>
-              </a:lnSpc>
-              <a:buClr>
-                <a:srgbClr val="12312B"/>
-              </a:buClr>
-              <a:buSzPts val="3009"/>
-              <a:buFont typeface="Archivo Medium"/>
-              <a:buChar char="⚬"/>
-            </a:pPr>
-            <a:r>
-              <a:rPr lang="en-US" sz="1600" dirty="0">
-                <a:latin typeface="Archivo Medium"/>
-                <a:sym typeface="Archivo Medium"/>
-              </a:rPr>
-              <a:t>Data</a:t>
-            </a:r>
-          </a:p>
-          <a:p>
-            <a:pPr marL="866521" lvl="2" indent="-288840" defTabSz="609630">
-              <a:lnSpc>
-                <a:spcPct val="140013"/>
-              </a:lnSpc>
-              <a:buClr>
-                <a:srgbClr val="12312B"/>
-              </a:buClr>
-              <a:buSzPts val="3009"/>
-              <a:buFont typeface="Archivo Medium"/>
-              <a:buChar char="⚬"/>
-            </a:pPr>
-            <a:r>
-              <a:rPr lang="en-US" sz="1600" dirty="0">
-                <a:latin typeface="Archivo Medium"/>
-                <a:sym typeface="Archivo Medium"/>
-              </a:rPr>
-              <a:t>Code</a:t>
-            </a:r>
-          </a:p>
-          <a:p>
-            <a:pPr marL="866521" lvl="2" indent="-288840" defTabSz="609630">
-              <a:lnSpc>
-                <a:spcPct val="140013"/>
-              </a:lnSpc>
-              <a:buClr>
-                <a:srgbClr val="12312B"/>
-              </a:buClr>
-              <a:buSzPts val="3009"/>
-              <a:buFont typeface="Archivo Medium"/>
-              <a:buChar char="⚬"/>
-            </a:pPr>
-            <a:r>
-              <a:rPr lang="en-US" sz="1600" dirty="0">
-                <a:latin typeface="Archivo Medium"/>
-                <a:sym typeface="Archivo Medium"/>
-              </a:rPr>
-              <a:t>Output</a:t>
-            </a:r>
-          </a:p>
-          <a:p>
-            <a:pPr marL="866521" lvl="2" indent="-288840" defTabSz="609630">
-              <a:lnSpc>
-                <a:spcPct val="140013"/>
-              </a:lnSpc>
-              <a:buClr>
-                <a:srgbClr val="12312B"/>
-              </a:buClr>
-              <a:buSzPts val="3009"/>
-              <a:buFont typeface="Archivo Medium"/>
-              <a:buChar char="⚬"/>
-            </a:pPr>
-            <a:r>
-              <a:rPr lang="en-US" sz="1600" dirty="0">
-                <a:latin typeface="Archivo Medium"/>
-                <a:sym typeface="Archivo Medium"/>
-              </a:rPr>
-              <a:t>Others as needed</a:t>
-            </a:r>
-            <a:endParaRPr lang="en-US" sz="2006" kern="0" dirty="0">
-              <a:solidFill>
-                <a:srgbClr val="12312B"/>
-              </a:solidFill>
-              <a:latin typeface="Archivo Medium"/>
-              <a:cs typeface="Archivo Medium"/>
-              <a:sym typeface="Archivo Medium"/>
-            </a:endParaRPr>
-          </a:p>
-          <a:p>
-            <a:pPr marL="433260" lvl="1" indent="-216630" defTabSz="609630">
-              <a:lnSpc>
-                <a:spcPct val="140013"/>
-              </a:lnSpc>
-              <a:buClr>
-                <a:srgbClr val="12312B"/>
-              </a:buClr>
-              <a:buSzPts val="3009"/>
-              <a:buFont typeface="Archivo Medium"/>
-              <a:buChar char="•"/>
-            </a:pPr>
-            <a:endParaRPr lang="en-US" sz="2006" kern="0" dirty="0">
-              <a:solidFill>
-                <a:srgbClr val="12312B"/>
-              </a:solidFill>
-              <a:latin typeface="Archivo Medium"/>
-              <a:cs typeface="Archivo Medium"/>
-              <a:sym typeface="Archivo Medium"/>
-            </a:endParaRPr>
-          </a:p>
-          <a:p>
-            <a:pPr marL="433260" lvl="1" indent="-216630" defTabSz="609630">
-              <a:lnSpc>
-                <a:spcPct val="140013"/>
-              </a:lnSpc>
-              <a:buClr>
-                <a:srgbClr val="12312B"/>
-              </a:buClr>
-              <a:buSzPts val="3009"/>
-              <a:buFont typeface="Archivo Medium"/>
-              <a:buChar char="•"/>
-            </a:pPr>
-            <a:r>
-              <a:rPr lang="en-US" sz="2006" kern="0" dirty="0">
-                <a:solidFill>
-                  <a:srgbClr val="12312B"/>
-                </a:solidFill>
-                <a:latin typeface="Archivo Medium"/>
-                <a:cs typeface="Archivo Medium"/>
-                <a:sym typeface="Archivo Medium"/>
-              </a:rPr>
-              <a:t>The materials for today are organized this way and are available here: </a:t>
-            </a:r>
-            <a:r>
-              <a:rPr lang="en-US" sz="2006" kern="0" dirty="0">
-                <a:solidFill>
-                  <a:srgbClr val="12312B"/>
-                </a:solidFill>
-                <a:latin typeface="Archivo Medium"/>
-                <a:cs typeface="Archivo Medium"/>
-                <a:sym typeface="Archivo Medium"/>
-                <a:hlinkClick r:id="rId3"/>
-              </a:rPr>
-              <a:t>https://dartgo.org/r-projects</a:t>
-            </a:r>
-            <a:r>
-              <a:rPr lang="en-US" sz="2006" kern="0" dirty="0">
-                <a:solidFill>
-                  <a:srgbClr val="12312B"/>
-                </a:solidFill>
-                <a:latin typeface="Archivo Medium"/>
-                <a:cs typeface="Archivo Medium"/>
-                <a:sym typeface="Archivo Medium"/>
-              </a:rPr>
-              <a:t> </a:t>
-            </a:r>
-            <a:endParaRPr lang="en-US" sz="2006" kern="0" dirty="0">
-              <a:solidFill>
-                <a:srgbClr val="12312B"/>
-              </a:solidFill>
-              <a:highlight>
-                <a:srgbClr val="FFFF00"/>
-              </a:highlight>
-              <a:latin typeface="Archivo Medium"/>
-              <a:cs typeface="Archivo Medium"/>
-              <a:sym typeface="Archivo Medium"/>
-            </a:endParaRPr>
-          </a:p>
-          <a:p>
-            <a:pPr>
-              <a:lnSpc>
-                <a:spcPct val="140013"/>
-              </a:lnSpc>
-            </a:pPr>
-            <a:endParaRPr sz="2000" dirty="0">
-              <a:solidFill>
-                <a:srgbClr val="12312B"/>
-              </a:solidFill>
-              <a:latin typeface="Arial"/>
-              <a:ea typeface="Arial"/>
-              <a:cs typeface="Arial"/>
-              <a:sym typeface="Arial"/>
-            </a:endParaRPr>
-          </a:p>
-        </p:txBody>
-      </p:sp>
-    </p:spTree>
-    <p:extLst>
-      <p:ext uri="{BB962C8B-B14F-4D97-AF65-F5344CB8AC3E}">
-        <p14:creationId xmlns:p14="http://schemas.microsoft.com/office/powerpoint/2010/main" val="253628221"/>
       </p:ext>
     </p:extLst>
   </p:cSld>

</xml_diff>

<commit_message>
session 1b material update
</commit_message>
<xml_diff>
--- a/slides/01b_R_intro_data_functions.pptx
+++ b/slides/01b_R_intro_data_functions.pptx
@@ -5,7 +5,7 @@
     <p:sldMasterId id="2147483661" r:id="rId1"/>
   </p:sldMasterIdLst>
   <p:notesMasterIdLst>
-    <p:notesMasterId r:id="rId22"/>
+    <p:notesMasterId r:id="rId23"/>
   </p:notesMasterIdLst>
   <p:sldIdLst>
     <p:sldId id="299" r:id="rId2"/>
@@ -19,15 +19,16 @@
     <p:sldId id="384" r:id="rId10"/>
     <p:sldId id="385" r:id="rId11"/>
     <p:sldId id="387" r:id="rId12"/>
-    <p:sldId id="265" r:id="rId13"/>
-    <p:sldId id="386" r:id="rId14"/>
-    <p:sldId id="389" r:id="rId15"/>
-    <p:sldId id="388" r:id="rId16"/>
-    <p:sldId id="390" r:id="rId17"/>
-    <p:sldId id="391" r:id="rId18"/>
-    <p:sldId id="380" r:id="rId19"/>
-    <p:sldId id="395" r:id="rId20"/>
-    <p:sldId id="381" r:id="rId21"/>
+    <p:sldId id="396" r:id="rId13"/>
+    <p:sldId id="388" r:id="rId14"/>
+    <p:sldId id="265" r:id="rId15"/>
+    <p:sldId id="386" r:id="rId16"/>
+    <p:sldId id="389" r:id="rId17"/>
+    <p:sldId id="390" r:id="rId18"/>
+    <p:sldId id="391" r:id="rId19"/>
+    <p:sldId id="380" r:id="rId20"/>
+    <p:sldId id="395" r:id="rId21"/>
+    <p:sldId id="381" r:id="rId22"/>
   </p:sldIdLst>
   <p:sldSz cx="12192000" cy="6858000"/>
   <p:notesSz cx="6858000" cy="9144000"/>
@@ -140,12 +141,20 @@
 </p188:authorLst>
 </file>
 
+<file path=ppt/revisionInfo.xml><?xml version="1.0" encoding="utf-8"?>
+<p1510:revInfo xmlns:a="http://schemas.openxmlformats.org/drawingml/2006/main" xmlns:r="http://schemas.openxmlformats.org/officeDocument/2006/relationships" xmlns:p1510="http://schemas.microsoft.com/office/powerpoint/2015/10/main">
+  <p1510:revLst>
+    <p1510:client id="{8F87CF4E-35EC-43E1-8BD5-AC5B8FE9E056}" v="5" dt="2026-09-01T17:59:17.334"/>
+  </p1510:revLst>
+</p1510:revInfo>
+</file>
+
 <file path=ppt/changesInfos/changesInfo1.xml><?xml version="1.0" encoding="utf-8"?>
 <pc:chgInfo xmlns:a="http://schemas.openxmlformats.org/drawingml/2006/main" xmlns:r="http://schemas.openxmlformats.org/officeDocument/2006/relationships" xmlns:ac="http://schemas.microsoft.com/office/drawing/2013/main/command" xmlns:pc="http://schemas.microsoft.com/office/powerpoint/2013/main/command">
   <pc:docChgLst>
     <pc:chgData name="Katie Owers Bonner" userId="031be739-2ca3-49bb-9134-32c5274b029d" providerId="ADAL" clId="{A2AFF3C0-B35D-4D35-896C-645D8DA4EEB0}"/>
     <pc:docChg chg="undo custSel addSld delSld modSld sldOrd modMainMaster">
-      <pc:chgData name="Katie Owers Bonner" userId="031be739-2ca3-49bb-9134-32c5274b029d" providerId="ADAL" clId="{A2AFF3C0-B35D-4D35-896C-645D8DA4EEB0}" dt="2026-08-31T13:48:03.169" v="756"/>
+      <pc:chgData name="Katie Owers Bonner" userId="031be739-2ca3-49bb-9134-32c5274b029d" providerId="ADAL" clId="{A2AFF3C0-B35D-4D35-896C-645D8DA4EEB0}" dt="2026-09-01T17:59:26.933" v="1513" actId="20577"/>
       <pc:docMkLst>
         <pc:docMk/>
       </pc:docMkLst>
@@ -157,7 +166,7 @@
         </pc:sldMkLst>
       </pc:sldChg>
       <pc:sldChg chg="addSp delSp modSp mod">
-        <pc:chgData name="Katie Owers Bonner" userId="031be739-2ca3-49bb-9134-32c5274b029d" providerId="ADAL" clId="{A2AFF3C0-B35D-4D35-896C-645D8DA4EEB0}" dt="2026-08-31T13:20:09.779" v="710" actId="20577"/>
+        <pc:chgData name="Katie Owers Bonner" userId="031be739-2ca3-49bb-9134-32c5274b029d" providerId="ADAL" clId="{A2AFF3C0-B35D-4D35-896C-645D8DA4EEB0}" dt="2026-09-01T17:24:35.715" v="828" actId="1076"/>
         <pc:sldMkLst>
           <pc:docMk/>
           <pc:sldMk cId="4126705857" sldId="272"/>
@@ -171,7 +180,7 @@
           </ac:spMkLst>
         </pc:spChg>
         <pc:spChg chg="add mod">
-          <ac:chgData name="Katie Owers Bonner" userId="031be739-2ca3-49bb-9134-32c5274b029d" providerId="ADAL" clId="{A2AFF3C0-B35D-4D35-896C-645D8DA4EEB0}" dt="2026-08-31T13:20:09.779" v="710" actId="20577"/>
+          <ac:chgData name="Katie Owers Bonner" userId="031be739-2ca3-49bb-9134-32c5274b029d" providerId="ADAL" clId="{A2AFF3C0-B35D-4D35-896C-645D8DA4EEB0}" dt="2026-09-01T17:24:35.715" v="828" actId="1076"/>
           <ac:spMkLst>
             <pc:docMk/>
             <pc:sldMk cId="4126705857" sldId="272"/>
@@ -187,7 +196,7 @@
           </ac:spMkLst>
         </pc:spChg>
         <pc:spChg chg="mod">
-          <ac:chgData name="Katie Owers Bonner" userId="031be739-2ca3-49bb-9134-32c5274b029d" providerId="ADAL" clId="{A2AFF3C0-B35D-4D35-896C-645D8DA4EEB0}" dt="2026-08-31T13:20:07.936" v="709" actId="20577"/>
+          <ac:chgData name="Katie Owers Bonner" userId="031be739-2ca3-49bb-9134-32c5274b029d" providerId="ADAL" clId="{A2AFF3C0-B35D-4D35-896C-645D8DA4EEB0}" dt="2026-09-01T17:23:56.470" v="807" actId="20577"/>
           <ac:spMkLst>
             <pc:docMk/>
             <pc:sldMk cId="4126705857" sldId="272"/>
@@ -294,7 +303,7 @@
         </pc:sldMkLst>
       </pc:sldChg>
       <pc:sldChg chg="modSp mod">
-        <pc:chgData name="Katie Owers Bonner" userId="031be739-2ca3-49bb-9134-32c5274b029d" providerId="ADAL" clId="{A2AFF3C0-B35D-4D35-896C-645D8DA4EEB0}" dt="2026-08-31T13:37:26.869" v="752" actId="6549"/>
+        <pc:chgData name="Katie Owers Bonner" userId="031be739-2ca3-49bb-9134-32c5274b029d" providerId="ADAL" clId="{A2AFF3C0-B35D-4D35-896C-645D8DA4EEB0}" dt="2026-09-01T17:40:11.341" v="869" actId="5793"/>
         <pc:sldMkLst>
           <pc:docMk/>
           <pc:sldMk cId="1004716227" sldId="384"/>
@@ -308,7 +317,7 @@
           </ac:spMkLst>
         </pc:spChg>
         <pc:spChg chg="mod">
-          <ac:chgData name="Katie Owers Bonner" userId="031be739-2ca3-49bb-9134-32c5274b029d" providerId="ADAL" clId="{A2AFF3C0-B35D-4D35-896C-645D8DA4EEB0}" dt="2026-08-31T13:37:26.869" v="752" actId="6549"/>
+          <ac:chgData name="Katie Owers Bonner" userId="031be739-2ca3-49bb-9134-32c5274b029d" providerId="ADAL" clId="{A2AFF3C0-B35D-4D35-896C-645D8DA4EEB0}" dt="2026-09-01T17:40:11.341" v="869" actId="5793"/>
           <ac:spMkLst>
             <pc:docMk/>
             <pc:sldMk cId="1004716227" sldId="384"/>
@@ -317,13 +326,13 @@
         </pc:spChg>
       </pc:sldChg>
       <pc:sldChg chg="modSp mod">
-        <pc:chgData name="Katie Owers Bonner" userId="031be739-2ca3-49bb-9134-32c5274b029d" providerId="ADAL" clId="{A2AFF3C0-B35D-4D35-896C-645D8DA4EEB0}" dt="2026-08-31T13:28:59.138" v="730" actId="20577"/>
+        <pc:chgData name="Katie Owers Bonner" userId="031be739-2ca3-49bb-9134-32c5274b029d" providerId="ADAL" clId="{A2AFF3C0-B35D-4D35-896C-645D8DA4EEB0}" dt="2026-09-01T17:35:44.016" v="842" actId="5793"/>
         <pc:sldMkLst>
           <pc:docMk/>
           <pc:sldMk cId="253628221" sldId="385"/>
         </pc:sldMkLst>
         <pc:spChg chg="mod">
-          <ac:chgData name="Katie Owers Bonner" userId="031be739-2ca3-49bb-9134-32c5274b029d" providerId="ADAL" clId="{A2AFF3C0-B35D-4D35-896C-645D8DA4EEB0}" dt="2026-08-31T13:28:59.138" v="730" actId="20577"/>
+          <ac:chgData name="Katie Owers Bonner" userId="031be739-2ca3-49bb-9134-32c5274b029d" providerId="ADAL" clId="{A2AFF3C0-B35D-4D35-896C-645D8DA4EEB0}" dt="2026-09-01T17:35:44.016" v="842" actId="5793"/>
           <ac:spMkLst>
             <pc:docMk/>
             <pc:sldMk cId="253628221" sldId="385"/>
@@ -331,12 +340,35 @@
           </ac:spMkLst>
         </pc:spChg>
       </pc:sldChg>
-      <pc:sldChg chg="ord">
-        <pc:chgData name="Katie Owers Bonner" userId="031be739-2ca3-49bb-9134-32c5274b029d" providerId="ADAL" clId="{A2AFF3C0-B35D-4D35-896C-645D8DA4EEB0}" dt="2026-08-31T13:48:03.169" v="756"/>
+      <pc:sldChg chg="modSp add mod">
+        <pc:chgData name="Katie Owers Bonner" userId="031be739-2ca3-49bb-9134-32c5274b029d" providerId="ADAL" clId="{A2AFF3C0-B35D-4D35-896C-645D8DA4EEB0}" dt="2026-09-01T17:59:26.933" v="1513" actId="20577"/>
+        <pc:sldMkLst>
+          <pc:docMk/>
+          <pc:sldMk cId="803544650" sldId="388"/>
+        </pc:sldMkLst>
+        <pc:spChg chg="mod">
+          <ac:chgData name="Katie Owers Bonner" userId="031be739-2ca3-49bb-9134-32c5274b029d" providerId="ADAL" clId="{A2AFF3C0-B35D-4D35-896C-645D8DA4EEB0}" dt="2026-09-01T17:59:26.933" v="1513" actId="20577"/>
+          <ac:spMkLst>
+            <pc:docMk/>
+            <pc:sldMk cId="803544650" sldId="388"/>
+            <ac:spMk id="404" creationId="{CE1441DE-1E48-71E6-EE95-90FE965F0669}"/>
+          </ac:spMkLst>
+        </pc:spChg>
+      </pc:sldChg>
+      <pc:sldChg chg="modSp del mod ord">
+        <pc:chgData name="Katie Owers Bonner" userId="031be739-2ca3-49bb-9134-32c5274b029d" providerId="ADAL" clId="{A2AFF3C0-B35D-4D35-896C-645D8DA4EEB0}" dt="2026-09-01T17:59:15.012" v="1507" actId="2696"/>
         <pc:sldMkLst>
           <pc:docMk/>
           <pc:sldMk cId="2386386992" sldId="388"/>
         </pc:sldMkLst>
+        <pc:spChg chg="mod">
+          <ac:chgData name="Katie Owers Bonner" userId="031be739-2ca3-49bb-9134-32c5274b029d" providerId="ADAL" clId="{A2AFF3C0-B35D-4D35-896C-645D8DA4EEB0}" dt="2026-09-01T17:59:11.264" v="1506" actId="6549"/>
+          <ac:spMkLst>
+            <pc:docMk/>
+            <pc:sldMk cId="2386386992" sldId="388"/>
+            <ac:spMk id="404" creationId="{CE1441DE-1E48-71E6-EE95-90FE965F0669}"/>
+          </ac:spMkLst>
+        </pc:spChg>
       </pc:sldChg>
       <pc:sldChg chg="add del">
         <pc:chgData name="Katie Owers Bonner" userId="031be739-2ca3-49bb-9134-32c5274b029d" providerId="ADAL" clId="{A2AFF3C0-B35D-4D35-896C-645D8DA4EEB0}" dt="2026-08-25T14:30:52.052" v="10" actId="47"/>
@@ -425,6 +457,29 @@
             <pc:docMk/>
             <pc:sldMk cId="3505932459" sldId="395"/>
             <ac:spMk id="135" creationId="{0C15ED0C-A394-9233-F734-6F8EBBB3A9C7}"/>
+          </ac:spMkLst>
+        </pc:spChg>
+      </pc:sldChg>
+      <pc:sldChg chg="modSp add mod">
+        <pc:chgData name="Katie Owers Bonner" userId="031be739-2ca3-49bb-9134-32c5274b029d" providerId="ADAL" clId="{A2AFF3C0-B35D-4D35-896C-645D8DA4EEB0}" dt="2026-09-01T17:42:41.293" v="1505" actId="108"/>
+        <pc:sldMkLst>
+          <pc:docMk/>
+          <pc:sldMk cId="1918343688" sldId="396"/>
+        </pc:sldMkLst>
+        <pc:spChg chg="mod">
+          <ac:chgData name="Katie Owers Bonner" userId="031be739-2ca3-49bb-9134-32c5274b029d" providerId="ADAL" clId="{A2AFF3C0-B35D-4D35-896C-645D8DA4EEB0}" dt="2026-09-01T17:40:19.306" v="894" actId="20577"/>
+          <ac:spMkLst>
+            <pc:docMk/>
+            <pc:sldMk cId="1918343688" sldId="396"/>
+            <ac:spMk id="403" creationId="{08ACD910-0FC3-2C09-C618-51212C0B552D}"/>
+          </ac:spMkLst>
+        </pc:spChg>
+        <pc:spChg chg="mod">
+          <ac:chgData name="Katie Owers Bonner" userId="031be739-2ca3-49bb-9134-32c5274b029d" providerId="ADAL" clId="{A2AFF3C0-B35D-4D35-896C-645D8DA4EEB0}" dt="2026-09-01T17:42:41.293" v="1505" actId="108"/>
+          <ac:spMkLst>
+            <pc:docMk/>
+            <pc:sldMk cId="1918343688" sldId="396"/>
+            <ac:spMk id="404" creationId="{3B05AAFC-9033-2105-BA72-FB829C17E475}"/>
           </ac:spMkLst>
         </pc:spChg>
       </pc:sldChg>
@@ -559,7 +614,7 @@
           <a:p>
             <a:fld id="{F19BCB6A-05C9-45C4-8C56-4DA0982723A6}" type="datetimeFigureOut">
               <a:rPr lang="en-US" smtClean="0"/>
-              <a:t>8/31/2026</a:t>
+              <a:t>9/1/2026</a:t>
             </a:fld>
             <a:endParaRPr lang="en-US"/>
           </a:p>
@@ -1081,6 +1136,298 @@
   <p:cSld>
     <p:spTree>
       <p:nvGrpSpPr>
+        <p:cNvPr id="1" name="Shape 399">
+          <a:extLst>
+            <a:ext uri="{FF2B5EF4-FFF2-40B4-BE49-F238E27FC236}">
+              <a16:creationId xmlns:a16="http://schemas.microsoft.com/office/drawing/2014/main" id="{68185D7F-BF14-3F52-1820-188FADB38B1B}"/>
+            </a:ext>
+          </a:extLst>
+        </p:cNvPr>
+        <p:cNvGrpSpPr/>
+        <p:nvPr/>
+      </p:nvGrpSpPr>
+      <p:grpSpPr>
+        <a:xfrm>
+          <a:off x="0" y="0"/>
+          <a:ext cx="0" cy="0"/>
+          <a:chOff x="0" y="0"/>
+          <a:chExt cx="0" cy="0"/>
+        </a:xfrm>
+      </p:grpSpPr>
+      <p:sp>
+        <p:nvSpPr>
+          <p:cNvPr id="400" name="Google Shape;400;g3b4aedc2736_1_104:notes">
+            <a:extLst>
+              <a:ext uri="{FF2B5EF4-FFF2-40B4-BE49-F238E27FC236}">
+                <a16:creationId xmlns:a16="http://schemas.microsoft.com/office/drawing/2014/main" id="{4C9ADF0E-179A-BCD7-2653-EA6CF95B7CFD}"/>
+              </a:ext>
+            </a:extLst>
+          </p:cNvPr>
+          <p:cNvSpPr txBox="1">
+            <a:spLocks noGrp="1"/>
+          </p:cNvSpPr>
+          <p:nvPr>
+            <p:ph type="body" idx="1"/>
+          </p:nvPr>
+        </p:nvSpPr>
+        <p:spPr>
+          <a:xfrm>
+            <a:off x="685800" y="4343400"/>
+            <a:ext cx="5486400" cy="4114800"/>
+          </a:xfrm>
+          <a:prstGeom prst="rect">
+            <a:avLst/>
+          </a:prstGeom>
+          <a:noFill/>
+          <a:ln>
+            <a:noFill/>
+          </a:ln>
+        </p:spPr>
+        <p:txBody>
+          <a:bodyPr spcFirstLastPara="1" wrap="square" lIns="91425" tIns="91425" rIns="91425" bIns="91425" anchor="t" anchorCtr="0">
+            <a:noAutofit/>
+          </a:bodyPr>
+          <a:lstStyle/>
+          <a:p>
+            <a:pPr marL="0" lvl="0" indent="0" algn="l" rtl="0">
+              <a:spcBef>
+                <a:spcPts val="0"/>
+              </a:spcBef>
+              <a:spcAft>
+                <a:spcPts val="0"/>
+              </a:spcAft>
+              <a:buClr>
+                <a:schemeClr val="dk1"/>
+              </a:buClr>
+              <a:buSzPts val="1200"/>
+              <a:buFont typeface="Arial"/>
+              <a:buNone/>
+            </a:pPr>
+            <a:endParaRPr/>
+          </a:p>
+        </p:txBody>
+      </p:sp>
+      <p:sp>
+        <p:nvSpPr>
+          <p:cNvPr id="401" name="Google Shape;401;g3b4aedc2736_1_104:notes">
+            <a:extLst>
+              <a:ext uri="{FF2B5EF4-FFF2-40B4-BE49-F238E27FC236}">
+                <a16:creationId xmlns:a16="http://schemas.microsoft.com/office/drawing/2014/main" id="{377C0D1C-4FA6-6472-E9B9-9B7FC33A6C68}"/>
+              </a:ext>
+            </a:extLst>
+          </p:cNvPr>
+          <p:cNvSpPr>
+            <a:spLocks noGrp="1" noRot="1" noChangeAspect="1"/>
+          </p:cNvSpPr>
+          <p:nvPr>
+            <p:ph type="sldImg" idx="2"/>
+          </p:nvPr>
+        </p:nvSpPr>
+        <p:spPr>
+          <a:xfrm>
+            <a:off x="381000" y="685800"/>
+            <a:ext cx="6096000" cy="3429000"/>
+          </a:xfrm>
+          <a:custGeom>
+            <a:avLst/>
+            <a:gdLst/>
+            <a:ahLst/>
+            <a:cxnLst/>
+            <a:rect l="l" t="t" r="r" b="b"/>
+            <a:pathLst>
+              <a:path w="120000" h="120000" extrusionOk="0">
+                <a:moveTo>
+                  <a:pt x="0" y="0"/>
+                </a:moveTo>
+                <a:lnTo>
+                  <a:pt x="120000" y="0"/>
+                </a:lnTo>
+                <a:lnTo>
+                  <a:pt x="120000" y="120000"/>
+                </a:lnTo>
+                <a:lnTo>
+                  <a:pt x="0" y="120000"/>
+                </a:lnTo>
+                <a:close/>
+              </a:path>
+            </a:pathLst>
+          </a:custGeom>
+          <a:noFill/>
+          <a:ln w="12700" cap="flat" cmpd="sng">
+            <a:solidFill>
+              <a:srgbClr val="000000"/>
+            </a:solidFill>
+            <a:prstDash val="solid"/>
+            <a:round/>
+            <a:headEnd type="none" w="sm" len="sm"/>
+            <a:tailEnd type="none" w="sm" len="sm"/>
+          </a:ln>
+        </p:spPr>
+      </p:sp>
+    </p:spTree>
+    <p:extLst>
+      <p:ext uri="{BB962C8B-B14F-4D97-AF65-F5344CB8AC3E}">
+        <p14:creationId xmlns:p14="http://schemas.microsoft.com/office/powerpoint/2010/main" val="2917234816"/>
+      </p:ext>
+    </p:extLst>
+  </p:cSld>
+  <p:clrMapOvr>
+    <a:masterClrMapping/>
+  </p:clrMapOvr>
+</p:notes>
+</file>
+
+<file path=ppt/notesSlides/notesSlide12.xml><?xml version="1.0" encoding="utf-8"?>
+<p:notes xmlns:a="http://schemas.openxmlformats.org/drawingml/2006/main" xmlns:r="http://schemas.openxmlformats.org/officeDocument/2006/relationships" xmlns:p="http://schemas.openxmlformats.org/presentationml/2006/main" showMasterSp="0" showMasterPhAnim="0">
+  <p:cSld>
+    <p:spTree>
+      <p:nvGrpSpPr>
+        <p:cNvPr id="1" name="Shape 399">
+          <a:extLst>
+            <a:ext uri="{FF2B5EF4-FFF2-40B4-BE49-F238E27FC236}">
+              <a16:creationId xmlns:a16="http://schemas.microsoft.com/office/drawing/2014/main" id="{34F22D89-3098-F772-6A2C-E8AB6713CFAF}"/>
+            </a:ext>
+          </a:extLst>
+        </p:cNvPr>
+        <p:cNvGrpSpPr/>
+        <p:nvPr/>
+      </p:nvGrpSpPr>
+      <p:grpSpPr>
+        <a:xfrm>
+          <a:off x="0" y="0"/>
+          <a:ext cx="0" cy="0"/>
+          <a:chOff x="0" y="0"/>
+          <a:chExt cx="0" cy="0"/>
+        </a:xfrm>
+      </p:grpSpPr>
+      <p:sp>
+        <p:nvSpPr>
+          <p:cNvPr id="400" name="Google Shape;400;g3b4aedc2736_1_104:notes">
+            <a:extLst>
+              <a:ext uri="{FF2B5EF4-FFF2-40B4-BE49-F238E27FC236}">
+                <a16:creationId xmlns:a16="http://schemas.microsoft.com/office/drawing/2014/main" id="{67E83DA5-1B8C-A466-EDE7-107175B5A945}"/>
+              </a:ext>
+            </a:extLst>
+          </p:cNvPr>
+          <p:cNvSpPr txBox="1">
+            <a:spLocks noGrp="1"/>
+          </p:cNvSpPr>
+          <p:nvPr>
+            <p:ph type="body" idx="1"/>
+          </p:nvPr>
+        </p:nvSpPr>
+        <p:spPr>
+          <a:xfrm>
+            <a:off x="685800" y="4343400"/>
+            <a:ext cx="5486400" cy="4114800"/>
+          </a:xfrm>
+          <a:prstGeom prst="rect">
+            <a:avLst/>
+          </a:prstGeom>
+          <a:noFill/>
+          <a:ln>
+            <a:noFill/>
+          </a:ln>
+        </p:spPr>
+        <p:txBody>
+          <a:bodyPr spcFirstLastPara="1" wrap="square" lIns="91425" tIns="91425" rIns="91425" bIns="91425" anchor="t" anchorCtr="0">
+            <a:noAutofit/>
+          </a:bodyPr>
+          <a:lstStyle/>
+          <a:p>
+            <a:pPr marL="0" lvl="0" indent="0" algn="l" rtl="0">
+              <a:spcBef>
+                <a:spcPts val="0"/>
+              </a:spcBef>
+              <a:spcAft>
+                <a:spcPts val="0"/>
+              </a:spcAft>
+              <a:buClr>
+                <a:schemeClr val="dk1"/>
+              </a:buClr>
+              <a:buSzPts val="1200"/>
+              <a:buFont typeface="Arial"/>
+              <a:buNone/>
+            </a:pPr>
+            <a:endParaRPr/>
+          </a:p>
+        </p:txBody>
+      </p:sp>
+      <p:sp>
+        <p:nvSpPr>
+          <p:cNvPr id="401" name="Google Shape;401;g3b4aedc2736_1_104:notes">
+            <a:extLst>
+              <a:ext uri="{FF2B5EF4-FFF2-40B4-BE49-F238E27FC236}">
+                <a16:creationId xmlns:a16="http://schemas.microsoft.com/office/drawing/2014/main" id="{FC1B0303-9825-AF45-0DBC-14F560F912BA}"/>
+              </a:ext>
+            </a:extLst>
+          </p:cNvPr>
+          <p:cNvSpPr>
+            <a:spLocks noGrp="1" noRot="1" noChangeAspect="1"/>
+          </p:cNvSpPr>
+          <p:nvPr>
+            <p:ph type="sldImg" idx="2"/>
+          </p:nvPr>
+        </p:nvSpPr>
+        <p:spPr>
+          <a:xfrm>
+            <a:off x="381000" y="685800"/>
+            <a:ext cx="6096000" cy="3429000"/>
+          </a:xfrm>
+          <a:custGeom>
+            <a:avLst/>
+            <a:gdLst/>
+            <a:ahLst/>
+            <a:cxnLst/>
+            <a:rect l="l" t="t" r="r" b="b"/>
+            <a:pathLst>
+              <a:path w="120000" h="120000" extrusionOk="0">
+                <a:moveTo>
+                  <a:pt x="0" y="0"/>
+                </a:moveTo>
+                <a:lnTo>
+                  <a:pt x="120000" y="0"/>
+                </a:lnTo>
+                <a:lnTo>
+                  <a:pt x="120000" y="120000"/>
+                </a:lnTo>
+                <a:lnTo>
+                  <a:pt x="0" y="120000"/>
+                </a:lnTo>
+                <a:close/>
+              </a:path>
+            </a:pathLst>
+          </a:custGeom>
+          <a:noFill/>
+          <a:ln w="12700" cap="flat" cmpd="sng">
+            <a:solidFill>
+              <a:srgbClr val="000000"/>
+            </a:solidFill>
+            <a:prstDash val="solid"/>
+            <a:round/>
+            <a:headEnd type="none" w="sm" len="sm"/>
+            <a:tailEnd type="none" w="sm" len="sm"/>
+          </a:ln>
+        </p:spPr>
+      </p:sp>
+    </p:spTree>
+    <p:extLst>
+      <p:ext uri="{BB962C8B-B14F-4D97-AF65-F5344CB8AC3E}">
+        <p14:creationId xmlns:p14="http://schemas.microsoft.com/office/powerpoint/2010/main" val="1507917608"/>
+      </p:ext>
+    </p:extLst>
+  </p:cSld>
+  <p:clrMapOvr>
+    <a:masterClrMapping/>
+  </p:clrMapOvr>
+</p:notes>
+</file>
+
+<file path=ppt/notesSlides/notesSlide13.xml><?xml version="1.0" encoding="utf-8"?>
+<p:notes xmlns:a="http://schemas.openxmlformats.org/drawingml/2006/main" xmlns:r="http://schemas.openxmlformats.org/officeDocument/2006/relationships" xmlns:p="http://schemas.openxmlformats.org/presentationml/2006/main" showMasterSp="0" showMasterPhAnim="0">
+  <p:cSld>
+    <p:spTree>
+      <p:nvGrpSpPr>
         <p:cNvPr id="1" name="Shape 399"/>
         <p:cNvGrpSpPr/>
         <p:nvPr/>
@@ -1199,7 +1546,7 @@
 </p:notes>
 </file>
 
-<file path=ppt/notesSlides/notesSlide12.xml><?xml version="1.0" encoding="utf-8"?>
+<file path=ppt/notesSlides/notesSlide14.xml><?xml version="1.0" encoding="utf-8"?>
 <p:notes xmlns:a="http://schemas.openxmlformats.org/drawingml/2006/main" xmlns:r="http://schemas.openxmlformats.org/officeDocument/2006/relationships" xmlns:p="http://schemas.openxmlformats.org/presentationml/2006/main" showMasterSp="0" showMasterPhAnim="0">
   <p:cSld>
     <p:spTree>
@@ -1345,7 +1692,7 @@
 </p:notes>
 </file>
 
-<file path=ppt/notesSlides/notesSlide13.xml><?xml version="1.0" encoding="utf-8"?>
+<file path=ppt/notesSlides/notesSlide15.xml><?xml version="1.0" encoding="utf-8"?>
 <p:notes xmlns:a="http://schemas.openxmlformats.org/drawingml/2006/main" xmlns:r="http://schemas.openxmlformats.org/officeDocument/2006/relationships" xmlns:p="http://schemas.openxmlformats.org/presentationml/2006/main" showMasterSp="0" showMasterPhAnim="0">
   <p:cSld>
     <p:spTree>
@@ -1491,153 +1838,7 @@
 </p:notes>
 </file>
 
-<file path=ppt/notesSlides/notesSlide14.xml><?xml version="1.0" encoding="utf-8"?>
-<p:notes xmlns:a="http://schemas.openxmlformats.org/drawingml/2006/main" xmlns:r="http://schemas.openxmlformats.org/officeDocument/2006/relationships" xmlns:p="http://schemas.openxmlformats.org/presentationml/2006/main" showMasterSp="0" showMasterPhAnim="0">
-  <p:cSld>
-    <p:spTree>
-      <p:nvGrpSpPr>
-        <p:cNvPr id="1" name="Shape 399">
-          <a:extLst>
-            <a:ext uri="{FF2B5EF4-FFF2-40B4-BE49-F238E27FC236}">
-              <a16:creationId xmlns:a16="http://schemas.microsoft.com/office/drawing/2014/main" id="{34F22D89-3098-F772-6A2C-E8AB6713CFAF}"/>
-            </a:ext>
-          </a:extLst>
-        </p:cNvPr>
-        <p:cNvGrpSpPr/>
-        <p:nvPr/>
-      </p:nvGrpSpPr>
-      <p:grpSpPr>
-        <a:xfrm>
-          <a:off x="0" y="0"/>
-          <a:ext cx="0" cy="0"/>
-          <a:chOff x="0" y="0"/>
-          <a:chExt cx="0" cy="0"/>
-        </a:xfrm>
-      </p:grpSpPr>
-      <p:sp>
-        <p:nvSpPr>
-          <p:cNvPr id="400" name="Google Shape;400;g3b4aedc2736_1_104:notes">
-            <a:extLst>
-              <a:ext uri="{FF2B5EF4-FFF2-40B4-BE49-F238E27FC236}">
-                <a16:creationId xmlns:a16="http://schemas.microsoft.com/office/drawing/2014/main" id="{67E83DA5-1B8C-A466-EDE7-107175B5A945}"/>
-              </a:ext>
-            </a:extLst>
-          </p:cNvPr>
-          <p:cNvSpPr txBox="1">
-            <a:spLocks noGrp="1"/>
-          </p:cNvSpPr>
-          <p:nvPr>
-            <p:ph type="body" idx="1"/>
-          </p:nvPr>
-        </p:nvSpPr>
-        <p:spPr>
-          <a:xfrm>
-            <a:off x="685800" y="4343400"/>
-            <a:ext cx="5486400" cy="4114800"/>
-          </a:xfrm>
-          <a:prstGeom prst="rect">
-            <a:avLst/>
-          </a:prstGeom>
-          <a:noFill/>
-          <a:ln>
-            <a:noFill/>
-          </a:ln>
-        </p:spPr>
-        <p:txBody>
-          <a:bodyPr spcFirstLastPara="1" wrap="square" lIns="91425" tIns="91425" rIns="91425" bIns="91425" anchor="t" anchorCtr="0">
-            <a:noAutofit/>
-          </a:bodyPr>
-          <a:lstStyle/>
-          <a:p>
-            <a:pPr marL="0" lvl="0" indent="0" algn="l" rtl="0">
-              <a:spcBef>
-                <a:spcPts val="0"/>
-              </a:spcBef>
-              <a:spcAft>
-                <a:spcPts val="0"/>
-              </a:spcAft>
-              <a:buClr>
-                <a:schemeClr val="dk1"/>
-              </a:buClr>
-              <a:buSzPts val="1200"/>
-              <a:buFont typeface="Arial"/>
-              <a:buNone/>
-            </a:pPr>
-            <a:endParaRPr/>
-          </a:p>
-        </p:txBody>
-      </p:sp>
-      <p:sp>
-        <p:nvSpPr>
-          <p:cNvPr id="401" name="Google Shape;401;g3b4aedc2736_1_104:notes">
-            <a:extLst>
-              <a:ext uri="{FF2B5EF4-FFF2-40B4-BE49-F238E27FC236}">
-                <a16:creationId xmlns:a16="http://schemas.microsoft.com/office/drawing/2014/main" id="{FC1B0303-9825-AF45-0DBC-14F560F912BA}"/>
-              </a:ext>
-            </a:extLst>
-          </p:cNvPr>
-          <p:cNvSpPr>
-            <a:spLocks noGrp="1" noRot="1" noChangeAspect="1"/>
-          </p:cNvSpPr>
-          <p:nvPr>
-            <p:ph type="sldImg" idx="2"/>
-          </p:nvPr>
-        </p:nvSpPr>
-        <p:spPr>
-          <a:xfrm>
-            <a:off x="381000" y="685800"/>
-            <a:ext cx="6096000" cy="3429000"/>
-          </a:xfrm>
-          <a:custGeom>
-            <a:avLst/>
-            <a:gdLst/>
-            <a:ahLst/>
-            <a:cxnLst/>
-            <a:rect l="l" t="t" r="r" b="b"/>
-            <a:pathLst>
-              <a:path w="120000" h="120000" extrusionOk="0">
-                <a:moveTo>
-                  <a:pt x="0" y="0"/>
-                </a:moveTo>
-                <a:lnTo>
-                  <a:pt x="120000" y="0"/>
-                </a:lnTo>
-                <a:lnTo>
-                  <a:pt x="120000" y="120000"/>
-                </a:lnTo>
-                <a:lnTo>
-                  <a:pt x="0" y="120000"/>
-                </a:lnTo>
-                <a:close/>
-              </a:path>
-            </a:pathLst>
-          </a:custGeom>
-          <a:noFill/>
-          <a:ln w="12700" cap="flat" cmpd="sng">
-            <a:solidFill>
-              <a:srgbClr val="000000"/>
-            </a:solidFill>
-            <a:prstDash val="solid"/>
-            <a:round/>
-            <a:headEnd type="none" w="sm" len="sm"/>
-            <a:tailEnd type="none" w="sm" len="sm"/>
-          </a:ln>
-        </p:spPr>
-      </p:sp>
-    </p:spTree>
-    <p:extLst>
-      <p:ext uri="{BB962C8B-B14F-4D97-AF65-F5344CB8AC3E}">
-        <p14:creationId xmlns:p14="http://schemas.microsoft.com/office/powerpoint/2010/main" val="804786023"/>
-      </p:ext>
-    </p:extLst>
-  </p:cSld>
-  <p:clrMapOvr>
-    <a:masterClrMapping/>
-  </p:clrMapOvr>
-</p:notes>
-</file>
-
-<file path=ppt/notesSlides/notesSlide15.xml><?xml version="1.0" encoding="utf-8"?>
+<file path=ppt/notesSlides/notesSlide16.xml><?xml version="1.0" encoding="utf-8"?>
 <p:notes xmlns:a="http://schemas.openxmlformats.org/drawingml/2006/main" xmlns:r="http://schemas.openxmlformats.org/officeDocument/2006/relationships" xmlns:p="http://schemas.openxmlformats.org/presentationml/2006/main" showMasterSp="0" showMasterPhAnim="0">
   <p:cSld>
     <p:spTree>
@@ -1783,7 +1984,7 @@
 </p:notes>
 </file>
 
-<file path=ppt/notesSlides/notesSlide16.xml><?xml version="1.0" encoding="utf-8"?>
+<file path=ppt/notesSlides/notesSlide17.xml><?xml version="1.0" encoding="utf-8"?>
 <p:notes xmlns:a="http://schemas.openxmlformats.org/drawingml/2006/main" xmlns:r="http://schemas.openxmlformats.org/officeDocument/2006/relationships" xmlns:p="http://schemas.openxmlformats.org/presentationml/2006/main" showMasterSp="0" showMasterPhAnim="0">
   <p:cSld>
     <p:spTree>
@@ -1910,7 +2111,7 @@
 </p:notes>
 </file>
 
-<file path=ppt/notesSlides/notesSlide17.xml><?xml version="1.0" encoding="utf-8"?>
+<file path=ppt/notesSlides/notesSlide18.xml><?xml version="1.0" encoding="utf-8"?>
 <p:notes xmlns:a="http://schemas.openxmlformats.org/drawingml/2006/main" xmlns:r="http://schemas.openxmlformats.org/officeDocument/2006/relationships" xmlns:p="http://schemas.openxmlformats.org/presentationml/2006/main" showMasterSp="0" showMasterPhAnim="0">
   <p:cSld>
     <p:spTree>
@@ -2037,7 +2238,7 @@
 </p:notes>
 </file>
 
-<file path=ppt/notesSlides/notesSlide18.xml><?xml version="1.0" encoding="utf-8"?>
+<file path=ppt/notesSlides/notesSlide19.xml><?xml version="1.0" encoding="utf-8"?>
 <p:notes xmlns:a="http://schemas.openxmlformats.org/drawingml/2006/main" xmlns:r="http://schemas.openxmlformats.org/officeDocument/2006/relationships" xmlns:p="http://schemas.openxmlformats.org/presentationml/2006/main" showMasterSp="0" showMasterPhAnim="0">
   <p:cSld>
     <p:spTree>
@@ -2155,133 +2356,6 @@
     <p:extLst>
       <p:ext uri="{BB962C8B-B14F-4D97-AF65-F5344CB8AC3E}">
         <p14:creationId xmlns:p14="http://schemas.microsoft.com/office/powerpoint/2010/main" val="2958105343"/>
-      </p:ext>
-    </p:extLst>
-  </p:cSld>
-  <p:clrMapOvr>
-    <a:masterClrMapping/>
-  </p:clrMapOvr>
-</p:notes>
-</file>
-
-<file path=ppt/notesSlides/notesSlide19.xml><?xml version="1.0" encoding="utf-8"?>
-<p:notes xmlns:a="http://schemas.openxmlformats.org/drawingml/2006/main" xmlns:r="http://schemas.openxmlformats.org/officeDocument/2006/relationships" xmlns:p="http://schemas.openxmlformats.org/presentationml/2006/main" showMasterSp="0" showMasterPhAnim="0">
-  <p:cSld>
-    <p:spTree>
-      <p:nvGrpSpPr>
-        <p:cNvPr id="1" name="Shape 136">
-          <a:extLst>
-            <a:ext uri="{FF2B5EF4-FFF2-40B4-BE49-F238E27FC236}">
-              <a16:creationId xmlns:a16="http://schemas.microsoft.com/office/drawing/2014/main" id="{B49412A7-B15D-7A44-A17D-698E2D072C5A}"/>
-            </a:ext>
-          </a:extLst>
-        </p:cNvPr>
-        <p:cNvGrpSpPr/>
-        <p:nvPr/>
-      </p:nvGrpSpPr>
-      <p:grpSpPr>
-        <a:xfrm>
-          <a:off x="0" y="0"/>
-          <a:ext cx="0" cy="0"/>
-          <a:chOff x="0" y="0"/>
-          <a:chExt cx="0" cy="0"/>
-        </a:xfrm>
-      </p:grpSpPr>
-      <p:sp>
-        <p:nvSpPr>
-          <p:cNvPr id="137" name="Google Shape;137;p5:notes">
-            <a:extLst>
-              <a:ext uri="{FF2B5EF4-FFF2-40B4-BE49-F238E27FC236}">
-                <a16:creationId xmlns:a16="http://schemas.microsoft.com/office/drawing/2014/main" id="{F40A2094-F6A4-54B3-0F79-12B4B2BF6A4F}"/>
-              </a:ext>
-            </a:extLst>
-          </p:cNvPr>
-          <p:cNvSpPr txBox="1">
-            <a:spLocks noGrp="1"/>
-          </p:cNvSpPr>
-          <p:nvPr>
-            <p:ph type="body" idx="1"/>
-          </p:nvPr>
-        </p:nvSpPr>
-        <p:spPr>
-          <a:xfrm>
-            <a:off x="685800" y="4343400"/>
-            <a:ext cx="5486400" cy="4114800"/>
-          </a:xfrm>
-          <a:prstGeom prst="rect">
-            <a:avLst/>
-          </a:prstGeom>
-        </p:spPr>
-        <p:txBody>
-          <a:bodyPr spcFirstLastPara="1" wrap="square" lIns="91425" tIns="91425" rIns="91425" bIns="91425" anchor="t" anchorCtr="0">
-            <a:noAutofit/>
-          </a:bodyPr>
-          <a:lstStyle/>
-          <a:p>
-            <a:pPr marL="0" lvl="0" indent="0" algn="l" rtl="0">
-              <a:spcBef>
-                <a:spcPts val="0"/>
-              </a:spcBef>
-              <a:spcAft>
-                <a:spcPts val="0"/>
-              </a:spcAft>
-              <a:buNone/>
-            </a:pPr>
-            <a:endParaRPr dirty="0"/>
-          </a:p>
-        </p:txBody>
-      </p:sp>
-      <p:sp>
-        <p:nvSpPr>
-          <p:cNvPr id="138" name="Google Shape;138;p5:notes">
-            <a:extLst>
-              <a:ext uri="{FF2B5EF4-FFF2-40B4-BE49-F238E27FC236}">
-                <a16:creationId xmlns:a16="http://schemas.microsoft.com/office/drawing/2014/main" id="{290747B7-16A5-C89F-60C4-B0FF6670EAAD}"/>
-              </a:ext>
-            </a:extLst>
-          </p:cNvPr>
-          <p:cNvSpPr>
-            <a:spLocks noGrp="1" noRot="1" noChangeAspect="1"/>
-          </p:cNvSpPr>
-          <p:nvPr>
-            <p:ph type="sldImg" idx="2"/>
-          </p:nvPr>
-        </p:nvSpPr>
-        <p:spPr>
-          <a:xfrm>
-            <a:off x="381000" y="685800"/>
-            <a:ext cx="6096000" cy="3429000"/>
-          </a:xfrm>
-          <a:custGeom>
-            <a:avLst/>
-            <a:gdLst/>
-            <a:ahLst/>
-            <a:cxnLst/>
-            <a:rect l="l" t="t" r="r" b="b"/>
-            <a:pathLst>
-              <a:path w="120000" h="120000" extrusionOk="0">
-                <a:moveTo>
-                  <a:pt x="0" y="0"/>
-                </a:moveTo>
-                <a:lnTo>
-                  <a:pt x="120000" y="0"/>
-                </a:lnTo>
-                <a:lnTo>
-                  <a:pt x="120000" y="120000"/>
-                </a:lnTo>
-                <a:lnTo>
-                  <a:pt x="0" y="120000"/>
-                </a:lnTo>
-                <a:close/>
-              </a:path>
-            </a:pathLst>
-          </a:custGeom>
-        </p:spPr>
-      </p:sp>
-    </p:spTree>
-    <p:extLst>
-      <p:ext uri="{BB962C8B-B14F-4D97-AF65-F5344CB8AC3E}">
-        <p14:creationId xmlns:p14="http://schemas.microsoft.com/office/powerpoint/2010/main" val="142371176"/>
       </p:ext>
     </p:extLst>
   </p:cSld>
@@ -2409,6 +2483,133 @@
     <p:extLst>
       <p:ext uri="{BB962C8B-B14F-4D97-AF65-F5344CB8AC3E}">
         <p14:creationId xmlns:p14="http://schemas.microsoft.com/office/powerpoint/2010/main" val="1730492483"/>
+      </p:ext>
+    </p:extLst>
+  </p:cSld>
+  <p:clrMapOvr>
+    <a:masterClrMapping/>
+  </p:clrMapOvr>
+</p:notes>
+</file>
+
+<file path=ppt/notesSlides/notesSlide20.xml><?xml version="1.0" encoding="utf-8"?>
+<p:notes xmlns:a="http://schemas.openxmlformats.org/drawingml/2006/main" xmlns:r="http://schemas.openxmlformats.org/officeDocument/2006/relationships" xmlns:p="http://schemas.openxmlformats.org/presentationml/2006/main" showMasterSp="0" showMasterPhAnim="0">
+  <p:cSld>
+    <p:spTree>
+      <p:nvGrpSpPr>
+        <p:cNvPr id="1" name="Shape 136">
+          <a:extLst>
+            <a:ext uri="{FF2B5EF4-FFF2-40B4-BE49-F238E27FC236}">
+              <a16:creationId xmlns:a16="http://schemas.microsoft.com/office/drawing/2014/main" id="{B49412A7-B15D-7A44-A17D-698E2D072C5A}"/>
+            </a:ext>
+          </a:extLst>
+        </p:cNvPr>
+        <p:cNvGrpSpPr/>
+        <p:nvPr/>
+      </p:nvGrpSpPr>
+      <p:grpSpPr>
+        <a:xfrm>
+          <a:off x="0" y="0"/>
+          <a:ext cx="0" cy="0"/>
+          <a:chOff x="0" y="0"/>
+          <a:chExt cx="0" cy="0"/>
+        </a:xfrm>
+      </p:grpSpPr>
+      <p:sp>
+        <p:nvSpPr>
+          <p:cNvPr id="137" name="Google Shape;137;p5:notes">
+            <a:extLst>
+              <a:ext uri="{FF2B5EF4-FFF2-40B4-BE49-F238E27FC236}">
+                <a16:creationId xmlns:a16="http://schemas.microsoft.com/office/drawing/2014/main" id="{F40A2094-F6A4-54B3-0F79-12B4B2BF6A4F}"/>
+              </a:ext>
+            </a:extLst>
+          </p:cNvPr>
+          <p:cNvSpPr txBox="1">
+            <a:spLocks noGrp="1"/>
+          </p:cNvSpPr>
+          <p:nvPr>
+            <p:ph type="body" idx="1"/>
+          </p:nvPr>
+        </p:nvSpPr>
+        <p:spPr>
+          <a:xfrm>
+            <a:off x="685800" y="4343400"/>
+            <a:ext cx="5486400" cy="4114800"/>
+          </a:xfrm>
+          <a:prstGeom prst="rect">
+            <a:avLst/>
+          </a:prstGeom>
+        </p:spPr>
+        <p:txBody>
+          <a:bodyPr spcFirstLastPara="1" wrap="square" lIns="91425" tIns="91425" rIns="91425" bIns="91425" anchor="t" anchorCtr="0">
+            <a:noAutofit/>
+          </a:bodyPr>
+          <a:lstStyle/>
+          <a:p>
+            <a:pPr marL="0" lvl="0" indent="0" algn="l" rtl="0">
+              <a:spcBef>
+                <a:spcPts val="0"/>
+              </a:spcBef>
+              <a:spcAft>
+                <a:spcPts val="0"/>
+              </a:spcAft>
+              <a:buNone/>
+            </a:pPr>
+            <a:endParaRPr dirty="0"/>
+          </a:p>
+        </p:txBody>
+      </p:sp>
+      <p:sp>
+        <p:nvSpPr>
+          <p:cNvPr id="138" name="Google Shape;138;p5:notes">
+            <a:extLst>
+              <a:ext uri="{FF2B5EF4-FFF2-40B4-BE49-F238E27FC236}">
+                <a16:creationId xmlns:a16="http://schemas.microsoft.com/office/drawing/2014/main" id="{290747B7-16A5-C89F-60C4-B0FF6670EAAD}"/>
+              </a:ext>
+            </a:extLst>
+          </p:cNvPr>
+          <p:cNvSpPr>
+            <a:spLocks noGrp="1" noRot="1" noChangeAspect="1"/>
+          </p:cNvSpPr>
+          <p:nvPr>
+            <p:ph type="sldImg" idx="2"/>
+          </p:nvPr>
+        </p:nvSpPr>
+        <p:spPr>
+          <a:xfrm>
+            <a:off x="381000" y="685800"/>
+            <a:ext cx="6096000" cy="3429000"/>
+          </a:xfrm>
+          <a:custGeom>
+            <a:avLst/>
+            <a:gdLst/>
+            <a:ahLst/>
+            <a:cxnLst/>
+            <a:rect l="l" t="t" r="r" b="b"/>
+            <a:pathLst>
+              <a:path w="120000" h="120000" extrusionOk="0">
+                <a:moveTo>
+                  <a:pt x="0" y="0"/>
+                </a:moveTo>
+                <a:lnTo>
+                  <a:pt x="120000" y="0"/>
+                </a:lnTo>
+                <a:lnTo>
+                  <a:pt x="120000" y="120000"/>
+                </a:lnTo>
+                <a:lnTo>
+                  <a:pt x="0" y="120000"/>
+                </a:lnTo>
+                <a:close/>
+              </a:path>
+            </a:pathLst>
+          </a:custGeom>
+        </p:spPr>
+      </p:sp>
+    </p:spTree>
+    <p:extLst>
+      <p:ext uri="{BB962C8B-B14F-4D97-AF65-F5344CB8AC3E}">
+        <p14:creationId xmlns:p14="http://schemas.microsoft.com/office/powerpoint/2010/main" val="142371176"/>
       </p:ext>
     </p:extLst>
   </p:cSld>
@@ -8108,6 +8309,13 @@
             <a:noFill/>
           </a:ln>
         </p:spPr>
+        <p:txBody>
+          <a:bodyPr/>
+          <a:lstStyle/>
+          <a:p>
+            <a:endParaRPr lang="en-US"/>
+          </a:p>
+        </p:txBody>
       </p:sp>
     </p:spTree>
     <p:extLst>
@@ -11596,7 +11804,7 @@
         <p:spPr>
           <a:xfrm>
             <a:off x="880492" y="1904631"/>
-            <a:ext cx="9776400" cy="4832349"/>
+            <a:ext cx="9776400" cy="4833631"/>
           </a:xfrm>
           <a:prstGeom prst="rect">
             <a:avLst/>
@@ -11648,7 +11856,52 @@
                 <a:cs typeface="Archivo Medium"/>
                 <a:sym typeface="Archivo Medium"/>
               </a:rPr>
-              <a:t>One folder, one project – store all files for a project in one well-organized folder, with subfolders for</a:t>
+              <a:t>One folder, one project – store all files for a project in one well-organized folder</a:t>
+            </a:r>
+          </a:p>
+          <a:p>
+            <a:pPr marL="433260" lvl="1" indent="-216630" defTabSz="609630">
+              <a:lnSpc>
+                <a:spcPct val="140013"/>
+              </a:lnSpc>
+              <a:buClr>
+                <a:srgbClr val="12312B"/>
+              </a:buClr>
+              <a:buSzPts val="3009"/>
+              <a:buFont typeface="Archivo Medium"/>
+              <a:buChar char="•"/>
+            </a:pPr>
+            <a:endParaRPr lang="en-US" sz="2006" kern="0" dirty="0">
+              <a:solidFill>
+                <a:srgbClr val="12312B"/>
+              </a:solidFill>
+              <a:latin typeface="Archivo Medium"/>
+              <a:cs typeface="Archivo Medium"/>
+              <a:sym typeface="Archivo Medium"/>
+            </a:endParaRPr>
+          </a:p>
+          <a:p>
+            <a:pPr marL="433260" lvl="1" indent="-216630" defTabSz="609630">
+              <a:lnSpc>
+                <a:spcPct val="140013"/>
+              </a:lnSpc>
+              <a:buClr>
+                <a:srgbClr val="12312B"/>
+              </a:buClr>
+              <a:buSzPts val="3009"/>
+              <a:buFont typeface="Archivo Medium"/>
+              <a:buChar char="•"/>
+            </a:pPr>
+            <a:r>
+              <a:rPr lang="en-US" sz="2006" kern="0" dirty="0">
+                <a:solidFill>
+                  <a:srgbClr val="12312B"/>
+                </a:solidFill>
+                <a:latin typeface="Archivo Medium"/>
+                <a:cs typeface="Archivo Medium"/>
+                <a:sym typeface="Archivo Medium"/>
+              </a:rPr>
+              <a:t>Use subfolders for</a:t>
             </a:r>
           </a:p>
           <a:p>
@@ -11808,37 +12061,13 @@
                 <a:solidFill>
                   <a:srgbClr val="12312B"/>
                 </a:solidFill>
-                <a:highlight>
-                  <a:srgbClr val="FFFF00"/>
-                </a:highlight>
                 <a:latin typeface="Archivo Medium"/>
                 <a:cs typeface="Archivo Medium"/>
                 <a:sym typeface="Archivo Medium"/>
                 <a:hlinkClick r:id="rId3"/>
               </a:rPr>
-              <a:t>https://dartgo.org/r-projects</a:t>
+              <a:t>https://dartgo.org/f26_research-fundamentals_download</a:t>
             </a:r>
-            <a:r>
-              <a:rPr lang="en-US" sz="2006" kern="0" dirty="0">
-                <a:solidFill>
-                  <a:srgbClr val="12312B"/>
-                </a:solidFill>
-                <a:highlight>
-                  <a:srgbClr val="FFFF00"/>
-                </a:highlight>
-                <a:latin typeface="Archivo Medium"/>
-                <a:cs typeface="Archivo Medium"/>
-                <a:sym typeface="Archivo Medium"/>
-              </a:rPr>
-              <a:t> </a:t>
-            </a:r>
-          </a:p>
-          <a:p>
-            <a:pPr>
-              <a:lnSpc>
-                <a:spcPct val="140013"/>
-              </a:lnSpc>
-            </a:pPr>
             <a:endParaRPr sz="2000" dirty="0">
               <a:solidFill>
                 <a:srgbClr val="12312B"/>
@@ -12118,6 +12347,560 @@
   <p:cSld>
     <p:spTree>
       <p:nvGrpSpPr>
+        <p:cNvPr id="1" name="Shape 402">
+          <a:extLst>
+            <a:ext uri="{FF2B5EF4-FFF2-40B4-BE49-F238E27FC236}">
+              <a16:creationId xmlns:a16="http://schemas.microsoft.com/office/drawing/2014/main" id="{1936C50B-B2F8-059C-69D1-FC7F95E5DF5A}"/>
+            </a:ext>
+          </a:extLst>
+        </p:cNvPr>
+        <p:cNvGrpSpPr/>
+        <p:nvPr/>
+      </p:nvGrpSpPr>
+      <p:grpSpPr>
+        <a:xfrm>
+          <a:off x="0" y="0"/>
+          <a:ext cx="0" cy="0"/>
+          <a:chOff x="0" y="0"/>
+          <a:chExt cx="0" cy="0"/>
+        </a:xfrm>
+      </p:grpSpPr>
+      <p:sp>
+        <p:nvSpPr>
+          <p:cNvPr id="403" name="Google Shape;403;p77">
+            <a:extLst>
+              <a:ext uri="{FF2B5EF4-FFF2-40B4-BE49-F238E27FC236}">
+                <a16:creationId xmlns:a16="http://schemas.microsoft.com/office/drawing/2014/main" id="{08ACD910-0FC3-2C09-C618-51212C0B552D}"/>
+              </a:ext>
+            </a:extLst>
+          </p:cNvPr>
+          <p:cNvSpPr txBox="1"/>
+          <p:nvPr/>
+        </p:nvSpPr>
+        <p:spPr>
+          <a:xfrm>
+            <a:off x="922201" y="1157695"/>
+            <a:ext cx="6097600" cy="746936"/>
+          </a:xfrm>
+          <a:prstGeom prst="rect">
+            <a:avLst/>
+          </a:prstGeom>
+          <a:noFill/>
+          <a:ln>
+            <a:noFill/>
+          </a:ln>
+        </p:spPr>
+        <p:txBody>
+          <a:bodyPr spcFirstLastPara="1" wrap="square" lIns="0" tIns="0" rIns="0" bIns="0" anchor="t" anchorCtr="0">
+            <a:spAutoFit/>
+          </a:bodyPr>
+          <a:lstStyle/>
+          <a:p>
+            <a:pPr>
+              <a:lnSpc>
+                <a:spcPct val="140007"/>
+              </a:lnSpc>
+            </a:pPr>
+            <a:r>
+              <a:rPr lang="en-US" sz="3467" dirty="0">
+                <a:solidFill>
+                  <a:srgbClr val="00693D"/>
+                </a:solidFill>
+                <a:latin typeface="Anton"/>
+                <a:ea typeface="Anton"/>
+                <a:cs typeface="Anton"/>
+                <a:sym typeface="Anton"/>
+              </a:rPr>
+              <a:t>Options for writing code</a:t>
+            </a:r>
+            <a:endParaRPr sz="933" dirty="0">
+              <a:solidFill>
+                <a:srgbClr val="000000"/>
+              </a:solidFill>
+              <a:latin typeface="Anton"/>
+              <a:ea typeface="Anton"/>
+              <a:cs typeface="Anton"/>
+              <a:sym typeface="Anton"/>
+            </a:endParaRPr>
+          </a:p>
+        </p:txBody>
+      </p:sp>
+      <p:sp>
+        <p:nvSpPr>
+          <p:cNvPr id="404" name="Google Shape;404;p77">
+            <a:extLst>
+              <a:ext uri="{FF2B5EF4-FFF2-40B4-BE49-F238E27FC236}">
+                <a16:creationId xmlns:a16="http://schemas.microsoft.com/office/drawing/2014/main" id="{3B05AAFC-9033-2105-BA72-FB829C17E475}"/>
+              </a:ext>
+            </a:extLst>
+          </p:cNvPr>
+          <p:cNvSpPr txBox="1"/>
+          <p:nvPr/>
+        </p:nvSpPr>
+        <p:spPr>
+          <a:xfrm>
+            <a:off x="880492" y="1904631"/>
+            <a:ext cx="9776400" cy="4616905"/>
+          </a:xfrm>
+          <a:prstGeom prst="rect">
+            <a:avLst/>
+          </a:prstGeom>
+          <a:noFill/>
+          <a:ln>
+            <a:noFill/>
+          </a:ln>
+        </p:spPr>
+        <p:txBody>
+          <a:bodyPr spcFirstLastPara="1" wrap="square" lIns="0" tIns="0" rIns="0" bIns="0" anchor="t" anchorCtr="0">
+            <a:spAutoFit/>
+          </a:bodyPr>
+          <a:lstStyle/>
+          <a:p>
+            <a:pPr marL="609585">
+              <a:lnSpc>
+                <a:spcPct val="140013"/>
+              </a:lnSpc>
+            </a:pPr>
+            <a:endParaRPr sz="2400" dirty="0">
+              <a:solidFill>
+                <a:srgbClr val="12312B"/>
+              </a:solidFill>
+              <a:latin typeface="Archivo Medium"/>
+              <a:ea typeface="Archivo Medium"/>
+              <a:cs typeface="Archivo Medium"/>
+              <a:sym typeface="Archivo Medium"/>
+            </a:endParaRPr>
+          </a:p>
+          <a:p>
+            <a:pPr marL="433260" lvl="1" indent="-216630" defTabSz="609630">
+              <a:lnSpc>
+                <a:spcPct val="140013"/>
+              </a:lnSpc>
+              <a:buClr>
+                <a:srgbClr val="12312B"/>
+              </a:buClr>
+              <a:buSzPts val="3009"/>
+              <a:buFont typeface="Archivo Medium"/>
+              <a:buChar char="•"/>
+            </a:pPr>
+            <a:r>
+              <a:rPr lang="en-US" sz="2006" kern="0" dirty="0">
+                <a:solidFill>
+                  <a:srgbClr val="12312B"/>
+                </a:solidFill>
+                <a:latin typeface="Archivo Medium"/>
+                <a:cs typeface="Archivo Medium"/>
+                <a:sym typeface="Archivo Medium"/>
+              </a:rPr>
+              <a:t>R scripts like the one we wrote in the last session are a great no-frills way to record the commands you ran and associated comments</a:t>
+            </a:r>
+          </a:p>
+          <a:p>
+            <a:pPr marL="866521" lvl="2" indent="-288840" defTabSz="609630">
+              <a:lnSpc>
+                <a:spcPct val="140013"/>
+              </a:lnSpc>
+              <a:buClr>
+                <a:srgbClr val="12312B"/>
+              </a:buClr>
+              <a:buSzPts val="3009"/>
+              <a:buFont typeface="Archivo Medium"/>
+              <a:buChar char="⚬"/>
+            </a:pPr>
+            <a:r>
+              <a:rPr lang="en-US" dirty="0">
+                <a:latin typeface="Archivo Medium"/>
+                <a:sym typeface="Archivo Medium"/>
+              </a:rPr>
+              <a:t>Think of this as a plain text document (</a:t>
+            </a:r>
+            <a:r>
+              <a:rPr lang="en-US" dirty="0" err="1">
+                <a:latin typeface="Archivo Medium"/>
+                <a:sym typeface="Archivo Medium"/>
+              </a:rPr>
+              <a:t>eg</a:t>
+            </a:r>
+            <a:r>
+              <a:rPr lang="en-US" dirty="0">
+                <a:latin typeface="Archivo Medium"/>
+                <a:sym typeface="Archivo Medium"/>
+              </a:rPr>
+              <a:t> a .txt file)</a:t>
+            </a:r>
+          </a:p>
+          <a:p>
+            <a:pPr marL="433260" lvl="1" indent="-216630" defTabSz="609630">
+              <a:lnSpc>
+                <a:spcPct val="140013"/>
+              </a:lnSpc>
+              <a:buClr>
+                <a:srgbClr val="12312B"/>
+              </a:buClr>
+              <a:buSzPts val="3009"/>
+              <a:buFont typeface="Archivo Medium"/>
+              <a:buChar char="•"/>
+            </a:pPr>
+            <a:endParaRPr lang="en-US" sz="2006" kern="0" dirty="0">
+              <a:solidFill>
+                <a:srgbClr val="12312B"/>
+              </a:solidFill>
+              <a:latin typeface="Archivo Medium"/>
+              <a:cs typeface="Archivo Medium"/>
+              <a:sym typeface="Archivo Medium"/>
+            </a:endParaRPr>
+          </a:p>
+          <a:p>
+            <a:pPr marL="433260" lvl="1" indent="-216630" defTabSz="609630">
+              <a:lnSpc>
+                <a:spcPct val="140013"/>
+              </a:lnSpc>
+              <a:buClr>
+                <a:srgbClr val="12312B"/>
+              </a:buClr>
+              <a:buSzPts val="3009"/>
+              <a:buFont typeface="Archivo Medium"/>
+              <a:buChar char="•"/>
+            </a:pPr>
+            <a:r>
+              <a:rPr lang="en-US" sz="2006" kern="0" dirty="0">
+                <a:solidFill>
+                  <a:srgbClr val="12312B"/>
+                </a:solidFill>
+                <a:latin typeface="Archivo Medium"/>
+                <a:cs typeface="Archivo Medium"/>
+                <a:sym typeface="Archivo Medium"/>
+              </a:rPr>
+              <a:t>What if you wanted to give more explanation of your thought process, or explain the output of a command and reference the figure it generated? </a:t>
+            </a:r>
+          </a:p>
+          <a:p>
+            <a:pPr marL="866521" lvl="2" indent="-288840" defTabSz="609630">
+              <a:lnSpc>
+                <a:spcPct val="140013"/>
+              </a:lnSpc>
+              <a:buClr>
+                <a:srgbClr val="12312B"/>
+              </a:buClr>
+              <a:buSzPts val="3009"/>
+              <a:buFont typeface="Archivo Medium"/>
+              <a:buChar char="⚬"/>
+            </a:pPr>
+            <a:r>
+              <a:rPr lang="en-US" dirty="0">
+                <a:latin typeface="Archivo Medium"/>
+                <a:sym typeface="Archivo Medium"/>
+              </a:rPr>
+              <a:t>Quarto documents are a great way to do this</a:t>
+            </a:r>
+          </a:p>
+          <a:p>
+            <a:pPr marL="866521" lvl="2" indent="-288840" defTabSz="609630">
+              <a:lnSpc>
+                <a:spcPct val="140013"/>
+              </a:lnSpc>
+              <a:buClr>
+                <a:srgbClr val="12312B"/>
+              </a:buClr>
+              <a:buSzPts val="3009"/>
+              <a:buFont typeface="Archivo Medium"/>
+              <a:buChar char="⚬"/>
+            </a:pPr>
+            <a:r>
+              <a:rPr lang="en-US" dirty="0">
+                <a:latin typeface="Archivo Medium"/>
+                <a:sym typeface="Archivo Medium"/>
+              </a:rPr>
+              <a:t>They allow you to combine code and text blocks, as well as the output of your code all in one place. </a:t>
+            </a:r>
+          </a:p>
+          <a:p>
+            <a:pPr marL="866521" lvl="2" indent="-288840" defTabSz="609630">
+              <a:lnSpc>
+                <a:spcPct val="140013"/>
+              </a:lnSpc>
+              <a:buClr>
+                <a:srgbClr val="12312B"/>
+              </a:buClr>
+              <a:buSzPts val="3009"/>
+              <a:buFont typeface="Archivo Medium"/>
+              <a:buChar char="⚬"/>
+            </a:pPr>
+            <a:r>
+              <a:rPr lang="en-US" dirty="0">
+                <a:latin typeface="Archivo Medium"/>
+                <a:sym typeface="Archivo Medium"/>
+              </a:rPr>
+              <a:t>Think of it as a Word document with formatting and inserted images. </a:t>
+            </a:r>
+            <a:endParaRPr dirty="0">
+              <a:latin typeface="Archivo Medium"/>
+              <a:sym typeface="Arial"/>
+            </a:endParaRPr>
+          </a:p>
+        </p:txBody>
+      </p:sp>
+    </p:spTree>
+    <p:extLst>
+      <p:ext uri="{BB962C8B-B14F-4D97-AF65-F5344CB8AC3E}">
+        <p14:creationId xmlns:p14="http://schemas.microsoft.com/office/powerpoint/2010/main" val="1918343688"/>
+      </p:ext>
+    </p:extLst>
+  </p:cSld>
+  <p:clrMapOvr>
+    <a:masterClrMapping/>
+  </p:clrMapOvr>
+</p:sld>
+</file>
+
+<file path=ppt/slides/slide13.xml><?xml version="1.0" encoding="utf-8"?>
+<p:sld xmlns:a="http://schemas.openxmlformats.org/drawingml/2006/main" xmlns:r="http://schemas.openxmlformats.org/officeDocument/2006/relationships" xmlns:p="http://schemas.openxmlformats.org/presentationml/2006/main">
+  <p:cSld>
+    <p:spTree>
+      <p:nvGrpSpPr>
+        <p:cNvPr id="1" name="Shape 402">
+          <a:extLst>
+            <a:ext uri="{FF2B5EF4-FFF2-40B4-BE49-F238E27FC236}">
+              <a16:creationId xmlns:a16="http://schemas.microsoft.com/office/drawing/2014/main" id="{17492F1C-6C41-2C7D-69A8-6133416D96BF}"/>
+            </a:ext>
+          </a:extLst>
+        </p:cNvPr>
+        <p:cNvGrpSpPr/>
+        <p:nvPr/>
+      </p:nvGrpSpPr>
+      <p:grpSpPr>
+        <a:xfrm>
+          <a:off x="0" y="0"/>
+          <a:ext cx="0" cy="0"/>
+          <a:chOff x="0" y="0"/>
+          <a:chExt cx="0" cy="0"/>
+        </a:xfrm>
+      </p:grpSpPr>
+      <p:sp>
+        <p:nvSpPr>
+          <p:cNvPr id="403" name="Google Shape;403;p77">
+            <a:extLst>
+              <a:ext uri="{FF2B5EF4-FFF2-40B4-BE49-F238E27FC236}">
+                <a16:creationId xmlns:a16="http://schemas.microsoft.com/office/drawing/2014/main" id="{2AAEA18C-4620-269A-348C-38807269B343}"/>
+              </a:ext>
+            </a:extLst>
+          </p:cNvPr>
+          <p:cNvSpPr txBox="1"/>
+          <p:nvPr/>
+        </p:nvSpPr>
+        <p:spPr>
+          <a:xfrm>
+            <a:off x="922201" y="1157695"/>
+            <a:ext cx="6097600" cy="746936"/>
+          </a:xfrm>
+          <a:prstGeom prst="rect">
+            <a:avLst/>
+          </a:prstGeom>
+          <a:noFill/>
+          <a:ln>
+            <a:noFill/>
+          </a:ln>
+        </p:spPr>
+        <p:txBody>
+          <a:bodyPr spcFirstLastPara="1" wrap="square" lIns="0" tIns="0" rIns="0" bIns="0" anchor="t" anchorCtr="0">
+            <a:spAutoFit/>
+          </a:bodyPr>
+          <a:lstStyle/>
+          <a:p>
+            <a:pPr>
+              <a:lnSpc>
+                <a:spcPct val="140007"/>
+              </a:lnSpc>
+            </a:pPr>
+            <a:r>
+              <a:rPr lang="en-US" sz="3467" dirty="0">
+                <a:solidFill>
+                  <a:srgbClr val="00693D"/>
+                </a:solidFill>
+                <a:latin typeface="Anton"/>
+                <a:ea typeface="Anton"/>
+                <a:cs typeface="Anton"/>
+                <a:sym typeface="Anton"/>
+              </a:rPr>
+              <a:t>Loading Data</a:t>
+            </a:r>
+            <a:endParaRPr sz="933" dirty="0">
+              <a:solidFill>
+                <a:srgbClr val="000000"/>
+              </a:solidFill>
+              <a:latin typeface="Anton"/>
+              <a:ea typeface="Anton"/>
+              <a:cs typeface="Anton"/>
+              <a:sym typeface="Anton"/>
+            </a:endParaRPr>
+          </a:p>
+        </p:txBody>
+      </p:sp>
+      <p:sp>
+        <p:nvSpPr>
+          <p:cNvPr id="404" name="Google Shape;404;p77">
+            <a:extLst>
+              <a:ext uri="{FF2B5EF4-FFF2-40B4-BE49-F238E27FC236}">
+                <a16:creationId xmlns:a16="http://schemas.microsoft.com/office/drawing/2014/main" id="{CE1441DE-1E48-71E6-EE95-90FE965F0669}"/>
+              </a:ext>
+            </a:extLst>
+          </p:cNvPr>
+          <p:cNvSpPr txBox="1"/>
+          <p:nvPr/>
+        </p:nvSpPr>
+        <p:spPr>
+          <a:xfrm>
+            <a:off x="880492" y="1904631"/>
+            <a:ext cx="9776400" cy="2157001"/>
+          </a:xfrm>
+          <a:prstGeom prst="rect">
+            <a:avLst/>
+          </a:prstGeom>
+          <a:noFill/>
+          <a:ln>
+            <a:noFill/>
+          </a:ln>
+        </p:spPr>
+        <p:txBody>
+          <a:bodyPr spcFirstLastPara="1" wrap="square" lIns="0" tIns="0" rIns="0" bIns="0" anchor="t" anchorCtr="0">
+            <a:spAutoFit/>
+          </a:bodyPr>
+          <a:lstStyle/>
+          <a:p>
+            <a:pPr marL="609585">
+              <a:lnSpc>
+                <a:spcPct val="140013"/>
+              </a:lnSpc>
+            </a:pPr>
+            <a:endParaRPr sz="2400" dirty="0">
+              <a:solidFill>
+                <a:srgbClr val="12312B"/>
+              </a:solidFill>
+              <a:latin typeface="Archivo Medium"/>
+              <a:ea typeface="Archivo Medium"/>
+              <a:cs typeface="Archivo Medium"/>
+              <a:sym typeface="Archivo Medium"/>
+            </a:endParaRPr>
+          </a:p>
+          <a:p>
+            <a:pPr marL="433260" lvl="1" indent="-216630" defTabSz="609630">
+              <a:lnSpc>
+                <a:spcPct val="140013"/>
+              </a:lnSpc>
+              <a:buClr>
+                <a:srgbClr val="12312B"/>
+              </a:buClr>
+              <a:buSzPts val="3009"/>
+              <a:buFont typeface="Archivo Medium"/>
+              <a:buChar char="•"/>
+            </a:pPr>
+            <a:r>
+              <a:rPr lang="en-US" sz="2006" kern="0" dirty="0">
+                <a:solidFill>
+                  <a:srgbClr val="12312B"/>
+                </a:solidFill>
+                <a:latin typeface="Archivo Medium"/>
+                <a:cs typeface="Archivo Medium"/>
+                <a:sym typeface="Archivo Medium"/>
+              </a:rPr>
+              <a:t>The first step is to tell R where on your computer to look for the data</a:t>
+            </a:r>
+          </a:p>
+          <a:p>
+            <a:pPr marL="866521" lvl="2" indent="-288840" defTabSz="609630">
+              <a:lnSpc>
+                <a:spcPct val="140013"/>
+              </a:lnSpc>
+              <a:buClr>
+                <a:srgbClr val="12312B"/>
+              </a:buClr>
+              <a:buSzPts val="3009"/>
+              <a:buFont typeface="Archivo Medium"/>
+              <a:buChar char="⚬"/>
+            </a:pPr>
+            <a:r>
+              <a:rPr lang="en-US" dirty="0">
+                <a:latin typeface="Archivo Medium"/>
+                <a:sym typeface="Archivo Medium"/>
+              </a:rPr>
+              <a:t>The bad way: </a:t>
+            </a:r>
+            <a:r>
+              <a:rPr lang="en-US">
+                <a:latin typeface="Archivo Medium"/>
+                <a:sym typeface="Archivo Medium"/>
+              </a:rPr>
+              <a:t>Set your working </a:t>
+            </a:r>
+            <a:r>
+              <a:rPr lang="en-US" dirty="0">
+                <a:latin typeface="Archivo Medium"/>
+                <a:sym typeface="Archivo Medium"/>
+              </a:rPr>
+              <a:t>directory using an absolute path</a:t>
+            </a:r>
+          </a:p>
+          <a:p>
+            <a:pPr marL="866521" lvl="2" indent="-288840" defTabSz="609630">
+              <a:lnSpc>
+                <a:spcPct val="140013"/>
+              </a:lnSpc>
+              <a:buClr>
+                <a:srgbClr val="12312B"/>
+              </a:buClr>
+              <a:buSzPts val="3009"/>
+              <a:buFont typeface="Archivo Medium"/>
+              <a:buChar char="⚬"/>
+            </a:pPr>
+            <a:r>
+              <a:rPr lang="en-US" dirty="0">
+                <a:latin typeface="Archivo Medium"/>
+                <a:sym typeface="Archivo Medium"/>
+              </a:rPr>
+              <a:t>The good way: Use the “here” package to specify a relative path</a:t>
+            </a:r>
+          </a:p>
+          <a:p>
+            <a:pPr marL="433260" lvl="1" indent="-216630" defTabSz="609630">
+              <a:lnSpc>
+                <a:spcPct val="140013"/>
+              </a:lnSpc>
+              <a:buClr>
+                <a:srgbClr val="12312B"/>
+              </a:buClr>
+              <a:buSzPts val="3009"/>
+              <a:buFont typeface="Archivo Medium"/>
+              <a:buChar char="•"/>
+            </a:pPr>
+            <a:endParaRPr lang="en-US" sz="2006" kern="0" dirty="0">
+              <a:solidFill>
+                <a:srgbClr val="12312B"/>
+              </a:solidFill>
+              <a:latin typeface="Archivo Medium"/>
+              <a:cs typeface="Archivo Medium"/>
+              <a:sym typeface="Archivo Medium"/>
+            </a:endParaRPr>
+          </a:p>
+        </p:txBody>
+      </p:sp>
+    </p:spTree>
+    <p:extLst>
+      <p:ext uri="{BB962C8B-B14F-4D97-AF65-F5344CB8AC3E}">
+        <p14:creationId xmlns:p14="http://schemas.microsoft.com/office/powerpoint/2010/main" val="803544650"/>
+      </p:ext>
+    </p:extLst>
+  </p:cSld>
+  <p:clrMapOvr>
+    <a:masterClrMapping/>
+  </p:clrMapOvr>
+</p:sld>
+</file>
+
+<file path=ppt/slides/slide14.xml><?xml version="1.0" encoding="utf-8"?>
+<p:sld xmlns:a="http://schemas.openxmlformats.org/drawingml/2006/main" xmlns:r="http://schemas.openxmlformats.org/officeDocument/2006/relationships" xmlns:p="http://schemas.openxmlformats.org/presentationml/2006/main">
+  <p:cSld>
+    <p:spTree>
+      <p:nvGrpSpPr>
         <p:cNvPr id="1" name="Shape 402"/>
         <p:cNvGrpSpPr/>
         <p:nvPr/>
@@ -12425,7 +13208,7 @@
 </p:sld>
 </file>
 
-<file path=ppt/slides/slide13.xml><?xml version="1.0" encoding="utf-8"?>
+<file path=ppt/slides/slide15.xml><?xml version="1.0" encoding="utf-8"?>
 <p:sld xmlns:a="http://schemas.openxmlformats.org/drawingml/2006/main" xmlns:r="http://schemas.openxmlformats.org/officeDocument/2006/relationships" xmlns:p="http://schemas.openxmlformats.org/presentationml/2006/main">
   <p:cSld>
     <p:spTree>
@@ -12747,7 +13530,7 @@
 </p:sld>
 </file>
 
-<file path=ppt/slides/slide14.xml><?xml version="1.0" encoding="utf-8"?>
+<file path=ppt/slides/slide16.xml><?xml version="1.0" encoding="utf-8"?>
 <p:sld xmlns:a="http://schemas.openxmlformats.org/drawingml/2006/main" xmlns:r="http://schemas.openxmlformats.org/officeDocument/2006/relationships" xmlns:p="http://schemas.openxmlformats.org/presentationml/2006/main">
   <p:cSld>
     <p:spTree>
@@ -13068,291 +13851,7 @@
 </p:sld>
 </file>
 
-<file path=ppt/slides/slide15.xml><?xml version="1.0" encoding="utf-8"?>
-<p:sld xmlns:a="http://schemas.openxmlformats.org/drawingml/2006/main" xmlns:r="http://schemas.openxmlformats.org/officeDocument/2006/relationships" xmlns:p="http://schemas.openxmlformats.org/presentationml/2006/main">
-  <p:cSld>
-    <p:spTree>
-      <p:nvGrpSpPr>
-        <p:cNvPr id="1" name="Shape 402">
-          <a:extLst>
-            <a:ext uri="{FF2B5EF4-FFF2-40B4-BE49-F238E27FC236}">
-              <a16:creationId xmlns:a16="http://schemas.microsoft.com/office/drawing/2014/main" id="{17492F1C-6C41-2C7D-69A8-6133416D96BF}"/>
-            </a:ext>
-          </a:extLst>
-        </p:cNvPr>
-        <p:cNvGrpSpPr/>
-        <p:nvPr/>
-      </p:nvGrpSpPr>
-      <p:grpSpPr>
-        <a:xfrm>
-          <a:off x="0" y="0"/>
-          <a:ext cx="0" cy="0"/>
-          <a:chOff x="0" y="0"/>
-          <a:chExt cx="0" cy="0"/>
-        </a:xfrm>
-      </p:grpSpPr>
-      <p:sp>
-        <p:nvSpPr>
-          <p:cNvPr id="403" name="Google Shape;403;p77">
-            <a:extLst>
-              <a:ext uri="{FF2B5EF4-FFF2-40B4-BE49-F238E27FC236}">
-                <a16:creationId xmlns:a16="http://schemas.microsoft.com/office/drawing/2014/main" id="{2AAEA18C-4620-269A-348C-38807269B343}"/>
-              </a:ext>
-            </a:extLst>
-          </p:cNvPr>
-          <p:cNvSpPr txBox="1"/>
-          <p:nvPr/>
-        </p:nvSpPr>
-        <p:spPr>
-          <a:xfrm>
-            <a:off x="922201" y="1157695"/>
-            <a:ext cx="6097600" cy="746936"/>
-          </a:xfrm>
-          <a:prstGeom prst="rect">
-            <a:avLst/>
-          </a:prstGeom>
-          <a:noFill/>
-          <a:ln>
-            <a:noFill/>
-          </a:ln>
-        </p:spPr>
-        <p:txBody>
-          <a:bodyPr spcFirstLastPara="1" wrap="square" lIns="0" tIns="0" rIns="0" bIns="0" anchor="t" anchorCtr="0">
-            <a:spAutoFit/>
-          </a:bodyPr>
-          <a:lstStyle/>
-          <a:p>
-            <a:pPr>
-              <a:lnSpc>
-                <a:spcPct val="140007"/>
-              </a:lnSpc>
-            </a:pPr>
-            <a:r>
-              <a:rPr lang="en-US" sz="3467" dirty="0">
-                <a:solidFill>
-                  <a:srgbClr val="00693D"/>
-                </a:solidFill>
-                <a:latin typeface="Anton"/>
-                <a:ea typeface="Anton"/>
-                <a:cs typeface="Anton"/>
-                <a:sym typeface="Anton"/>
-              </a:rPr>
-              <a:t>Loading Data</a:t>
-            </a:r>
-            <a:endParaRPr sz="933" dirty="0">
-              <a:solidFill>
-                <a:srgbClr val="000000"/>
-              </a:solidFill>
-              <a:latin typeface="Anton"/>
-              <a:ea typeface="Anton"/>
-              <a:cs typeface="Anton"/>
-              <a:sym typeface="Anton"/>
-            </a:endParaRPr>
-          </a:p>
-        </p:txBody>
-      </p:sp>
-      <p:sp>
-        <p:nvSpPr>
-          <p:cNvPr id="404" name="Google Shape;404;p77">
-            <a:extLst>
-              <a:ext uri="{FF2B5EF4-FFF2-40B4-BE49-F238E27FC236}">
-                <a16:creationId xmlns:a16="http://schemas.microsoft.com/office/drawing/2014/main" id="{CE1441DE-1E48-71E6-EE95-90FE965F0669}"/>
-              </a:ext>
-            </a:extLst>
-          </p:cNvPr>
-          <p:cNvSpPr txBox="1"/>
-          <p:nvPr/>
-        </p:nvSpPr>
-        <p:spPr>
-          <a:xfrm>
-            <a:off x="880492" y="1904631"/>
-            <a:ext cx="9776400" cy="2677913"/>
-          </a:xfrm>
-          <a:prstGeom prst="rect">
-            <a:avLst/>
-          </a:prstGeom>
-          <a:noFill/>
-          <a:ln>
-            <a:noFill/>
-          </a:ln>
-        </p:spPr>
-        <p:txBody>
-          <a:bodyPr spcFirstLastPara="1" wrap="square" lIns="0" tIns="0" rIns="0" bIns="0" anchor="t" anchorCtr="0">
-            <a:spAutoFit/>
-          </a:bodyPr>
-          <a:lstStyle/>
-          <a:p>
-            <a:pPr marL="609585">
-              <a:lnSpc>
-                <a:spcPct val="140013"/>
-              </a:lnSpc>
-            </a:pPr>
-            <a:endParaRPr sz="2400" dirty="0">
-              <a:solidFill>
-                <a:srgbClr val="12312B"/>
-              </a:solidFill>
-              <a:latin typeface="Archivo Medium"/>
-              <a:ea typeface="Archivo Medium"/>
-              <a:cs typeface="Archivo Medium"/>
-              <a:sym typeface="Archivo Medium"/>
-            </a:endParaRPr>
-          </a:p>
-          <a:p>
-            <a:pPr marL="433260" lvl="1" indent="-216630" defTabSz="609630">
-              <a:lnSpc>
-                <a:spcPct val="140013"/>
-              </a:lnSpc>
-              <a:buClr>
-                <a:srgbClr val="12312B"/>
-              </a:buClr>
-              <a:buSzPts val="3009"/>
-              <a:buFont typeface="Archivo Medium"/>
-              <a:buChar char="•"/>
-            </a:pPr>
-            <a:r>
-              <a:rPr lang="en-US" sz="2006" kern="0" dirty="0">
-                <a:solidFill>
-                  <a:srgbClr val="12312B"/>
-                </a:solidFill>
-                <a:latin typeface="Archivo Medium"/>
-                <a:cs typeface="Archivo Medium"/>
-                <a:sym typeface="Archivo Medium"/>
-              </a:rPr>
-              <a:t>The first step is to tell R where on your computer to look for the data</a:t>
-            </a:r>
-          </a:p>
-          <a:p>
-            <a:pPr marL="866521" lvl="2" indent="-288840" defTabSz="609630">
-              <a:lnSpc>
-                <a:spcPct val="140013"/>
-              </a:lnSpc>
-              <a:buClr>
-                <a:srgbClr val="12312B"/>
-              </a:buClr>
-              <a:buSzPts val="3009"/>
-              <a:buFont typeface="Archivo Medium"/>
-              <a:buChar char="⚬"/>
-            </a:pPr>
-            <a:r>
-              <a:rPr lang="en-US" dirty="0">
-                <a:latin typeface="Archivo Medium"/>
-                <a:sym typeface="Archivo Medium"/>
-              </a:rPr>
-              <a:t>The bad way: Set working directory using an absolute path</a:t>
-            </a:r>
-          </a:p>
-          <a:p>
-            <a:pPr marL="866521" lvl="2" indent="-288840" defTabSz="609630">
-              <a:lnSpc>
-                <a:spcPct val="140013"/>
-              </a:lnSpc>
-              <a:buClr>
-                <a:srgbClr val="12312B"/>
-              </a:buClr>
-              <a:buSzPts val="3009"/>
-              <a:buFont typeface="Archivo Medium"/>
-              <a:buChar char="⚬"/>
-            </a:pPr>
-            <a:r>
-              <a:rPr lang="en-US" dirty="0">
-                <a:latin typeface="Archivo Medium"/>
-                <a:sym typeface="Archivo Medium"/>
-              </a:rPr>
-              <a:t>The good way: Use the “here” package to specify a relative path</a:t>
-            </a:r>
-          </a:p>
-          <a:p>
-            <a:pPr marL="433260" lvl="1" indent="-216630" defTabSz="609630">
-              <a:lnSpc>
-                <a:spcPct val="140013"/>
-              </a:lnSpc>
-              <a:buClr>
-                <a:srgbClr val="12312B"/>
-              </a:buClr>
-              <a:buSzPts val="3009"/>
-              <a:buFont typeface="Archivo Medium"/>
-              <a:buChar char="•"/>
-            </a:pPr>
-            <a:endParaRPr lang="en-US" sz="2006" kern="0" dirty="0">
-              <a:solidFill>
-                <a:srgbClr val="12312B"/>
-              </a:solidFill>
-              <a:latin typeface="Archivo Medium"/>
-              <a:cs typeface="Archivo Medium"/>
-              <a:sym typeface="Archivo Medium"/>
-            </a:endParaRPr>
-          </a:p>
-          <a:p>
-            <a:pPr marL="433260" lvl="1" indent="-216630" defTabSz="609630">
-              <a:lnSpc>
-                <a:spcPct val="140013"/>
-              </a:lnSpc>
-              <a:buClr>
-                <a:srgbClr val="12312B"/>
-              </a:buClr>
-              <a:buSzPts val="3009"/>
-              <a:buFont typeface="Archivo Medium"/>
-              <a:buChar char="•"/>
-            </a:pPr>
-            <a:r>
-              <a:rPr lang="en-US" sz="2006" kern="0" dirty="0">
-                <a:solidFill>
-                  <a:srgbClr val="12312B"/>
-                </a:solidFill>
-                <a:latin typeface="Archivo Medium"/>
-                <a:cs typeface="Archivo Medium"/>
-                <a:sym typeface="Archivo Medium"/>
-              </a:rPr>
-              <a:t>Then you tell it how to read it using a function, like read.csv() or </a:t>
-            </a:r>
-            <a:r>
-              <a:rPr lang="en-US" sz="2006" kern="0" dirty="0" err="1">
-                <a:solidFill>
-                  <a:srgbClr val="12312B"/>
-                </a:solidFill>
-                <a:latin typeface="Archivo Medium"/>
-                <a:cs typeface="Archivo Medium"/>
-                <a:sym typeface="Archivo Medium"/>
-              </a:rPr>
-              <a:t>read_xlsx</a:t>
-            </a:r>
-            <a:r>
-              <a:rPr lang="en-US" sz="2006" kern="0" dirty="0">
-                <a:solidFill>
-                  <a:srgbClr val="12312B"/>
-                </a:solidFill>
-                <a:latin typeface="Archivo Medium"/>
-                <a:cs typeface="Archivo Medium"/>
-                <a:sym typeface="Archivo Medium"/>
-              </a:rPr>
-              <a:t>()</a:t>
-            </a:r>
-            <a:endParaRPr sz="2000" dirty="0">
-              <a:solidFill>
-                <a:srgbClr val="12312B"/>
-              </a:solidFill>
-              <a:latin typeface="Arial"/>
-              <a:ea typeface="Arial"/>
-              <a:cs typeface="Arial"/>
-              <a:sym typeface="Arial"/>
-            </a:endParaRPr>
-          </a:p>
-        </p:txBody>
-      </p:sp>
-    </p:spTree>
-    <p:extLst>
-      <p:ext uri="{BB962C8B-B14F-4D97-AF65-F5344CB8AC3E}">
-        <p14:creationId xmlns:p14="http://schemas.microsoft.com/office/powerpoint/2010/main" val="2386386992"/>
-      </p:ext>
-    </p:extLst>
-  </p:cSld>
-  <p:clrMapOvr>
-    <a:masterClrMapping/>
-  </p:clrMapOvr>
-</p:sld>
-</file>
-
-<file path=ppt/slides/slide16.xml><?xml version="1.0" encoding="utf-8"?>
+<file path=ppt/slides/slide17.xml><?xml version="1.0" encoding="utf-8"?>
 <p:sld xmlns:a="http://schemas.openxmlformats.org/drawingml/2006/main" xmlns:r="http://schemas.openxmlformats.org/officeDocument/2006/relationships" xmlns:p="http://schemas.openxmlformats.org/presentationml/2006/main">
   <p:cSld>
     <p:spTree>
@@ -13607,7 +14106,7 @@
 </p:sld>
 </file>
 
-<file path=ppt/slides/slide17.xml><?xml version="1.0" encoding="utf-8"?>
+<file path=ppt/slides/slide18.xml><?xml version="1.0" encoding="utf-8"?>
 <p:sld xmlns:a="http://schemas.openxmlformats.org/drawingml/2006/main" xmlns:r="http://schemas.openxmlformats.org/officeDocument/2006/relationships" xmlns:p="http://schemas.openxmlformats.org/presentationml/2006/main">
   <p:cSld>
     <p:spTree>
@@ -13779,7 +14278,7 @@
 </p:sld>
 </file>
 
-<file path=ppt/slides/slide18.xml><?xml version="1.0" encoding="utf-8"?>
+<file path=ppt/slides/slide19.xml><?xml version="1.0" encoding="utf-8"?>
 <p:sld xmlns:a="http://schemas.openxmlformats.org/drawingml/2006/main" xmlns:r="http://schemas.openxmlformats.org/officeDocument/2006/relationships" xmlns:p="http://schemas.openxmlformats.org/presentationml/2006/main">
   <p:cSld>
     <p:spTree>
@@ -14278,178 +14777,6 @@
     <p:extLst>
       <p:ext uri="{BB962C8B-B14F-4D97-AF65-F5344CB8AC3E}">
         <p14:creationId xmlns:p14="http://schemas.microsoft.com/office/powerpoint/2010/main" val="2135785689"/>
-      </p:ext>
-    </p:extLst>
-  </p:cSld>
-  <p:clrMapOvr>
-    <a:masterClrMapping/>
-  </p:clrMapOvr>
-</p:sld>
-</file>
-
-<file path=ppt/slides/slide19.xml><?xml version="1.0" encoding="utf-8"?>
-<p:sld xmlns:a="http://schemas.openxmlformats.org/drawingml/2006/main" xmlns:r="http://schemas.openxmlformats.org/officeDocument/2006/relationships" xmlns:p="http://schemas.openxmlformats.org/presentationml/2006/main">
-  <p:cSld>
-    <p:spTree>
-      <p:nvGrpSpPr>
-        <p:cNvPr id="1" name="Shape 133">
-          <a:extLst>
-            <a:ext uri="{FF2B5EF4-FFF2-40B4-BE49-F238E27FC236}">
-              <a16:creationId xmlns:a16="http://schemas.microsoft.com/office/drawing/2014/main" id="{D4EF62E4-FB2B-7E4A-4CB1-53FFFC5316C8}"/>
-            </a:ext>
-          </a:extLst>
-        </p:cNvPr>
-        <p:cNvGrpSpPr/>
-        <p:nvPr/>
-      </p:nvGrpSpPr>
-      <p:grpSpPr>
-        <a:xfrm>
-          <a:off x="0" y="0"/>
-          <a:ext cx="0" cy="0"/>
-          <a:chOff x="0" y="0"/>
-          <a:chExt cx="0" cy="0"/>
-        </a:xfrm>
-      </p:grpSpPr>
-      <p:sp>
-        <p:nvSpPr>
-          <p:cNvPr id="134" name="Google Shape;134;p25">
-            <a:extLst>
-              <a:ext uri="{FF2B5EF4-FFF2-40B4-BE49-F238E27FC236}">
-                <a16:creationId xmlns:a16="http://schemas.microsoft.com/office/drawing/2014/main" id="{B2390F86-F7C2-0C93-6066-1A98C227DC84}"/>
-              </a:ext>
-            </a:extLst>
-          </p:cNvPr>
-          <p:cNvSpPr txBox="1"/>
-          <p:nvPr/>
-        </p:nvSpPr>
-        <p:spPr>
-          <a:xfrm>
-            <a:off x="1417320" y="2148841"/>
-            <a:ext cx="9930384" cy="738664"/>
-          </a:xfrm>
-          <a:prstGeom prst="rect">
-            <a:avLst/>
-          </a:prstGeom>
-          <a:noFill/>
-          <a:ln>
-            <a:noFill/>
-          </a:ln>
-        </p:spPr>
-        <p:txBody>
-          <a:bodyPr spcFirstLastPara="1" wrap="square" lIns="0" tIns="0" rIns="0" bIns="0" anchor="t" anchorCtr="0">
-            <a:spAutoFit/>
-          </a:bodyPr>
-          <a:lstStyle/>
-          <a:p>
-            <a:pPr defTabSz="609630">
-              <a:buClr>
-                <a:srgbClr val="000000"/>
-              </a:buClr>
-            </a:pPr>
-            <a:r>
-              <a:rPr lang="en-US" sz="4800" kern="0" dirty="0">
-                <a:solidFill>
-                  <a:srgbClr val="A5D75F"/>
-                </a:solidFill>
-                <a:latin typeface="Anton"/>
-                <a:ea typeface="Anton"/>
-                <a:cs typeface="Anton"/>
-                <a:sym typeface="Anton"/>
-              </a:rPr>
-              <a:t>Appendix on why coding and R</a:t>
-            </a:r>
-            <a:endParaRPr sz="100" kern="0" dirty="0">
-              <a:solidFill>
-                <a:srgbClr val="A5D75F"/>
-              </a:solidFill>
-              <a:latin typeface="Anton"/>
-              <a:ea typeface="Anton"/>
-              <a:cs typeface="Anton"/>
-              <a:sym typeface="Anton"/>
-            </a:endParaRPr>
-          </a:p>
-        </p:txBody>
-      </p:sp>
-      <p:sp>
-        <p:nvSpPr>
-          <p:cNvPr id="135" name="Google Shape;135;p25">
-            <a:extLst>
-              <a:ext uri="{FF2B5EF4-FFF2-40B4-BE49-F238E27FC236}">
-                <a16:creationId xmlns:a16="http://schemas.microsoft.com/office/drawing/2014/main" id="{0C15ED0C-A394-9233-F734-6F8EBBB3A9C7}"/>
-              </a:ext>
-            </a:extLst>
-          </p:cNvPr>
-          <p:cNvSpPr/>
-          <p:nvPr/>
-        </p:nvSpPr>
-        <p:spPr>
-          <a:xfrm>
-            <a:off x="1065004" y="2844069"/>
-            <a:ext cx="8373826" cy="780393"/>
-          </a:xfrm>
-          <a:custGeom>
-            <a:avLst/>
-            <a:gdLst/>
-            <a:ahLst/>
-            <a:cxnLst/>
-            <a:rect l="l" t="t" r="r" b="b"/>
-            <a:pathLst>
-              <a:path w="6287497" h="938348" extrusionOk="0">
-                <a:moveTo>
-                  <a:pt x="0" y="0"/>
-                </a:moveTo>
-                <a:lnTo>
-                  <a:pt x="6287496" y="0"/>
-                </a:lnTo>
-                <a:lnTo>
-                  <a:pt x="6287496" y="938349"/>
-                </a:lnTo>
-                <a:lnTo>
-                  <a:pt x="0" y="938349"/>
-                </a:lnTo>
-                <a:lnTo>
-                  <a:pt x="0" y="0"/>
-                </a:lnTo>
-                <a:close/>
-              </a:path>
-            </a:pathLst>
-          </a:custGeom>
-          <a:blipFill rotWithShape="1">
-            <a:blip r:embed="rId3">
-              <a:alphaModFix/>
-            </a:blip>
-            <a:stretch>
-              <a:fillRect/>
-            </a:stretch>
-          </a:blipFill>
-          <a:ln>
-            <a:noFill/>
-          </a:ln>
-        </p:spPr>
-        <p:txBody>
-          <a:bodyPr/>
-          <a:lstStyle/>
-          <a:p>
-            <a:pPr defTabSz="609630">
-              <a:buClr>
-                <a:srgbClr val="000000"/>
-              </a:buClr>
-            </a:pPr>
-            <a:endParaRPr lang="en-US" sz="933" kern="0">
-              <a:solidFill>
-                <a:srgbClr val="000000"/>
-              </a:solidFill>
-              <a:latin typeface="Arial"/>
-              <a:cs typeface="Arial"/>
-              <a:sym typeface="Arial"/>
-            </a:endParaRPr>
-          </a:p>
-        </p:txBody>
-      </p:sp>
-    </p:spTree>
-    <p:extLst>
-      <p:ext uri="{BB962C8B-B14F-4D97-AF65-F5344CB8AC3E}">
-        <p14:creationId xmlns:p14="http://schemas.microsoft.com/office/powerpoint/2010/main" val="3505932459"/>
       </p:ext>
     </p:extLst>
   </p:cSld>
@@ -14560,7 +14887,7 @@
         <p:spPr>
           <a:xfrm>
             <a:off x="884764" y="1900078"/>
-            <a:ext cx="9776400" cy="1724831"/>
+            <a:ext cx="9776400" cy="2155718"/>
           </a:xfrm>
           <a:prstGeom prst="rect">
             <a:avLst/>
@@ -14642,6 +14969,29 @@
                 <a:sym typeface="Archivo Medium"/>
               </a:rPr>
               <a:t>Learn basic R syntax</a:t>
+            </a:r>
+          </a:p>
+          <a:p>
+            <a:pPr marL="1016730" lvl="2" indent="-342900" defTabSz="609630">
+              <a:lnSpc>
+                <a:spcPct val="140013"/>
+              </a:lnSpc>
+              <a:buClr>
+                <a:srgbClr val="12312B"/>
+              </a:buClr>
+              <a:buSzPct val="115000"/>
+              <a:buAutoNum type="arabicPeriod"/>
+            </a:pPr>
+            <a:r>
+              <a:rPr lang="en-US" sz="2000" kern="0" dirty="0">
+                <a:solidFill>
+                  <a:srgbClr val="12312B"/>
+                </a:solidFill>
+                <a:latin typeface="Archivo Medium"/>
+                <a:cs typeface="Archivo Medium"/>
+                <a:sym typeface="Archivo Medium"/>
+              </a:rPr>
+              <a:t>Learn basics of R functions and getting help</a:t>
             </a:r>
           </a:p>
           <a:p>
@@ -14735,7 +15085,7 @@
         </p:nvSpPr>
         <p:spPr>
           <a:xfrm>
-            <a:off x="798287" y="4476635"/>
+            <a:off x="884764" y="4476635"/>
             <a:ext cx="9776400" cy="1292662"/>
           </a:xfrm>
           <a:prstGeom prst="rect">
@@ -14817,7 +15167,7 @@
                 <a:cs typeface="Archivo Medium"/>
                 <a:sym typeface="Archivo Medium"/>
               </a:rPr>
-              <a:t>Understand and get help using functions and packages</a:t>
+              <a:t>Learn about and use packages</a:t>
             </a:r>
             <a:endParaRPr sz="2006" kern="0" dirty="0">
               <a:solidFill>
@@ -14845,6 +15195,178 @@
 </file>
 
 <file path=ppt/slides/slide20.xml><?xml version="1.0" encoding="utf-8"?>
+<p:sld xmlns:a="http://schemas.openxmlformats.org/drawingml/2006/main" xmlns:r="http://schemas.openxmlformats.org/officeDocument/2006/relationships" xmlns:p="http://schemas.openxmlformats.org/presentationml/2006/main">
+  <p:cSld>
+    <p:spTree>
+      <p:nvGrpSpPr>
+        <p:cNvPr id="1" name="Shape 133">
+          <a:extLst>
+            <a:ext uri="{FF2B5EF4-FFF2-40B4-BE49-F238E27FC236}">
+              <a16:creationId xmlns:a16="http://schemas.microsoft.com/office/drawing/2014/main" id="{D4EF62E4-FB2B-7E4A-4CB1-53FFFC5316C8}"/>
+            </a:ext>
+          </a:extLst>
+        </p:cNvPr>
+        <p:cNvGrpSpPr/>
+        <p:nvPr/>
+      </p:nvGrpSpPr>
+      <p:grpSpPr>
+        <a:xfrm>
+          <a:off x="0" y="0"/>
+          <a:ext cx="0" cy="0"/>
+          <a:chOff x="0" y="0"/>
+          <a:chExt cx="0" cy="0"/>
+        </a:xfrm>
+      </p:grpSpPr>
+      <p:sp>
+        <p:nvSpPr>
+          <p:cNvPr id="134" name="Google Shape;134;p25">
+            <a:extLst>
+              <a:ext uri="{FF2B5EF4-FFF2-40B4-BE49-F238E27FC236}">
+                <a16:creationId xmlns:a16="http://schemas.microsoft.com/office/drawing/2014/main" id="{B2390F86-F7C2-0C93-6066-1A98C227DC84}"/>
+              </a:ext>
+            </a:extLst>
+          </p:cNvPr>
+          <p:cNvSpPr txBox="1"/>
+          <p:nvPr/>
+        </p:nvSpPr>
+        <p:spPr>
+          <a:xfrm>
+            <a:off x="1417320" y="2148841"/>
+            <a:ext cx="9930384" cy="738664"/>
+          </a:xfrm>
+          <a:prstGeom prst="rect">
+            <a:avLst/>
+          </a:prstGeom>
+          <a:noFill/>
+          <a:ln>
+            <a:noFill/>
+          </a:ln>
+        </p:spPr>
+        <p:txBody>
+          <a:bodyPr spcFirstLastPara="1" wrap="square" lIns="0" tIns="0" rIns="0" bIns="0" anchor="t" anchorCtr="0">
+            <a:spAutoFit/>
+          </a:bodyPr>
+          <a:lstStyle/>
+          <a:p>
+            <a:pPr defTabSz="609630">
+              <a:buClr>
+                <a:srgbClr val="000000"/>
+              </a:buClr>
+            </a:pPr>
+            <a:r>
+              <a:rPr lang="en-US" sz="4800" kern="0" dirty="0">
+                <a:solidFill>
+                  <a:srgbClr val="A5D75F"/>
+                </a:solidFill>
+                <a:latin typeface="Anton"/>
+                <a:ea typeface="Anton"/>
+                <a:cs typeface="Anton"/>
+                <a:sym typeface="Anton"/>
+              </a:rPr>
+              <a:t>Appendix on why coding and R</a:t>
+            </a:r>
+            <a:endParaRPr sz="100" kern="0" dirty="0">
+              <a:solidFill>
+                <a:srgbClr val="A5D75F"/>
+              </a:solidFill>
+              <a:latin typeface="Anton"/>
+              <a:ea typeface="Anton"/>
+              <a:cs typeface="Anton"/>
+              <a:sym typeface="Anton"/>
+            </a:endParaRPr>
+          </a:p>
+        </p:txBody>
+      </p:sp>
+      <p:sp>
+        <p:nvSpPr>
+          <p:cNvPr id="135" name="Google Shape;135;p25">
+            <a:extLst>
+              <a:ext uri="{FF2B5EF4-FFF2-40B4-BE49-F238E27FC236}">
+                <a16:creationId xmlns:a16="http://schemas.microsoft.com/office/drawing/2014/main" id="{0C15ED0C-A394-9233-F734-6F8EBBB3A9C7}"/>
+              </a:ext>
+            </a:extLst>
+          </p:cNvPr>
+          <p:cNvSpPr/>
+          <p:nvPr/>
+        </p:nvSpPr>
+        <p:spPr>
+          <a:xfrm>
+            <a:off x="1065004" y="2844069"/>
+            <a:ext cx="8373826" cy="780393"/>
+          </a:xfrm>
+          <a:custGeom>
+            <a:avLst/>
+            <a:gdLst/>
+            <a:ahLst/>
+            <a:cxnLst/>
+            <a:rect l="l" t="t" r="r" b="b"/>
+            <a:pathLst>
+              <a:path w="6287497" h="938348" extrusionOk="0">
+                <a:moveTo>
+                  <a:pt x="0" y="0"/>
+                </a:moveTo>
+                <a:lnTo>
+                  <a:pt x="6287496" y="0"/>
+                </a:lnTo>
+                <a:lnTo>
+                  <a:pt x="6287496" y="938349"/>
+                </a:lnTo>
+                <a:lnTo>
+                  <a:pt x="0" y="938349"/>
+                </a:lnTo>
+                <a:lnTo>
+                  <a:pt x="0" y="0"/>
+                </a:lnTo>
+                <a:close/>
+              </a:path>
+            </a:pathLst>
+          </a:custGeom>
+          <a:blipFill rotWithShape="1">
+            <a:blip r:embed="rId3">
+              <a:alphaModFix/>
+            </a:blip>
+            <a:stretch>
+              <a:fillRect/>
+            </a:stretch>
+          </a:blipFill>
+          <a:ln>
+            <a:noFill/>
+          </a:ln>
+        </p:spPr>
+        <p:txBody>
+          <a:bodyPr/>
+          <a:lstStyle/>
+          <a:p>
+            <a:pPr defTabSz="609630">
+              <a:buClr>
+                <a:srgbClr val="000000"/>
+              </a:buClr>
+            </a:pPr>
+            <a:endParaRPr lang="en-US" sz="933" kern="0">
+              <a:solidFill>
+                <a:srgbClr val="000000"/>
+              </a:solidFill>
+              <a:latin typeface="Arial"/>
+              <a:cs typeface="Arial"/>
+              <a:sym typeface="Arial"/>
+            </a:endParaRPr>
+          </a:p>
+        </p:txBody>
+      </p:sp>
+    </p:spTree>
+    <p:extLst>
+      <p:ext uri="{BB962C8B-B14F-4D97-AF65-F5344CB8AC3E}">
+        <p14:creationId xmlns:p14="http://schemas.microsoft.com/office/powerpoint/2010/main" val="3505932459"/>
+      </p:ext>
+    </p:extLst>
+  </p:cSld>
+  <p:clrMapOvr>
+    <a:masterClrMapping/>
+  </p:clrMapOvr>
+</p:sld>
+</file>
+
+<file path=ppt/slides/slide21.xml><?xml version="1.0" encoding="utf-8"?>
 <p:sld xmlns:a="http://schemas.openxmlformats.org/drawingml/2006/main" xmlns:r="http://schemas.openxmlformats.org/officeDocument/2006/relationships" xmlns:p="http://schemas.openxmlformats.org/presentationml/2006/main">
   <p:cSld>
     <p:spTree>
@@ -17228,7 +17750,7 @@
         <p:spPr>
           <a:xfrm>
             <a:off x="867673" y="1900079"/>
-            <a:ext cx="9776400" cy="4665123"/>
+            <a:ext cx="9776400" cy="3800784"/>
           </a:xfrm>
           <a:prstGeom prst="rect">
             <a:avLst/>
@@ -17346,11 +17868,11 @@
                 <a:latin typeface="Archivo Medium"/>
                 <a:sym typeface="Archivo Medium"/>
               </a:rPr>
-              <a:t>Quarto documents</a:t>
+              <a:t>Options for writing code</a:t>
             </a:r>
           </a:p>
           <a:p>
-            <a:pPr marL="433260" lvl="1" indent="-216630" defTabSz="609630">
+            <a:pPr marL="216630" lvl="1" defTabSz="609630">
               <a:lnSpc>
                 <a:spcPct val="140013"/>
               </a:lnSpc>
@@ -17358,8 +17880,6 @@
                 <a:srgbClr val="12312B"/>
               </a:buClr>
               <a:buSzPts val="3009"/>
-              <a:buFont typeface="Archivo Medium"/>
-              <a:buChar char="•"/>
             </a:pPr>
             <a:endParaRPr lang="en-US" sz="2006" kern="0" dirty="0">
               <a:solidFill>
@@ -17391,62 +17911,6 @@
               </a:rPr>
               <a:t>Load data into R</a:t>
             </a:r>
-          </a:p>
-          <a:p>
-            <a:pPr marL="433260" lvl="1" indent="-216630" defTabSz="609630">
-              <a:lnSpc>
-                <a:spcPct val="140013"/>
-              </a:lnSpc>
-              <a:buClr>
-                <a:srgbClr val="12312B"/>
-              </a:buClr>
-              <a:buSzPts val="3009"/>
-              <a:buFont typeface="Archivo Medium"/>
-              <a:buChar char="•"/>
-            </a:pPr>
-            <a:endParaRPr lang="en-US" sz="2006" kern="0" dirty="0">
-              <a:solidFill>
-                <a:srgbClr val="12312B"/>
-              </a:solidFill>
-              <a:latin typeface="Archivo Medium"/>
-              <a:ea typeface="Arial"/>
-              <a:cs typeface="Arial"/>
-              <a:sym typeface="Archivo Medium"/>
-            </a:endParaRPr>
-          </a:p>
-          <a:p>
-            <a:pPr marL="433260" lvl="1" indent="-216630" defTabSz="609630">
-              <a:lnSpc>
-                <a:spcPct val="140013"/>
-              </a:lnSpc>
-              <a:buClr>
-                <a:srgbClr val="12312B"/>
-              </a:buClr>
-              <a:buSzPts val="3009"/>
-              <a:buFont typeface="Archivo Medium"/>
-              <a:buChar char="•"/>
-            </a:pPr>
-            <a:r>
-              <a:rPr lang="en-US" sz="2006" kern="0" dirty="0">
-                <a:solidFill>
-                  <a:srgbClr val="12312B"/>
-                </a:solidFill>
-                <a:latin typeface="Archivo Medium"/>
-                <a:ea typeface="Arial"/>
-                <a:cs typeface="Arial"/>
-                <a:sym typeface="Archivo Medium"/>
-              </a:rPr>
-              <a:t>Learn how functions work and how to access their documentation</a:t>
-            </a:r>
-            <a:endParaRPr lang="en-US" sz="2000" dirty="0">
-              <a:solidFill>
-                <a:srgbClr val="12312B"/>
-              </a:solidFill>
-              <a:latin typeface="Arial"/>
-              <a:ea typeface="Arial"/>
-              <a:cs typeface="Arial"/>
-              <a:sym typeface="Arial"/>
-            </a:endParaRPr>
           </a:p>
           <a:p>
             <a:pPr marL="433260" lvl="1" indent="-216630" defTabSz="609630">

</xml_diff>